<commit_message>
Add GitHub repo link to PDF report header/footer and PPTX slides
</commit_message>
<xml_diff>
--- a/Cybersecurity_Major_Project.pptx
+++ b/Cybersecurity_Major_Project.pptx
@@ -3146,6 +3146,11 @@
               <a:t>By: Group of 7 Members</a:t>
             </a:r>
           </a:p>
+          <a:p>
+            <a:r>
+              <a:t>Repository: https://github.com/AzDevops143/CSIEEE</a:t>
+            </a:r>
+          </a:p>
         </p:txBody>
       </p:sp>
     </p:spTree>
@@ -3917,6 +3922,12 @@
             <a:pPr lvl="1"/>
             <a:r>
               <a:t>As proven in our simulation, the attacker infers the exact word when unprotected, but infers useless gibberish when CASOM is active.</a:t>
+            </a:r>
+          </a:p>
+          <a:p>
+            <a:pPr lvl="1"/>
+            <a:r>
+              <a:t>Project Repository: https://github.com/AzDevops143/CSIEEE</a:t>
             </a:r>
           </a:p>
         </p:txBody>

</xml_diff>

<commit_message>
Update academic markdown files, generate presentation slides, and add interactive Demo.html
</commit_message>
<xml_diff>
--- a/Cybersecurity_Major_Project.pptx
+++ b/Cybersecurity_Major_Project.pptx
@@ -14,8 +14,9 @@
     <p:sldId id="262" r:id="rId13"/>
     <p:sldId id="263" r:id="rId14"/>
     <p:sldId id="264" r:id="rId15"/>
+    <p:sldId id="265" r:id="rId16"/>
   </p:sldIdLst>
-  <p:sldSz cx="9144000" cy="6858000" type="screen4x3"/>
+  <p:sldSz cx="9144000" cy="5143500" type="screen4x3"/>
   <p:notesSz cx="6858000" cy="9144000"/>
   <p:defaultTextStyle>
     <a:defPPr>
@@ -3089,6 +3090,14 @@
 <file path=ppt/slides/slide1.xml><?xml version="1.0" encoding="utf-8"?>
 <p:sld xmlns:a="http://schemas.openxmlformats.org/drawingml/2006/main" xmlns:p="http://schemas.openxmlformats.org/presentationml/2006/main" xmlns:r="http://schemas.openxmlformats.org/officeDocument/2006/relationships">
   <p:cSld>
+    <p:bg>
+      <p:bgPr>
+        <a:solidFill>
+          <a:srgbClr val="0F172A"/>
+        </a:solidFill>
+        <a:effectLst/>
+      </p:bgPr>
+    </p:bg>
     <p:spTree>
       <p:nvGrpSpPr>
         <p:cNvPr id="1" name=""/>
@@ -3098,57 +3107,261 @@
       <p:grpSpPr/>
       <p:sp>
         <p:nvSpPr>
-          <p:cNvPr id="2" name="Title 1"/>
-          <p:cNvSpPr>
-            <a:spLocks noGrp="1"/>
-          </p:cNvSpPr>
-          <p:nvPr>
-            <p:ph type="ctrTitle"/>
-          </p:nvPr>
-        </p:nvSpPr>
-        <p:spPr/>
-        <p:txBody>
-          <a:bodyPr/>
-          <a:lstStyle/>
-          <a:p>
-            <a:r>
-              <a:t>CSL6010-Cybersecurity Major Project:</a:t>
-            </a:r>
-          </a:p>
-          <a:p>
-            <a:r>
-              <a:t>Eyes on Your Typing &amp; CASOM Defense</a:t>
-            </a:r>
-          </a:p>
-        </p:txBody>
-      </p:sp>
-      <p:sp>
-        <p:nvSpPr>
-          <p:cNvPr id="3" name="Subtitle 2"/>
-          <p:cNvSpPr>
-            <a:spLocks noGrp="1"/>
-          </p:cNvSpPr>
-          <p:nvPr>
-            <p:ph type="subTitle" idx="1"/>
-          </p:nvPr>
-        </p:nvSpPr>
-        <p:spPr/>
-        <p:txBody>
-          <a:bodyPr/>
-          <a:lstStyle/>
-          <a:p>
-            <a:r>
-              <a:t>Analysis of SNOOPFINGER Attack and Proposed Middleware</a:t>
-            </a:r>
-          </a:p>
-          <a:p>
-            <a:r>
-              <a:t>By: Group of 7 Members</a:t>
-            </a:r>
-          </a:p>
-          <a:p>
+          <p:cNvPr id="2" name="TextBox 1"/>
+          <p:cNvSpPr txBox="1"/>
+          <p:nvPr/>
+        </p:nvSpPr>
+        <p:spPr>
+          <a:xfrm>
+            <a:off x="731520" y="1371600"/>
+            <a:ext cx="7680960" cy="2286000"/>
+          </a:xfrm>
+          <a:prstGeom prst="rect">
+            <a:avLst/>
+          </a:prstGeom>
+          <a:noFill/>
+        </p:spPr>
+        <p:txBody>
+          <a:bodyPr wrap="square" tIns="91440" bIns="91440">
+            <a:spAutoFit/>
+          </a:bodyPr>
+          <a:lstStyle/>
+          <a:p>
+            <a:pPr algn="l">
+              <a:spcAft>
+                <a:spcPts val="2000"/>
+              </a:spcAft>
+              <a:defRPr sz="3600" b="1">
+                <a:solidFill>
+                  <a:srgbClr val="F8FAFC"/>
+                </a:solidFill>
+                <a:latin typeface="Calibri"/>
+              </a:defRPr>
+            </a:pPr>
+            <a:r>
+              <a:t>Side-Channel Keystroke Leakage and Context-Aware Defense in AR/VR Environments</a:t>
+            </a:r>
+          </a:p>
+          <a:p>
+            <a:pPr algn="l">
+              <a:spcAft>
+                <a:spcPts val="4000"/>
+              </a:spcAft>
+              <a:defRPr sz="1800">
+                <a:solidFill>
+                  <a:srgbClr val="38BDF8"/>
+                </a:solidFill>
+                <a:latin typeface="Calibri"/>
+              </a:defRPr>
+            </a:pPr>
+            <a:r>
+              <a:t>Analysis of the SNOOPFINGER Attack and the CASOM Defense Framework</a:t>
+            </a:r>
+          </a:p>
+          <a:p>
+            <a:pPr algn="l">
+              <a:defRPr sz="1300">
+                <a:solidFill>
+                  <a:srgbClr val="94A3B8"/>
+                </a:solidFill>
+                <a:latin typeface="Calibri"/>
+              </a:defRPr>
+            </a:pPr>
+            <a:r>
+              <a:t>CSL6010-Cybersecurity Major Project Submission</a:t>
+            </a:r>
+            <a:br/>
+            <a:r>
+              <a:t>Prepared by: Graduate Student Analysis Team</a:t>
+            </a:r>
+            <a:br/>
             <a:r>
               <a:t>Repository: https://github.com/AzDevops143/CSIEEE</a:t>
+            </a:r>
+          </a:p>
+        </p:txBody>
+      </p:sp>
+    </p:spTree>
+  </p:cSld>
+  <p:clrMapOvr>
+    <a:masterClrMapping/>
+  </p:clrMapOvr>
+</p:sld>
+</file>
+
+<file path=ppt/slides/slide10.xml><?xml version="1.0" encoding="utf-8"?>
+<p:sld xmlns:a="http://schemas.openxmlformats.org/drawingml/2006/main" xmlns:p="http://schemas.openxmlformats.org/presentationml/2006/main" xmlns:r="http://schemas.openxmlformats.org/officeDocument/2006/relationships">
+  <p:cSld>
+    <p:bg>
+      <p:bgPr>
+        <a:solidFill>
+          <a:srgbClr val="0F172A"/>
+        </a:solidFill>
+        <a:effectLst/>
+      </p:bgPr>
+    </p:bg>
+    <p:spTree>
+      <p:nvGrpSpPr>
+        <p:cNvPr id="1" name=""/>
+        <p:cNvGrpSpPr/>
+        <p:nvPr/>
+      </p:nvGrpSpPr>
+      <p:grpSpPr/>
+      <p:sp>
+        <p:nvSpPr>
+          <p:cNvPr id="2" name="TextBox 1"/>
+          <p:cNvSpPr txBox="1"/>
+          <p:nvPr/>
+        </p:nvSpPr>
+        <p:spPr>
+          <a:xfrm>
+            <a:off x="548640" y="365760"/>
+            <a:ext cx="8046720" cy="731520"/>
+          </a:xfrm>
+          <a:prstGeom prst="rect">
+            <a:avLst/>
+          </a:prstGeom>
+          <a:noFill/>
+        </p:spPr>
+        <p:txBody>
+          <a:bodyPr wrap="square" tIns="91440" bIns="91440">
+            <a:spAutoFit/>
+          </a:bodyPr>
+          <a:lstStyle/>
+          <a:p>
+            <a:pPr>
+              <a:defRPr sz="2800" b="1">
+                <a:solidFill>
+                  <a:srgbClr val="38BDF8"/>
+                </a:solidFill>
+                <a:latin typeface="Calibri"/>
+              </a:defRPr>
+            </a:pPr>
+            <a:r>
+              <a:t>Conclusion &amp; Core Contributions</a:t>
+            </a:r>
+          </a:p>
+        </p:txBody>
+      </p:sp>
+      <p:sp>
+        <p:nvSpPr>
+          <p:cNvPr id="3" name="TextBox 2"/>
+          <p:cNvSpPr txBox="1"/>
+          <p:nvPr/>
+        </p:nvSpPr>
+        <p:spPr>
+          <a:xfrm>
+            <a:off x="548640" y="1280160"/>
+            <a:ext cx="8046720" cy="3474720"/>
+          </a:xfrm>
+          <a:prstGeom prst="rect">
+            <a:avLst/>
+          </a:prstGeom>
+          <a:noFill/>
+        </p:spPr>
+        <p:txBody>
+          <a:bodyPr wrap="square" tIns="91440" bIns="91440">
+            <a:spAutoFit/>
+          </a:bodyPr>
+          <a:lstStyle/>
+          <a:p>
+            <a:pPr>
+              <a:spcAft>
+                <a:spcPts val="1000"/>
+              </a:spcAft>
+            </a:pPr>
+            <a:r>
+              <a:rPr sz="1800" b="1">
+                <a:solidFill>
+                  <a:srgbClr val="F8FAFC"/>
+                </a:solidFill>
+                <a:latin typeface="Calibri"/>
+              </a:rPr>
+              <a:t>Side-Channel Vulnerability: </a:t>
+            </a:r>
+            <a:r>
+              <a:rPr sz="1800" b="0">
+                <a:solidFill>
+                  <a:srgbClr val="F8FAFC"/>
+                </a:solidFill>
+                <a:latin typeface="Calibri"/>
+              </a:rPr>
+              <a:t>Proved that zero-permission head sensors leak text, posing a severe side-channel danger in virtual environments.</a:t>
+            </a:r>
+          </a:p>
+          <a:p>
+            <a:pPr>
+              <a:spcAft>
+                <a:spcPts val="1000"/>
+              </a:spcAft>
+            </a:pPr>
+            <a:r>
+              <a:rPr sz="1800" b="1">
+                <a:solidFill>
+                  <a:srgbClr val="F8FAFC"/>
+                </a:solidFill>
+                <a:latin typeface="Calibri"/>
+              </a:rPr>
+              <a:t>CASOM Framework: </a:t>
+            </a:r>
+            <a:r>
+              <a:rPr sz="1800" b="0">
+                <a:solidFill>
+                  <a:srgbClr val="F8FAFC"/>
+                </a:solidFill>
+                <a:latin typeface="Calibri"/>
+              </a:rPr>
+              <a:t>Implemented and evaluated the Context-Aware Sensor Obfuscation Middleware (CASOM) inside a Python simulation environment.</a:t>
+            </a:r>
+          </a:p>
+          <a:p>
+            <a:pPr>
+              <a:spcAft>
+                <a:spcPts val="1000"/>
+              </a:spcAft>
+            </a:pPr>
+            <a:r>
+              <a:rPr sz="1800" b="1">
+                <a:solidFill>
+                  <a:srgbClr val="F8FAFC"/>
+                </a:solidFill>
+                <a:latin typeface="Calibri"/>
+              </a:rPr>
+              <a:t>Evaluation Honesty: </a:t>
+            </a:r>
+            <a:r>
+              <a:rPr sz="1800" b="0">
+                <a:solidFill>
+                  <a:srgbClr val="F8FAFC"/>
+                </a:solidFill>
+                <a:latin typeface="Calibri"/>
+              </a:rPr>
+              <a:t>Disproved simple countermeasures (IID Noise and Drift) by evaluating them against the real BackTree attack.</a:t>
+            </a:r>
+          </a:p>
+          <a:p>
+            <a:pPr>
+              <a:spcAft>
+                <a:spcPts val="1000"/>
+              </a:spcAft>
+            </a:pPr>
+            <a:r>
+              <a:rPr sz="1800" b="1">
+                <a:solidFill>
+                  <a:srgbClr val="10B981"/>
+                </a:solidFill>
+                <a:latin typeface="Calibri"/>
+              </a:rPr>
+              <a:t>Recommended Defense: </a:t>
+            </a:r>
+            <a:r>
+              <a:rPr sz="1800" b="0">
+                <a:solidFill>
+                  <a:srgbClr val="10B981"/>
+                </a:solidFill>
+                <a:latin typeface="Calibri"/>
+              </a:rPr>
+              <a:t>Validated Block Offset Laplace Noise as a robust, highly secure, and deployable countermeasure that collapses attack success to ~3.6% while preserving 100% foreground user experience.</a:t>
             </a:r>
           </a:p>
         </p:txBody>
@@ -3164,6 +3377,14 @@
 <file path=ppt/slides/slide2.xml><?xml version="1.0" encoding="utf-8"?>
 <p:sld xmlns:a="http://schemas.openxmlformats.org/drawingml/2006/main" xmlns:p="http://schemas.openxmlformats.org/presentationml/2006/main" xmlns:r="http://schemas.openxmlformats.org/officeDocument/2006/relationships">
   <p:cSld>
+    <p:bg>
+      <p:bgPr>
+        <a:solidFill>
+          <a:srgbClr val="0F172A"/>
+        </a:solidFill>
+        <a:effectLst/>
+      </p:bgPr>
+    </p:bg>
     <p:spTree>
       <p:nvGrpSpPr>
         <p:cNvPr id="1" name=""/>
@@ -3173,60 +3394,184 @@
       <p:grpSpPr/>
       <p:sp>
         <p:nvSpPr>
-          <p:cNvPr id="2" name="Title 1"/>
-          <p:cNvSpPr>
-            <a:spLocks noGrp="1"/>
-          </p:cNvSpPr>
-          <p:nvPr>
-            <p:ph type="title"/>
-          </p:nvPr>
-        </p:nvSpPr>
-        <p:spPr/>
-        <p:txBody>
-          <a:bodyPr/>
-          <a:lstStyle/>
-          <a:p>
-            <a:r>
-              <a:t>Introduction: SNOOPFINGER Attack</a:t>
-            </a:r>
-          </a:p>
-        </p:txBody>
-      </p:sp>
-      <p:sp>
-        <p:nvSpPr>
-          <p:cNvPr id="3" name="Content Placeholder 2"/>
-          <p:cNvSpPr>
-            <a:spLocks noGrp="1"/>
-          </p:cNvSpPr>
-          <p:nvPr>
-            <p:ph idx="1"/>
-          </p:nvPr>
-        </p:nvSpPr>
-        <p:spPr/>
-        <p:txBody>
-          <a:bodyPr/>
-          <a:lstStyle/>
-          <a:p>
-            <a:r>
-              <a:t>What is SNOOPFINGER?</a:t>
-            </a:r>
-          </a:p>
-          <a:p>
-            <a:pPr lvl="1"/>
-            <a:r>
-              <a:t>A novel cross-modality side-channel attack in AR/VR systems.</a:t>
-            </a:r>
-          </a:p>
-          <a:p>
-            <a:pPr lvl="1"/>
-            <a:r>
-              <a:t>Exploits head movement data (which requires zero permissions) to infer hand-based typing on virtual keyboards.</a:t>
-            </a:r>
-          </a:p>
-          <a:p>
-            <a:pPr lvl="1"/>
-            <a:r>
-              <a:t>Adversaries can deduce typed words by translating 3D head orientation into 2D gaze points.</a:t>
+          <p:cNvPr id="2" name="TextBox 1"/>
+          <p:cNvSpPr txBox="1"/>
+          <p:nvPr/>
+        </p:nvSpPr>
+        <p:spPr>
+          <a:xfrm>
+            <a:off x="548640" y="365760"/>
+            <a:ext cx="8046720" cy="731520"/>
+          </a:xfrm>
+          <a:prstGeom prst="rect">
+            <a:avLst/>
+          </a:prstGeom>
+          <a:noFill/>
+        </p:spPr>
+        <p:txBody>
+          <a:bodyPr wrap="square" tIns="91440" bIns="91440">
+            <a:spAutoFit/>
+          </a:bodyPr>
+          <a:lstStyle/>
+          <a:p>
+            <a:pPr>
+              <a:defRPr sz="2800" b="1">
+                <a:solidFill>
+                  <a:srgbClr val="38BDF8"/>
+                </a:solidFill>
+                <a:latin typeface="Calibri"/>
+              </a:defRPr>
+            </a:pPr>
+            <a:r>
+              <a:t>The Side-Channel Threat: SNOOPFINGER</a:t>
+            </a:r>
+          </a:p>
+        </p:txBody>
+      </p:sp>
+      <p:sp>
+        <p:nvSpPr>
+          <p:cNvPr id="3" name="TextBox 2"/>
+          <p:cNvSpPr txBox="1"/>
+          <p:nvPr/>
+        </p:nvSpPr>
+        <p:spPr>
+          <a:xfrm>
+            <a:off x="548640" y="1280160"/>
+            <a:ext cx="8046720" cy="3474720"/>
+          </a:xfrm>
+          <a:prstGeom prst="rect">
+            <a:avLst/>
+          </a:prstGeom>
+          <a:noFill/>
+        </p:spPr>
+        <p:txBody>
+          <a:bodyPr wrap="square" tIns="91440" bIns="91440">
+            <a:spAutoFit/>
+          </a:bodyPr>
+          <a:lstStyle/>
+          <a:p>
+            <a:pPr>
+              <a:spcAft>
+                <a:spcPts val="1000"/>
+              </a:spcAft>
+            </a:pPr>
+            <a:r>
+              <a:rPr sz="1800" b="1">
+                <a:solidFill>
+                  <a:srgbClr val="F8FAFC"/>
+                </a:solidFill>
+                <a:latin typeface="Calibri"/>
+              </a:rPr>
+              <a:t>Attack Definition: </a:t>
+            </a:r>
+            <a:r>
+              <a:rPr sz="1800" b="0">
+                <a:solidFill>
+                  <a:srgbClr val="F8FAFC"/>
+                </a:solidFill>
+                <a:latin typeface="Calibri"/>
+              </a:rPr>
+              <a:t>SNOOPFINGER is a cross-modality side-channel attack targeting head-mounted displays in VR/AR environments.</a:t>
+            </a:r>
+          </a:p>
+          <a:p>
+            <a:pPr>
+              <a:spcAft>
+                <a:spcPts val="1000"/>
+              </a:spcAft>
+            </a:pPr>
+            <a:r>
+              <a:rPr sz="1800" b="1">
+                <a:solidFill>
+                  <a:srgbClr val="F8FAFC"/>
+                </a:solidFill>
+                <a:latin typeface="Calibri"/>
+              </a:rPr>
+              <a:t>Vulnerability Surface: </a:t>
+            </a:r>
+            <a:r>
+              <a:rPr sz="1800" b="0">
+                <a:solidFill>
+                  <a:srgbClr val="F8FAFC"/>
+                </a:solidFill>
+                <a:latin typeface="Calibri"/>
+              </a:rPr>
+              <a:t>APIs treat head-movement orientation (quaternions) as zero-permission sensors, broadcasting it to all background threads.</a:t>
+            </a:r>
+          </a:p>
+          <a:p>
+            <a:pPr>
+              <a:spcAft>
+                <a:spcPts val="1000"/>
+              </a:spcAft>
+            </a:pPr>
+            <a:r>
+              <a:rPr sz="1800" b="1">
+                <a:solidFill>
+                  <a:srgbClr val="F8FAFC"/>
+                </a:solidFill>
+                <a:latin typeface="Calibri"/>
+              </a:rPr>
+              <a:t>Exploitation Vector: </a:t>
+            </a:r>
+            <a:r>
+              <a:rPr sz="1800" b="0">
+                <a:solidFill>
+                  <a:srgbClr val="F8FAFC"/>
+                </a:solidFill>
+                <a:latin typeface="Calibri"/>
+              </a:rPr>
+              <a:t>When users type on virtual keyboards, they make natural micro-pauses (dwell times) to visually target and confirm keys.</a:t>
+            </a:r>
+          </a:p>
+          <a:p>
+            <a:pPr>
+              <a:spcAft>
+                <a:spcPts val="1000"/>
+              </a:spcAft>
+            </a:pPr>
+            <a:r>
+              <a:rPr sz="1800" b="1">
+                <a:solidFill>
+                  <a:srgbClr val="F8FAFC"/>
+                </a:solidFill>
+                <a:latin typeface="Calibri"/>
+              </a:rPr>
+              <a:t>Mechanism: </a:t>
+            </a:r>
+            <a:r>
+              <a:rPr sz="1800" b="0">
+                <a:solidFill>
+                  <a:srgbClr val="F8FAFC"/>
+                </a:solidFill>
+                <a:latin typeface="Calibri"/>
+              </a:rPr>
+              <a:t>Background processes reconstruct typed text by converting 3D head rotation into 2D gaze points and clustering them temporally.</a:t>
+            </a:r>
+          </a:p>
+          <a:p>
+            <a:pPr>
+              <a:spcAft>
+                <a:spcPts val="1000"/>
+              </a:spcAft>
+            </a:pPr>
+            <a:r>
+              <a:rPr sz="1800" b="1">
+                <a:solidFill>
+                  <a:srgbClr val="F43F5E"/>
+                </a:solidFill>
+                <a:latin typeface="Calibri"/>
+              </a:rPr>
+              <a:t>Impact: </a:t>
+            </a:r>
+            <a:r>
+              <a:rPr sz="1800" b="0">
+                <a:solidFill>
+                  <a:srgbClr val="F43F5E"/>
+                </a:solidFill>
+                <a:latin typeface="Calibri"/>
+              </a:rPr>
+              <a:t>Requires no camera access or high privileges, allowing standard apps to steal passwords and pins.</a:t>
             </a:r>
           </a:p>
         </p:txBody>
@@ -3242,6 +3587,14 @@
 <file path=ppt/slides/slide3.xml><?xml version="1.0" encoding="utf-8"?>
 <p:sld xmlns:a="http://schemas.openxmlformats.org/drawingml/2006/main" xmlns:p="http://schemas.openxmlformats.org/presentationml/2006/main" xmlns:r="http://schemas.openxmlformats.org/officeDocument/2006/relationships">
   <p:cSld>
+    <p:bg>
+      <p:bgPr>
+        <a:solidFill>
+          <a:srgbClr val="0F172A"/>
+        </a:solidFill>
+        <a:effectLst/>
+      </p:bgPr>
+    </p:bg>
     <p:spTree>
       <p:nvGrpSpPr>
         <p:cNvPr id="1" name=""/>
@@ -3251,28 +3604,157 @@
       <p:grpSpPr/>
       <p:sp>
         <p:nvSpPr>
-          <p:cNvPr id="2" name="Title 1"/>
-          <p:cNvSpPr>
-            <a:spLocks noGrp="1"/>
-          </p:cNvSpPr>
-          <p:nvPr>
-            <p:ph type="title"/>
-          </p:nvPr>
-        </p:nvSpPr>
-        <p:spPr/>
-        <p:txBody>
-          <a:bodyPr/>
-          <a:lstStyle/>
-          <a:p>
-            <a:r>
-              <a:t>Understanding the Attack: Mathematical Background</a:t>
+          <p:cNvPr id="2" name="TextBox 1"/>
+          <p:cNvSpPr txBox="1"/>
+          <p:nvPr/>
+        </p:nvSpPr>
+        <p:spPr>
+          <a:xfrm>
+            <a:off x="548640" y="365760"/>
+            <a:ext cx="8046720" cy="731520"/>
+          </a:xfrm>
+          <a:prstGeom prst="rect">
+            <a:avLst/>
+          </a:prstGeom>
+          <a:noFill/>
+        </p:spPr>
+        <p:txBody>
+          <a:bodyPr wrap="square" tIns="91440" bIns="91440">
+            <a:spAutoFit/>
+          </a:bodyPr>
+          <a:lstStyle/>
+          <a:p>
+            <a:pPr>
+              <a:defRPr sz="2800" b="1">
+                <a:solidFill>
+                  <a:srgbClr val="38BDF8"/>
+                </a:solidFill>
+                <a:latin typeface="Calibri"/>
+              </a:defRPr>
+            </a:pPr>
+            <a:r>
+              <a:t>Mathematical Modeling: 3D to 2D Gaze Projection</a:t>
+            </a:r>
+          </a:p>
+        </p:txBody>
+      </p:sp>
+      <p:sp>
+        <p:nvSpPr>
+          <p:cNvPr id="3" name="TextBox 2"/>
+          <p:cNvSpPr txBox="1"/>
+          <p:nvPr/>
+        </p:nvSpPr>
+        <p:spPr>
+          <a:xfrm>
+            <a:off x="548640" y="1188720"/>
+            <a:ext cx="4114800" cy="3566160"/>
+          </a:xfrm>
+          <a:prstGeom prst="rect">
+            <a:avLst/>
+          </a:prstGeom>
+          <a:noFill/>
+        </p:spPr>
+        <p:txBody>
+          <a:bodyPr wrap="square" tIns="91440" bIns="91440">
+            <a:spAutoFit/>
+          </a:bodyPr>
+          <a:lstStyle/>
+          <a:p>
+            <a:pPr>
+              <a:spcAft>
+                <a:spcPts val="1000"/>
+              </a:spcAft>
+            </a:pPr>
+            <a:r>
+              <a:rPr sz="1600" b="1">
+                <a:solidFill>
+                  <a:srgbClr val="F8FAFC"/>
+                </a:solidFill>
+                <a:latin typeface="Calibri"/>
+              </a:rPr>
+              <a:t>Coordinate Conversion: </a:t>
+            </a:r>
+            <a:r>
+              <a:rPr sz="1600" b="0">
+                <a:solidFill>
+                  <a:srgbClr val="F8FAFC"/>
+                </a:solidFill>
+                <a:latin typeface="Calibri"/>
+              </a:rPr>
+              <a:t>Converts raw headset orientation tracking (w, x, y, z) into Euler angles (Pitch and Yaw) to estimate looking directions.</a:t>
+            </a:r>
+          </a:p>
+          <a:p>
+            <a:pPr>
+              <a:spcAft>
+                <a:spcPts val="1000"/>
+              </a:spcAft>
+            </a:pPr>
+            <a:r>
+              <a:rPr sz="1600" b="1">
+                <a:solidFill>
+                  <a:srgbClr val="F8FAFC"/>
+                </a:solidFill>
+                <a:latin typeface="Calibri"/>
+              </a:rPr>
+              <a:t>2D Projection: </a:t>
+            </a:r>
+            <a:r>
+              <a:rPr sz="1600" b="0">
+                <a:solidFill>
+                  <a:srgbClr val="F8FAFC"/>
+                </a:solidFill>
+                <a:latin typeface="Calibri"/>
+              </a:rPr>
+              <a:t>Maps the 3D gaze vector onto the 2D plane of the virtual keyboard via an equirectangular coordinate projection.</a:t>
+            </a:r>
+          </a:p>
+          <a:p>
+            <a:pPr>
+              <a:spcAft>
+                <a:spcPts val="1000"/>
+              </a:spcAft>
+            </a:pPr>
+            <a:r>
+              <a:rPr sz="1600" b="1">
+                <a:solidFill>
+                  <a:srgbClr val="F8FAFC"/>
+                </a:solidFill>
+                <a:latin typeface="Calibri"/>
+              </a:rPr>
+              <a:t>Tremor Simulation: </a:t>
+            </a:r>
+            <a:r>
+              <a:rPr sz="1600" b="0">
+                <a:solidFill>
+                  <a:srgbClr val="F8FAFC"/>
+                </a:solidFill>
+                <a:latin typeface="Calibri"/>
+              </a:rPr>
+              <a:t>Models natural gaze jitter using Gaussian distribution centered at key targets:</a:t>
+            </a:r>
+          </a:p>
+          <a:p>
+            <a:pPr lvl="1">
+              <a:spcAft>
+                <a:spcPts val="1000"/>
+              </a:spcAft>
+            </a:pPr>
+            <a:r>
+              <a:rPr sz="1500" b="0">
+                <a:solidFill>
+                  <a:srgbClr val="F8FAFC"/>
+                </a:solidFill>
+                <a:latin typeface="Calibri"/>
+              </a:rPr>
+              <a:t>x ~ N(x_key, sigma^2), where sigma = 0.03 cm represents human target tremor.</a:t>
             </a:r>
           </a:p>
         </p:txBody>
       </p:sp>
       <p:pic>
         <p:nvPicPr>
-          <p:cNvPr id="3" name="Picture 2" descr="eq1.png"/>
+          <p:cNvPr id="4" name="Picture 3" descr="math_pitch.png"/>
           <p:cNvPicPr>
             <a:picLocks noChangeAspect="1"/>
           </p:cNvPicPr>
@@ -3286,8 +3768,8 @@
         </p:blipFill>
         <p:spPr>
           <a:xfrm>
-            <a:off x="914400" y="1828800"/>
-            <a:ext cx="2743200" cy="806335"/>
+            <a:off x="4846320" y="1645920"/>
+            <a:ext cx="3749039" cy="868334"/>
           </a:xfrm>
           <a:prstGeom prst="rect">
             <a:avLst/>
@@ -3296,7 +3778,7 @@
       </p:pic>
       <p:pic>
         <p:nvPicPr>
-          <p:cNvPr id="4" name="Picture 3" descr="eq2.png"/>
+          <p:cNvPr id="5" name="Picture 4" descr="math_yaw.png"/>
           <p:cNvPicPr>
             <a:picLocks noChangeAspect="1"/>
           </p:cNvPicPr>
@@ -3310,538 +3792,8 @@
         </p:blipFill>
         <p:spPr>
           <a:xfrm>
-            <a:off x="914400" y="3200400"/>
-            <a:ext cx="2743200" cy="806335"/>
-          </a:xfrm>
-          <a:prstGeom prst="rect">
-            <a:avLst/>
-          </a:prstGeom>
-        </p:spPr>
-      </p:pic>
-      <p:pic>
-        <p:nvPicPr>
-          <p:cNvPr id="5" name="Picture 4" descr="eq3.png"/>
-          <p:cNvPicPr>
-            <a:picLocks noChangeAspect="1"/>
-          </p:cNvPicPr>
-          <p:nvPr/>
-        </p:nvPicPr>
-        <p:blipFill>
-          <a:blip r:embed="rId4"/>
-          <a:stretch>
-            <a:fillRect/>
-          </a:stretch>
-        </p:blipFill>
-        <p:spPr>
-          <a:xfrm>
-            <a:off x="914400" y="4572000"/>
-            <a:ext cx="2743200" cy="806335"/>
-          </a:xfrm>
-          <a:prstGeom prst="rect">
-            <a:avLst/>
-          </a:prstGeom>
-        </p:spPr>
-      </p:pic>
-      <p:sp>
-        <p:nvSpPr>
-          <p:cNvPr id="6" name="TextBox 5"/>
-          <p:cNvSpPr txBox="1"/>
-          <p:nvPr/>
-        </p:nvSpPr>
-        <p:spPr>
-          <a:xfrm>
-            <a:off x="4572000" y="1828800"/>
-            <a:ext cx="3657600" cy="2743200"/>
-          </a:xfrm>
-          <a:prstGeom prst="rect">
-            <a:avLst/>
-          </a:prstGeom>
-          <a:noFill/>
-        </p:spPr>
-        <p:txBody>
-          <a:bodyPr wrap="none">
-            <a:spAutoFit/>
-          </a:bodyPr>
-          <a:lstStyle/>
-          <a:p>
-            <a:r>
-              <a:t>Conversion from Quaternions to Euler Angles</a:t>
-            </a:r>
-          </a:p>
-          <a:p>
-            <a:pPr lvl="1"/>
-            <a:r>
-              <a:t>The attack relies on converting the headset's quaternion orientation (w, x, y, z) into Euler angles (Roll, Pitch, Yaw) to estimate gaze direction.</a:t>
-            </a:r>
-          </a:p>
-        </p:txBody>
-      </p:sp>
-    </p:spTree>
-  </p:cSld>
-  <p:clrMapOvr>
-    <a:masterClrMapping/>
-  </p:clrMapOvr>
-</p:sld>
-</file>
-
-<file path=ppt/slides/slide4.xml><?xml version="1.0" encoding="utf-8"?>
-<p:sld xmlns:a="http://schemas.openxmlformats.org/drawingml/2006/main" xmlns:p="http://schemas.openxmlformats.org/presentationml/2006/main" xmlns:r="http://schemas.openxmlformats.org/officeDocument/2006/relationships">
-  <p:cSld>
-    <p:spTree>
-      <p:nvGrpSpPr>
-        <p:cNvPr id="1" name=""/>
-        <p:cNvGrpSpPr/>
-        <p:nvPr/>
-      </p:nvGrpSpPr>
-      <p:grpSpPr/>
-      <p:sp>
-        <p:nvSpPr>
-          <p:cNvPr id="2" name="Title 1"/>
-          <p:cNvSpPr>
-            <a:spLocks noGrp="1"/>
-          </p:cNvSpPr>
-          <p:nvPr>
-            <p:ph type="title"/>
-          </p:nvPr>
-        </p:nvSpPr>
-        <p:spPr/>
-        <p:txBody>
-          <a:bodyPr/>
-          <a:lstStyle/>
-          <a:p>
-            <a:r>
-              <a:t>3D Gaze Direction to 2D Points</a:t>
-            </a:r>
-          </a:p>
-        </p:txBody>
-      </p:sp>
-      <p:pic>
-        <p:nvPicPr>
-          <p:cNvPr id="3" name="Picture 2" descr="eq4.png"/>
-          <p:cNvPicPr>
-            <a:picLocks noChangeAspect="1"/>
-          </p:cNvPicPr>
-          <p:nvPr/>
-        </p:nvPicPr>
-        <p:blipFill>
-          <a:blip r:embed="rId2"/>
-          <a:stretch>
-            <a:fillRect/>
-          </a:stretch>
-        </p:blipFill>
-        <p:spPr>
-          <a:xfrm>
-            <a:off x="914400" y="1828800"/>
-            <a:ext cx="2743200" cy="806335"/>
-          </a:xfrm>
-          <a:prstGeom prst="rect">
-            <a:avLst/>
-          </a:prstGeom>
-        </p:spPr>
-      </p:pic>
-      <p:pic>
-        <p:nvPicPr>
-          <p:cNvPr id="4" name="Picture 3" descr="eq5.png"/>
-          <p:cNvPicPr>
-            <a:picLocks noChangeAspect="1"/>
-          </p:cNvPicPr>
-          <p:nvPr/>
-        </p:nvPicPr>
-        <p:blipFill>
-          <a:blip r:embed="rId3"/>
-          <a:stretch>
-            <a:fillRect/>
-          </a:stretch>
-        </p:blipFill>
-        <p:spPr>
-          <a:xfrm>
-            <a:off x="914400" y="3200400"/>
-            <a:ext cx="2743200" cy="806335"/>
-          </a:xfrm>
-          <a:prstGeom prst="rect">
-            <a:avLst/>
-          </a:prstGeom>
-        </p:spPr>
-      </p:pic>
-      <p:pic>
-        <p:nvPicPr>
-          <p:cNvPr id="5" name="Picture 4" descr="eq6.png"/>
-          <p:cNvPicPr>
-            <a:picLocks noChangeAspect="1"/>
-          </p:cNvPicPr>
-          <p:nvPr/>
-        </p:nvPicPr>
-        <p:blipFill>
-          <a:blip r:embed="rId4"/>
-          <a:stretch>
-            <a:fillRect/>
-          </a:stretch>
-        </p:blipFill>
-        <p:spPr>
-          <a:xfrm>
-            <a:off x="914400" y="4572000"/>
-            <a:ext cx="2743200" cy="806335"/>
-          </a:xfrm>
-          <a:prstGeom prst="rect">
-            <a:avLst/>
-          </a:prstGeom>
-        </p:spPr>
-      </p:pic>
-      <p:sp>
-        <p:nvSpPr>
-          <p:cNvPr id="6" name="TextBox 5"/>
-          <p:cNvSpPr txBox="1"/>
-          <p:nvPr/>
-        </p:nvSpPr>
-        <p:spPr>
-          <a:xfrm>
-            <a:off x="4572000" y="1828800"/>
-            <a:ext cx="3657600" cy="2743200"/>
-          </a:xfrm>
-          <a:prstGeom prst="rect">
-            <a:avLst/>
-          </a:prstGeom>
-          <a:noFill/>
-        </p:spPr>
-        <p:txBody>
-          <a:bodyPr wrap="none">
-            <a:spAutoFit/>
-          </a:bodyPr>
-          <a:lstStyle/>
-          <a:p>
-            <a:r>
-              <a:t>Equirectangular Projection</a:t>
-            </a:r>
-          </a:p>
-          <a:p>
-            <a:pPr lvl="1"/>
-            <a:r>
-              <a:t>3D gaze directions are mapped onto a 2D plane (the virtual keyboard) to estimate which keys the user is looking at while typing.</a:t>
-            </a:r>
-          </a:p>
-        </p:txBody>
-      </p:sp>
-    </p:spTree>
-  </p:cSld>
-  <p:clrMapOvr>
-    <a:masterClrMapping/>
-  </p:clrMapOvr>
-</p:sld>
-</file>
-
-<file path=ppt/slides/slide5.xml><?xml version="1.0" encoding="utf-8"?>
-<p:sld xmlns:a="http://schemas.openxmlformats.org/drawingml/2006/main" xmlns:p="http://schemas.openxmlformats.org/presentationml/2006/main" xmlns:r="http://schemas.openxmlformats.org/officeDocument/2006/relationships">
-  <p:cSld>
-    <p:spTree>
-      <p:nvGrpSpPr>
-        <p:cNvPr id="1" name=""/>
-        <p:cNvGrpSpPr/>
-        <p:nvPr/>
-      </p:nvGrpSpPr>
-      <p:grpSpPr/>
-      <p:sp>
-        <p:nvSpPr>
-          <p:cNvPr id="2" name="Title 1"/>
-          <p:cNvSpPr>
-            <a:spLocks noGrp="1"/>
-          </p:cNvSpPr>
-          <p:nvPr>
-            <p:ph type="title"/>
-          </p:nvPr>
-        </p:nvSpPr>
-        <p:spPr/>
-        <p:txBody>
-          <a:bodyPr/>
-          <a:lstStyle/>
-          <a:p>
-            <a:r>
-              <a:t>Identified Gaps &amp; Limitations</a:t>
-            </a:r>
-          </a:p>
-        </p:txBody>
-      </p:sp>
-      <p:sp>
-        <p:nvSpPr>
-          <p:cNvPr id="3" name="Content Placeholder 2"/>
-          <p:cNvSpPr>
-            <a:spLocks noGrp="1"/>
-          </p:cNvSpPr>
-          <p:nvPr>
-            <p:ph idx="1"/>
-          </p:nvPr>
-        </p:nvSpPr>
-        <p:spPr/>
-        <p:txBody>
-          <a:bodyPr/>
-          <a:lstStyle/>
-          <a:p>
-            <a:r>
-              <a:t>Limitations of the SNOOPFINGER Attack:</a:t>
-            </a:r>
-          </a:p>
-          <a:p>
-            <a:pPr lvl="1"/>
-            <a:r>
-              <a:t>Relies heavily on high-fidelity, high-frequency (72 Hz) sensor data.</a:t>
-            </a:r>
-          </a:p>
-          <a:p>
-            <a:pPr lvl="1"/>
-            <a:r>
-              <a:t>Requires the user to move their head rather than just their eyes.</a:t>
-            </a:r>
-          </a:p>
-          <a:p>
-            <a:pPr lvl="1"/>
-            <a:r>
-              <a:t>Gaps in Mitigation:</a:t>
-            </a:r>
-          </a:p>
-          <a:p>
-            <a:pPr lvl="2"/>
-            <a:r>
-              <a:t>The paper proposes theoretical countermeasures (e.g., Adaptive Sensor Data Obfuscation) but provides no practical implementation or architectural blueprint.</a:t>
-            </a:r>
-          </a:p>
-        </p:txBody>
-      </p:sp>
-    </p:spTree>
-  </p:cSld>
-  <p:clrMapOvr>
-    <a:masterClrMapping/>
-  </p:clrMapOvr>
-</p:sld>
-</file>
-
-<file path=ppt/slides/slide6.xml><?xml version="1.0" encoding="utf-8"?>
-<p:sld xmlns:a="http://schemas.openxmlformats.org/drawingml/2006/main" xmlns:p="http://schemas.openxmlformats.org/presentationml/2006/main" xmlns:r="http://schemas.openxmlformats.org/officeDocument/2006/relationships">
-  <p:cSld>
-    <p:spTree>
-      <p:nvGrpSpPr>
-        <p:cNvPr id="1" name=""/>
-        <p:cNvGrpSpPr/>
-        <p:nvPr/>
-      </p:nvGrpSpPr>
-      <p:grpSpPr/>
-      <p:sp>
-        <p:nvSpPr>
-          <p:cNvPr id="2" name="Title 1"/>
-          <p:cNvSpPr>
-            <a:spLocks noGrp="1"/>
-          </p:cNvSpPr>
-          <p:nvPr>
-            <p:ph type="title"/>
-          </p:nvPr>
-        </p:nvSpPr>
-        <p:spPr/>
-        <p:txBody>
-          <a:bodyPr/>
-          <a:lstStyle/>
-          <a:p>
-            <a:r>
-              <a:t>Our Solution: CASOM Middleware</a:t>
-            </a:r>
-          </a:p>
-        </p:txBody>
-      </p:sp>
-      <p:sp>
-        <p:nvSpPr>
-          <p:cNvPr id="3" name="Content Placeholder 2"/>
-          <p:cNvSpPr>
-            <a:spLocks noGrp="1"/>
-          </p:cNvSpPr>
-          <p:nvPr>
-            <p:ph idx="1"/>
-          </p:nvPr>
-        </p:nvSpPr>
-        <p:spPr/>
-        <p:txBody>
-          <a:bodyPr/>
-          <a:lstStyle/>
-          <a:p>
-            <a:r>
-              <a:t>Context-Aware Sensor Obfuscation Middleware (CASOM)</a:t>
-            </a:r>
-          </a:p>
-          <a:p>
-            <a:pPr lvl="1"/>
-            <a:r>
-              <a:t>Architecture:</a:t>
-            </a:r>
-          </a:p>
-          <a:p>
-            <a:pPr lvl="2"/>
-            <a:r>
-              <a:t>Sits between the AR/VR OS Sensor Manager and Background Apps.</a:t>
-            </a:r>
-          </a:p>
-          <a:p>
-            <a:pPr lvl="2"/>
-            <a:r>
-              <a:t>Monitors sensor data to detect when a user is typing (using movement thresholding).</a:t>
-            </a:r>
-          </a:p>
-          <a:p>
-            <a:pPr lvl="1"/>
-            <a:r>
-              <a:t>Operation:</a:t>
-            </a:r>
-          </a:p>
-          <a:p>
-            <a:pPr lvl="2"/>
-            <a:r>
-              <a:t>If typing is NOT detected, passes raw data.</a:t>
-            </a:r>
-          </a:p>
-          <a:p>
-            <a:pPr lvl="2"/>
-            <a:r>
-              <a:t>If typing IS detected, injects Laplacian Noise into the data sent to background applications.</a:t>
-            </a:r>
-          </a:p>
-        </p:txBody>
-      </p:sp>
-    </p:spTree>
-  </p:cSld>
-  <p:clrMapOvr>
-    <a:masterClrMapping/>
-  </p:clrMapOvr>
-</p:sld>
-</file>
-
-<file path=ppt/slides/slide7.xml><?xml version="1.0" encoding="utf-8"?>
-<p:sld xmlns:a="http://schemas.openxmlformats.org/drawingml/2006/main" xmlns:p="http://schemas.openxmlformats.org/presentationml/2006/main" xmlns:r="http://schemas.openxmlformats.org/officeDocument/2006/relationships">
-  <p:cSld>
-    <p:spTree>
-      <p:nvGrpSpPr>
-        <p:cNvPr id="1" name=""/>
-        <p:cNvGrpSpPr/>
-        <p:nvPr/>
-      </p:nvGrpSpPr>
-      <p:grpSpPr/>
-      <p:sp>
-        <p:nvSpPr>
-          <p:cNvPr id="2" name="Title 1"/>
-          <p:cNvSpPr>
-            <a:spLocks noGrp="1"/>
-          </p:cNvSpPr>
-          <p:nvPr>
-            <p:ph type="title"/>
-          </p:nvPr>
-        </p:nvSpPr>
-        <p:spPr/>
-        <p:txBody>
-          <a:bodyPr/>
-          <a:lstStyle/>
-          <a:p>
-            <a:r>
-              <a:t>Implementation details</a:t>
-            </a:r>
-          </a:p>
-        </p:txBody>
-      </p:sp>
-      <p:sp>
-        <p:nvSpPr>
-          <p:cNvPr id="3" name="Content Placeholder 2"/>
-          <p:cNvSpPr>
-            <a:spLocks noGrp="1"/>
-          </p:cNvSpPr>
-          <p:nvPr>
-            <p:ph idx="1"/>
-          </p:nvPr>
-        </p:nvSpPr>
-        <p:spPr/>
-        <p:txBody>
-          <a:bodyPr/>
-          <a:lstStyle/>
-          <a:p>
-            <a:r>
-              <a:t>We built a complete Python Simulation:</a:t>
-            </a:r>
-          </a:p>
-          <a:p>
-            <a:pPr lvl="1"/>
-            <a:r>
-              <a:t>generator.py: Simulates human gaze points targeting specific keys with natural micro-variances.</a:t>
-            </a:r>
-          </a:p>
-          <a:p>
-            <a:pPr lvl="1"/>
-            <a:r>
-              <a:t>attacker.py: Simulates SNOOPFINGER by clustering temporal gaze points to infer the typed word.</a:t>
-            </a:r>
-          </a:p>
-          <a:p>
-            <a:pPr lvl="1"/>
-            <a:r>
-              <a:t>defender.py: The CASOM Middleware that intercepts data and applies dynamic Laplacian noise (scale = 1.5).</a:t>
-            </a:r>
-          </a:p>
-          <a:p>
-            <a:pPr lvl="1"/>
-            <a:r>
-              <a:t>main.py: Orchestrates the attack both WITH and WITHOUT the defense, providing visualizations.</a:t>
-            </a:r>
-          </a:p>
-        </p:txBody>
-      </p:sp>
-    </p:spTree>
-  </p:cSld>
-  <p:clrMapOvr>
-    <a:masterClrMapping/>
-  </p:clrMapOvr>
-</p:sld>
-</file>
-
-<file path=ppt/slides/slide8.xml><?xml version="1.0" encoding="utf-8"?>
-<p:sld xmlns:a="http://schemas.openxmlformats.org/drawingml/2006/main" xmlns:p="http://schemas.openxmlformats.org/presentationml/2006/main" xmlns:r="http://schemas.openxmlformats.org/officeDocument/2006/relationships">
-  <p:cSld>
-    <p:spTree>
-      <p:nvGrpSpPr>
-        <p:cNvPr id="1" name=""/>
-        <p:cNvGrpSpPr/>
-        <p:nvPr/>
-      </p:nvGrpSpPr>
-      <p:grpSpPr/>
-      <p:sp>
-        <p:nvSpPr>
-          <p:cNvPr id="2" name="Title 1"/>
-          <p:cNvSpPr>
-            <a:spLocks noGrp="1"/>
-          </p:cNvSpPr>
-          <p:nvPr>
-            <p:ph type="title"/>
-          </p:nvPr>
-        </p:nvSpPr>
-        <p:spPr/>
-        <p:txBody>
-          <a:bodyPr/>
-          <a:lstStyle/>
-          <a:p>
-            <a:r>
-              <a:t>Results &amp; Validation</a:t>
-            </a:r>
-          </a:p>
-        </p:txBody>
-      </p:sp>
-      <p:pic>
-        <p:nvPicPr>
-          <p:cNvPr id="3" name="Picture 2" descr="simulation_result.png"/>
-          <p:cNvPicPr>
-            <a:picLocks noChangeAspect="1"/>
-          </p:cNvPicPr>
-          <p:nvPr/>
-        </p:nvPicPr>
-        <p:blipFill>
-          <a:blip r:embed="rId2"/>
-          <a:stretch>
-            <a:fillRect/>
-          </a:stretch>
-        </p:blipFill>
-        <p:spPr>
-          <a:xfrm>
-            <a:off x="457200" y="1371600"/>
-            <a:ext cx="8229600" cy="3526971"/>
+            <a:off x="4846320" y="2926080"/>
+            <a:ext cx="3749039" cy="868334"/>
           </a:xfrm>
           <a:prstGeom prst="rect">
             <a:avLst/>
@@ -3856,9 +3808,17 @@
 </p:sld>
 </file>
 
-<file path=ppt/slides/slide9.xml><?xml version="1.0" encoding="utf-8"?>
+<file path=ppt/slides/slide4.xml><?xml version="1.0" encoding="utf-8"?>
 <p:sld xmlns:a="http://schemas.openxmlformats.org/drawingml/2006/main" xmlns:p="http://schemas.openxmlformats.org/presentationml/2006/main" xmlns:r="http://schemas.openxmlformats.org/officeDocument/2006/relationships">
   <p:cSld>
+    <p:bg>
+      <p:bgPr>
+        <a:solidFill>
+          <a:srgbClr val="0F172A"/>
+        </a:solidFill>
+        <a:effectLst/>
+      </p:bgPr>
+    </p:bg>
     <p:spTree>
       <p:nvGrpSpPr>
         <p:cNvPr id="1" name=""/>
@@ -3868,70 +3828,1874 @@
       <p:grpSpPr/>
       <p:sp>
         <p:nvSpPr>
-          <p:cNvPr id="2" name="Title 1"/>
-          <p:cNvSpPr>
-            <a:spLocks noGrp="1"/>
-          </p:cNvSpPr>
-          <p:nvPr>
-            <p:ph type="title"/>
-          </p:nvPr>
-        </p:nvSpPr>
-        <p:spPr/>
-        <p:txBody>
-          <a:bodyPr/>
-          <a:lstStyle/>
-          <a:p>
-            <a:r>
-              <a:t>Conclusion</a:t>
-            </a:r>
-          </a:p>
-        </p:txBody>
-      </p:sp>
-      <p:sp>
-        <p:nvSpPr>
-          <p:cNvPr id="3" name="Content Placeholder 2"/>
-          <p:cNvSpPr>
-            <a:spLocks noGrp="1"/>
-          </p:cNvSpPr>
-          <p:nvPr>
-            <p:ph idx="1"/>
-          </p:nvPr>
-        </p:nvSpPr>
-        <p:spPr/>
-        <p:txBody>
-          <a:bodyPr/>
-          <a:lstStyle/>
-          <a:p>
-            <a:r>
-              <a:t>Summary</a:t>
-            </a:r>
-          </a:p>
-          <a:p>
-            <a:pPr lvl="1"/>
-            <a:r>
-              <a:t>SNOOPFINGER exploits zero-permission sensors, posing a major risk.</a:t>
-            </a:r>
-          </a:p>
-          <a:p>
-            <a:pPr lvl="1"/>
-            <a:r>
-              <a:t>Our CASOM implementation successfully defends against the attack by dynamically degrading data utility for background apps.</a:t>
-            </a:r>
-          </a:p>
-          <a:p>
-            <a:pPr lvl="1"/>
-            <a:r>
-              <a:t>As proven in our simulation, the attacker infers the exact word when unprotected, but infers useless gibberish when CASOM is active.</a:t>
-            </a:r>
-          </a:p>
-          <a:p>
-            <a:pPr lvl="1"/>
-            <a:r>
-              <a:t>Project Repository: https://github.com/AzDevops143/CSIEEE</a:t>
-            </a:r>
-          </a:p>
-        </p:txBody>
-      </p:sp>
+          <p:cNvPr id="2" name="TextBox 1"/>
+          <p:cNvSpPr txBox="1"/>
+          <p:nvPr/>
+        </p:nvSpPr>
+        <p:spPr>
+          <a:xfrm>
+            <a:off x="548640" y="365760"/>
+            <a:ext cx="8046720" cy="731520"/>
+          </a:xfrm>
+          <a:prstGeom prst="rect">
+            <a:avLst/>
+          </a:prstGeom>
+          <a:noFill/>
+        </p:spPr>
+        <p:txBody>
+          <a:bodyPr wrap="square" tIns="91440" bIns="91440">
+            <a:spAutoFit/>
+          </a:bodyPr>
+          <a:lstStyle/>
+          <a:p>
+            <a:pPr>
+              <a:defRPr sz="2800" b="1">
+                <a:solidFill>
+                  <a:srgbClr val="38BDF8"/>
+                </a:solidFill>
+                <a:latin typeface="Calibri"/>
+              </a:defRPr>
+            </a:pPr>
+            <a:r>
+              <a:t>Identified Gaps &amp; Defense Limitations</a:t>
+            </a:r>
+          </a:p>
+        </p:txBody>
+      </p:sp>
+      <p:sp>
+        <p:nvSpPr>
+          <p:cNvPr id="3" name="TextBox 2"/>
+          <p:cNvSpPr txBox="1"/>
+          <p:nvPr/>
+        </p:nvSpPr>
+        <p:spPr>
+          <a:xfrm>
+            <a:off x="548640" y="1280160"/>
+            <a:ext cx="8046720" cy="3474720"/>
+          </a:xfrm>
+          <a:prstGeom prst="rect">
+            <a:avLst/>
+          </a:prstGeom>
+          <a:noFill/>
+        </p:spPr>
+        <p:txBody>
+          <a:bodyPr wrap="square" tIns="91440" bIns="91440">
+            <a:spAutoFit/>
+          </a:bodyPr>
+          <a:lstStyle/>
+          <a:p>
+            <a:pPr>
+              <a:spcAft>
+                <a:spcPts val="1000"/>
+              </a:spcAft>
+            </a:pPr>
+            <a:r>
+              <a:rPr sz="1800" b="1">
+                <a:solidFill>
+                  <a:srgbClr val="F8FAFC"/>
+                </a:solidFill>
+                <a:latin typeface="Calibri"/>
+              </a:rPr>
+              <a:t>Abstract Proposal Gap: </a:t>
+            </a:r>
+            <a:r>
+              <a:rPr sz="1800" b="0">
+                <a:solidFill>
+                  <a:srgbClr val="F8FAFC"/>
+                </a:solidFill>
+                <a:latin typeface="Calibri"/>
+              </a:rPr>
+              <a:t>The SNOOPFINGER IEEE paper discusses countermeasures (e.g. Obfuscation) but provides no implementation code or API design.</a:t>
+            </a:r>
+          </a:p>
+          <a:p>
+            <a:pPr>
+              <a:spcAft>
+                <a:spcPts val="1000"/>
+              </a:spcAft>
+            </a:pPr>
+            <a:r>
+              <a:rPr sz="1800" b="1">
+                <a:solidFill>
+                  <a:srgbClr val="F8FAFC"/>
+                </a:solidFill>
+                <a:latin typeface="Calibri"/>
+              </a:rPr>
+              <a:t>Utility Degradation: </a:t>
+            </a:r>
+            <a:r>
+              <a:rPr sz="1800" b="0">
+                <a:solidFill>
+                  <a:srgbClr val="F8FAFC"/>
+                </a:solidFill>
+                <a:latin typeface="Calibri"/>
+              </a:rPr>
+              <a:t>Adding simple independent random noise per frame degrades coordinate utility for background games/apps without stopping attackers.</a:t>
+            </a:r>
+          </a:p>
+          <a:p>
+            <a:pPr>
+              <a:spcAft>
+                <a:spcPts val="1000"/>
+              </a:spcAft>
+            </a:pPr>
+            <a:r>
+              <a:rPr sz="1800" b="1">
+                <a:solidFill>
+                  <a:srgbClr val="F8FAFC"/>
+                </a:solidFill>
+                <a:latin typeface="Calibri"/>
+              </a:rPr>
+              <a:t>Evaluation Deficit: </a:t>
+            </a:r>
+            <a:r>
+              <a:rPr sz="1800" b="0">
+                <a:solidFill>
+                  <a:srgbClr val="F8FAFC"/>
+                </a:solidFill>
+                <a:latin typeface="Calibri"/>
+              </a:rPr>
+              <a:t>The paper assumes simple attackers. It does not evaluate defenses against adaptive adversaries or geometric attacks like BackTree.</a:t>
+            </a:r>
+          </a:p>
+          <a:p>
+            <a:pPr>
+              <a:spcAft>
+                <a:spcPts val="1000"/>
+              </a:spcAft>
+            </a:pPr>
+            <a:r>
+              <a:rPr sz="1800" b="1">
+                <a:solidFill>
+                  <a:srgbClr val="F43F5E"/>
+                </a:solidFill>
+                <a:latin typeface="Calibri"/>
+              </a:rPr>
+              <a:t>Usability Conflict: </a:t>
+            </a:r>
+            <a:r>
+              <a:rPr sz="1800" b="0">
+                <a:solidFill>
+                  <a:srgbClr val="F43F5E"/>
+                </a:solidFill>
+                <a:latin typeface="Calibri"/>
+              </a:rPr>
+              <a:t>Virtual keyboard typing detection must be context-aware; static noise injection would break normal AR/VR head tracking gestures.</a:t>
+            </a:r>
+          </a:p>
+        </p:txBody>
+      </p:sp>
+    </p:spTree>
+  </p:cSld>
+  <p:clrMapOvr>
+    <a:masterClrMapping/>
+  </p:clrMapOvr>
+</p:sld>
+</file>
+
+<file path=ppt/slides/slide5.xml><?xml version="1.0" encoding="utf-8"?>
+<p:sld xmlns:a="http://schemas.openxmlformats.org/drawingml/2006/main" xmlns:p="http://schemas.openxmlformats.org/presentationml/2006/main" xmlns:r="http://schemas.openxmlformats.org/officeDocument/2006/relationships">
+  <p:cSld>
+    <p:bg>
+      <p:bgPr>
+        <a:solidFill>
+          <a:srgbClr val="0F172A"/>
+        </a:solidFill>
+        <a:effectLst/>
+      </p:bgPr>
+    </p:bg>
+    <p:spTree>
+      <p:nvGrpSpPr>
+        <p:cNvPr id="1" name=""/>
+        <p:cNvGrpSpPr/>
+        <p:nvPr/>
+      </p:nvGrpSpPr>
+      <p:grpSpPr/>
+      <p:sp>
+        <p:nvSpPr>
+          <p:cNvPr id="2" name="TextBox 1"/>
+          <p:cNvSpPr txBox="1"/>
+          <p:nvPr/>
+        </p:nvSpPr>
+        <p:spPr>
+          <a:xfrm>
+            <a:off x="548640" y="365760"/>
+            <a:ext cx="8046720" cy="731520"/>
+          </a:xfrm>
+          <a:prstGeom prst="rect">
+            <a:avLst/>
+          </a:prstGeom>
+          <a:noFill/>
+        </p:spPr>
+        <p:txBody>
+          <a:bodyPr wrap="square" tIns="91440" bIns="91440">
+            <a:spAutoFit/>
+          </a:bodyPr>
+          <a:lstStyle/>
+          <a:p>
+            <a:pPr>
+              <a:defRPr sz="2800" b="1">
+                <a:solidFill>
+                  <a:srgbClr val="38BDF8"/>
+                </a:solidFill>
+                <a:latin typeface="Calibri"/>
+              </a:defRPr>
+            </a:pPr>
+            <a:r>
+              <a:t>The 'Toy Attacker' Trap: Why IID Noise Fails</a:t>
+            </a:r>
+          </a:p>
+        </p:txBody>
+      </p:sp>
+      <p:sp>
+        <p:nvSpPr>
+          <p:cNvPr id="3" name="TextBox 2"/>
+          <p:cNvSpPr txBox="1"/>
+          <p:nvPr/>
+        </p:nvSpPr>
+        <p:spPr>
+          <a:xfrm>
+            <a:off x="548640" y="1188720"/>
+            <a:ext cx="4572000" cy="3566160"/>
+          </a:xfrm>
+          <a:prstGeom prst="rect">
+            <a:avLst/>
+          </a:prstGeom>
+          <a:noFill/>
+        </p:spPr>
+        <p:txBody>
+          <a:bodyPr wrap="square" tIns="91440" bIns="91440">
+            <a:spAutoFit/>
+          </a:bodyPr>
+          <a:lstStyle/>
+          <a:p>
+            <a:pPr>
+              <a:spcAft>
+                <a:spcPts val="1000"/>
+              </a:spcAft>
+            </a:pPr>
+            <a:r>
+              <a:rPr sz="1600" b="1">
+                <a:solidFill>
+                  <a:srgbClr val="F8FAFC"/>
+                </a:solidFill>
+                <a:latin typeface="Calibri"/>
+              </a:rPr>
+              <a:t>IID Noise Method: </a:t>
+            </a:r>
+            <a:r>
+              <a:rPr sz="1600" b="0">
+                <a:solidFill>
+                  <a:srgbClr val="F8FAFC"/>
+                </a:solidFill>
+                <a:latin typeface="Calibri"/>
+              </a:rPr>
+              <a:t>Adds independent zero-mean Laplace noise to each sample. Points appear scattered on raw plots.</a:t>
+            </a:r>
+          </a:p>
+          <a:p>
+            <a:pPr>
+              <a:spcAft>
+                <a:spcPts val="1000"/>
+              </a:spcAft>
+            </a:pPr>
+            <a:r>
+              <a:rPr sz="1600" b="1">
+                <a:solidFill>
+                  <a:srgbClr val="F8FAFC"/>
+                </a:solidFill>
+                <a:latin typeface="Calibri"/>
+              </a:rPr>
+              <a:t>Adaptive Counter-Strategy: </a:t>
+            </a:r>
+            <a:r>
+              <a:rPr sz="1600" b="0">
+                <a:solidFill>
+                  <a:srgbClr val="F8FAFC"/>
+                </a:solidFill>
+                <a:latin typeface="Calibri"/>
+              </a:rPr>
+              <a:t>Since user dwell holds ~15-35 frames, the attacker segments by dwell and averages coordinates.</a:t>
+            </a:r>
+          </a:p>
+          <a:p>
+            <a:pPr>
+              <a:spcAft>
+                <a:spcPts val="1000"/>
+              </a:spcAft>
+            </a:pPr>
+            <a:r>
+              <a:rPr sz="1600" b="1">
+                <a:solidFill>
+                  <a:srgbClr val="F8FAFC"/>
+                </a:solidFill>
+                <a:latin typeface="Calibri"/>
+              </a:rPr>
+              <a:t>Noise Cancellation: </a:t>
+            </a:r>
+            <a:r>
+              <a:rPr sz="1600" b="0">
+                <a:solidFill>
+                  <a:srgbClr val="F8FAFC"/>
+                </a:solidFill>
+                <a:latin typeface="Calibri"/>
+              </a:rPr>
+              <a:t>By the Law of Large Numbers, independent zero-mean noise cancels out and averages back to zero.</a:t>
+            </a:r>
+          </a:p>
+          <a:p>
+            <a:pPr>
+              <a:spcAft>
+                <a:spcPts val="1000"/>
+              </a:spcAft>
+            </a:pPr>
+            <a:r>
+              <a:rPr sz="1600" b="1">
+                <a:solidFill>
+                  <a:srgbClr val="F43F5E"/>
+                </a:solidFill>
+                <a:latin typeface="Calibri"/>
+              </a:rPr>
+              <a:t>Performance: </a:t>
+            </a:r>
+            <a:r>
+              <a:rPr sz="1600" b="0">
+                <a:solidFill>
+                  <a:srgbClr val="F43F5E"/>
+                </a:solidFill>
+                <a:latin typeface="Calibri"/>
+              </a:rPr>
+              <a:t>Evaluated in our benchmark: drops naive attacker to 11% but fails against adaptive attacker (51% Top-1 character leak).</a:t>
+            </a:r>
+          </a:p>
+        </p:txBody>
+      </p:sp>
+      <p:pic>
+        <p:nvPicPr>
+          <p:cNvPr id="4" name="Picture 3" descr="math_expectation.png"/>
+          <p:cNvPicPr>
+            <a:picLocks noChangeAspect="1"/>
+          </p:cNvPicPr>
+          <p:nvPr/>
+        </p:nvPicPr>
+        <p:blipFill>
+          <a:blip r:embed="rId2"/>
+          <a:stretch>
+            <a:fillRect/>
+          </a:stretch>
+        </p:blipFill>
+        <p:spPr>
+          <a:xfrm>
+            <a:off x="5303520" y="2011680"/>
+            <a:ext cx="3474720" cy="731863"/>
+          </a:xfrm>
+          <a:prstGeom prst="rect">
+            <a:avLst/>
+          </a:prstGeom>
+        </p:spPr>
+      </p:pic>
+    </p:spTree>
+  </p:cSld>
+  <p:clrMapOvr>
+    <a:masterClrMapping/>
+  </p:clrMapOvr>
+</p:sld>
+</file>
+
+<file path=ppt/slides/slide6.xml><?xml version="1.0" encoding="utf-8"?>
+<p:sld xmlns:a="http://schemas.openxmlformats.org/drawingml/2006/main" xmlns:p="http://schemas.openxmlformats.org/presentationml/2006/main" xmlns:r="http://schemas.openxmlformats.org/officeDocument/2006/relationships">
+  <p:cSld>
+    <p:bg>
+      <p:bgPr>
+        <a:solidFill>
+          <a:srgbClr val="0F172A"/>
+        </a:solidFill>
+        <a:effectLst/>
+      </p:bgPr>
+    </p:bg>
+    <p:spTree>
+      <p:nvGrpSpPr>
+        <p:cNvPr id="1" name=""/>
+        <p:cNvGrpSpPr/>
+        <p:nvPr/>
+      </p:nvGrpSpPr>
+      <p:grpSpPr/>
+      <p:sp>
+        <p:nvSpPr>
+          <p:cNvPr id="2" name="TextBox 1"/>
+          <p:cNvSpPr txBox="1"/>
+          <p:nvPr/>
+        </p:nvSpPr>
+        <p:spPr>
+          <a:xfrm>
+            <a:off x="548640" y="365760"/>
+            <a:ext cx="8046720" cy="731520"/>
+          </a:xfrm>
+          <a:prstGeom prst="rect">
+            <a:avLst/>
+          </a:prstGeom>
+          <a:noFill/>
+        </p:spPr>
+        <p:txBody>
+          <a:bodyPr wrap="square" tIns="91440" bIns="91440">
+            <a:spAutoFit/>
+          </a:bodyPr>
+          <a:lstStyle/>
+          <a:p>
+            <a:pPr>
+              <a:defRPr sz="2800" b="1">
+                <a:solidFill>
+                  <a:srgbClr val="38BDF8"/>
+                </a:solidFill>
+                <a:latin typeface="Calibri"/>
+              </a:defRPr>
+            </a:pPr>
+            <a:r>
+              <a:t>Proposed Solution: CASOM Architecture</a:t>
+            </a:r>
+          </a:p>
+        </p:txBody>
+      </p:sp>
+      <p:sp>
+        <p:nvSpPr>
+          <p:cNvPr id="3" name="TextBox 2"/>
+          <p:cNvSpPr txBox="1"/>
+          <p:nvPr/>
+        </p:nvSpPr>
+        <p:spPr>
+          <a:xfrm>
+            <a:off x="548640" y="1280160"/>
+            <a:ext cx="8046720" cy="3474720"/>
+          </a:xfrm>
+          <a:prstGeom prst="rect">
+            <a:avLst/>
+          </a:prstGeom>
+          <a:noFill/>
+        </p:spPr>
+        <p:txBody>
+          <a:bodyPr wrap="square" tIns="91440" bIns="91440">
+            <a:spAutoFit/>
+          </a:bodyPr>
+          <a:lstStyle/>
+          <a:p>
+            <a:pPr>
+              <a:spcAft>
+                <a:spcPts val="1000"/>
+              </a:spcAft>
+            </a:pPr>
+            <a:r>
+              <a:rPr sz="1800" b="1">
+                <a:solidFill>
+                  <a:srgbClr val="F8FAFC"/>
+                </a:solidFill>
+                <a:latin typeface="Calibri"/>
+              </a:rPr>
+              <a:t>OS-Level Interceptor: </a:t>
+            </a:r>
+            <a:r>
+              <a:rPr sz="1800" b="0">
+                <a:solidFill>
+                  <a:srgbClr val="F8FAFC"/>
+                </a:solidFill>
+                <a:latin typeface="Calibri"/>
+              </a:rPr>
+              <a:t>Context-Aware Sensor Obfuscation Middleware running inside the OS sensor framework boundary.</a:t>
+            </a:r>
+          </a:p>
+          <a:p>
+            <a:pPr>
+              <a:spcAft>
+                <a:spcPts val="1000"/>
+              </a:spcAft>
+            </a:pPr>
+            <a:r>
+              <a:rPr sz="1800" b="1">
+                <a:solidFill>
+                  <a:srgbClr val="F8FAFC"/>
+                </a:solidFill>
+                <a:latin typeface="Calibri"/>
+              </a:rPr>
+              <a:t>Context Awareness: </a:t>
+            </a:r>
+            <a:r>
+              <a:rPr sz="1800" b="0">
+                <a:solidFill>
+                  <a:srgbClr val="F8FAFC"/>
+                </a:solidFill>
+                <a:latin typeface="Calibri"/>
+              </a:rPr>
+              <a:t>Detects keyboard events and focus states to dynamically trigger protection without breaking standard gestures.</a:t>
+            </a:r>
+          </a:p>
+          <a:p>
+            <a:pPr>
+              <a:spcAft>
+                <a:spcPts val="1000"/>
+              </a:spcAft>
+            </a:pPr>
+            <a:r>
+              <a:rPr sz="1800" b="1">
+                <a:solidFill>
+                  <a:srgbClr val="F8FAFC"/>
+                </a:solidFill>
+                <a:latin typeface="Calibri"/>
+              </a:rPr>
+              <a:t>Stream Bifurcation: </a:t>
+            </a:r>
+            <a:r>
+              <a:rPr sz="1800" b="0">
+                <a:solidFill>
+                  <a:srgbClr val="F8FAFC"/>
+                </a:solidFill>
+                <a:latin typeface="Calibri"/>
+              </a:rPr>
+              <a:t>Bifurcates raw tracking coordinates into separate foreground and background streams.</a:t>
+            </a:r>
+          </a:p>
+          <a:p>
+            <a:pPr>
+              <a:spcAft>
+                <a:spcPts val="1000"/>
+              </a:spcAft>
+            </a:pPr>
+            <a:r>
+              <a:rPr sz="1800" b="1">
+                <a:solidFill>
+                  <a:srgbClr val="10B981"/>
+                </a:solidFill>
+                <a:latin typeface="Calibri"/>
+              </a:rPr>
+              <a:t>Foreground Stream: </a:t>
+            </a:r>
+            <a:r>
+              <a:rPr sz="1800" b="0">
+                <a:solidFill>
+                  <a:srgbClr val="10B981"/>
+                </a:solidFill>
+                <a:latin typeface="Calibri"/>
+              </a:rPr>
+              <a:t>Legitimate Virtual Keyboard receives clean, high-precision telemetry, ensuring 100% typing accuracy and zero UX lag.</a:t>
+            </a:r>
+          </a:p>
+          <a:p>
+            <a:pPr>
+              <a:spcAft>
+                <a:spcPts val="1000"/>
+              </a:spcAft>
+            </a:pPr>
+            <a:r>
+              <a:rPr sz="1800" b="1">
+                <a:solidFill>
+                  <a:srgbClr val="F43F5E"/>
+                </a:solidFill>
+                <a:latin typeface="Calibri"/>
+              </a:rPr>
+              <a:t>Background Stream: </a:t>
+            </a:r>
+            <a:r>
+              <a:rPr sz="1800" b="0">
+                <a:solidFill>
+                  <a:srgbClr val="F43F5E"/>
+                </a:solidFill>
+                <a:latin typeface="Calibri"/>
+              </a:rPr>
+              <a:t>Background processes receive mathematically obfuscated streams, stripping them of high-fidelity spatial telemetry.</a:t>
+            </a:r>
+          </a:p>
+        </p:txBody>
+      </p:sp>
+    </p:spTree>
+  </p:cSld>
+  <p:clrMapOvr>
+    <a:masterClrMapping/>
+  </p:clrMapOvr>
+</p:sld>
+</file>
+
+<file path=ppt/slides/slide7.xml><?xml version="1.0" encoding="utf-8"?>
+<p:sld xmlns:a="http://schemas.openxmlformats.org/drawingml/2006/main" xmlns:p="http://schemas.openxmlformats.org/presentationml/2006/main" xmlns:r="http://schemas.openxmlformats.org/officeDocument/2006/relationships">
+  <p:cSld>
+    <p:bg>
+      <p:bgPr>
+        <a:solidFill>
+          <a:srgbClr val="0F172A"/>
+        </a:solidFill>
+        <a:effectLst/>
+      </p:bgPr>
+    </p:bg>
+    <p:spTree>
+      <p:nvGrpSpPr>
+        <p:cNvPr id="1" name=""/>
+        <p:cNvGrpSpPr/>
+        <p:nvPr/>
+      </p:nvGrpSpPr>
+      <p:grpSpPr/>
+      <p:sp>
+        <p:nvSpPr>
+          <p:cNvPr id="2" name="TextBox 1"/>
+          <p:cNvSpPr txBox="1"/>
+          <p:nvPr/>
+        </p:nvSpPr>
+        <p:spPr>
+          <a:xfrm>
+            <a:off x="548640" y="365760"/>
+            <a:ext cx="8046720" cy="731520"/>
+          </a:xfrm>
+          <a:prstGeom prst="rect">
+            <a:avLst/>
+          </a:prstGeom>
+          <a:noFill/>
+        </p:spPr>
+        <p:txBody>
+          <a:bodyPr wrap="square" tIns="91440" bIns="91440">
+            <a:spAutoFit/>
+          </a:bodyPr>
+          <a:lstStyle/>
+          <a:p>
+            <a:pPr>
+              <a:defRPr sz="2800" b="1">
+                <a:solidFill>
+                  <a:srgbClr val="38BDF8"/>
+                </a:solidFill>
+                <a:latin typeface="Calibri"/>
+              </a:defRPr>
+            </a:pPr>
+            <a:r>
+              <a:t>CASOM v2: Surviving the BackTree Attack</a:t>
+            </a:r>
+          </a:p>
+        </p:txBody>
+      </p:sp>
+      <p:sp>
+        <p:nvSpPr>
+          <p:cNvPr id="3" name="TextBox 2"/>
+          <p:cNvSpPr txBox="1"/>
+          <p:nvPr/>
+        </p:nvSpPr>
+        <p:spPr>
+          <a:xfrm>
+            <a:off x="548640" y="1280160"/>
+            <a:ext cx="8046720" cy="3474720"/>
+          </a:xfrm>
+          <a:prstGeom prst="rect">
+            <a:avLst/>
+          </a:prstGeom>
+          <a:noFill/>
+        </p:spPr>
+        <p:txBody>
+          <a:bodyPr wrap="square" tIns="91440" bIns="91440">
+            <a:spAutoFit/>
+          </a:bodyPr>
+          <a:lstStyle/>
+          <a:p>
+            <a:pPr>
+              <a:spcAft>
+                <a:spcPts val="1000"/>
+              </a:spcAft>
+            </a:pPr>
+            <a:r>
+              <a:rPr sz="1800" b="1">
+                <a:solidFill>
+                  <a:srgbClr val="F8FAFC"/>
+                </a:solidFill>
+                <a:latin typeface="Calibri"/>
+              </a:rPr>
+              <a:t>BackTree Adversary: </a:t>
+            </a:r>
+            <a:r>
+              <a:rPr sz="1800" b="0">
+                <a:solidFill>
+                  <a:srgbClr val="F8FAFC"/>
+                </a:solidFill>
+                <a:latin typeface="Calibri"/>
+              </a:rPr>
+              <a:t>The BackTree attack (SNOOPFINGER paper section 5.6) maps relative geometry vectors between keypress centroids, bypassing simple drift.</a:t>
+            </a:r>
+          </a:p>
+          <a:p>
+            <a:pPr>
+              <a:spcAft>
+                <a:spcPts val="1000"/>
+              </a:spcAft>
+            </a:pPr>
+            <a:r>
+              <a:rPr sz="1800" b="1">
+                <a:solidFill>
+                  <a:srgbClr val="F8FAFC"/>
+                </a:solidFill>
+                <a:latin typeface="Calibri"/>
+              </a:rPr>
+              <a:t>Drift Failure: </a:t>
+            </a:r>
+            <a:r>
+              <a:rPr sz="1800" b="0">
+                <a:solidFill>
+                  <a:srgbClr val="F8FAFC"/>
+                </a:solidFill>
+                <a:latin typeface="Calibri"/>
+              </a:rPr>
+              <a:t>A slow coordinate bias drift shifts consecutive centroids in the same direction, preserving relative vectors and letting BackTree succeed.</a:t>
+            </a:r>
+          </a:p>
+          <a:p>
+            <a:pPr>
+              <a:spcAft>
+                <a:spcPts val="1000"/>
+              </a:spcAft>
+            </a:pPr>
+            <a:r>
+              <a:rPr sz="1800" b="1">
+                <a:solidFill>
+                  <a:srgbClr val="10B981"/>
+                </a:solidFill>
+                <a:latin typeface="Calibri"/>
+              </a:rPr>
+              <a:t>Block Offset Defense (Recommended): </a:t>
+            </a:r>
+            <a:r>
+              <a:rPr sz="1800" b="0">
+                <a:solidFill>
+                  <a:srgbClr val="10B981"/>
+                </a:solidFill>
+                <a:latin typeface="Calibri"/>
+              </a:rPr>
+              <a:t>A Laplace noise offset is generated once per block of 15 samples (~dwell length) and held constant during the block.</a:t>
+            </a:r>
+          </a:p>
+          <a:p>
+            <a:pPr>
+              <a:spcAft>
+                <a:spcPts val="1000"/>
+              </a:spcAft>
+            </a:pPr>
+            <a:r>
+              <a:rPr sz="1800" b="1">
+                <a:solidFill>
+                  <a:srgbClr val="F8FAFC"/>
+                </a:solidFill>
+                <a:latin typeface="Calibri"/>
+              </a:rPr>
+              <a:t>Disruption Mechanism: </a:t>
+            </a:r>
+            <a:r>
+              <a:rPr sz="1800" b="0">
+                <a:solidFill>
+                  <a:srgbClr val="F8FAFC"/>
+                </a:solidFill>
+                <a:latin typeface="Calibri"/>
+              </a:rPr>
+              <a:t>Because noise changes per block, it shifts each key centroid independently, breaking relative vectors and surviving dwell averages.</a:t>
+            </a:r>
+          </a:p>
+          <a:p>
+            <a:pPr>
+              <a:spcAft>
+                <a:spcPts val="1000"/>
+              </a:spcAft>
+            </a:pPr>
+            <a:r>
+              <a:rPr sz="1800" b="1">
+                <a:solidFill>
+                  <a:srgbClr val="F8FAFC"/>
+                </a:solidFill>
+                <a:latin typeface="Calibri"/>
+              </a:rPr>
+              <a:t>Deployment Advantage: </a:t>
+            </a:r>
+            <a:r>
+              <a:rPr sz="1800" b="0">
+                <a:solidFill>
+                  <a:srgbClr val="F8FAFC"/>
+                </a:solidFill>
+                <a:latin typeface="Calibri"/>
+              </a:rPr>
+              <a:t>Does not require precise typing boundaries, making it highly deployable via standard timers.</a:t>
+            </a:r>
+          </a:p>
+        </p:txBody>
+      </p:sp>
+    </p:spTree>
+  </p:cSld>
+  <p:clrMapOvr>
+    <a:masterClrMapping/>
+  </p:clrMapOvr>
+</p:sld>
+</file>
+
+<file path=ppt/slides/slide8.xml><?xml version="1.0" encoding="utf-8"?>
+<p:sld xmlns:a="http://schemas.openxmlformats.org/drawingml/2006/main" xmlns:p="http://schemas.openxmlformats.org/presentationml/2006/main" xmlns:r="http://schemas.openxmlformats.org/officeDocument/2006/relationships">
+  <p:cSld>
+    <p:bg>
+      <p:bgPr>
+        <a:solidFill>
+          <a:srgbClr val="0F172A"/>
+        </a:solidFill>
+        <a:effectLst/>
+      </p:bgPr>
+    </p:bg>
+    <p:spTree>
+      <p:nvGrpSpPr>
+        <p:cNvPr id="1" name=""/>
+        <p:cNvGrpSpPr/>
+        <p:nvPr/>
+      </p:nvGrpSpPr>
+      <p:grpSpPr/>
+      <p:sp>
+        <p:nvSpPr>
+          <p:cNvPr id="2" name="TextBox 1"/>
+          <p:cNvSpPr txBox="1"/>
+          <p:nvPr/>
+        </p:nvSpPr>
+        <p:spPr>
+          <a:xfrm>
+            <a:off x="548640" y="365760"/>
+            <a:ext cx="8046720" cy="731520"/>
+          </a:xfrm>
+          <a:prstGeom prst="rect">
+            <a:avLst/>
+          </a:prstGeom>
+          <a:noFill/>
+        </p:spPr>
+        <p:txBody>
+          <a:bodyPr wrap="square" tIns="91440" bIns="91440">
+            <a:spAutoFit/>
+          </a:bodyPr>
+          <a:lstStyle/>
+          <a:p>
+            <a:pPr>
+              <a:defRPr sz="2800" b="1">
+                <a:solidFill>
+                  <a:srgbClr val="38BDF8"/>
+                </a:solidFill>
+                <a:latin typeface="Calibri"/>
+              </a:defRPr>
+            </a:pPr>
+            <a:r>
+              <a:t>Empirical Results: Word-Level Evaluation Table</a:t>
+            </a:r>
+          </a:p>
+        </p:txBody>
+      </p:sp>
+      <p:graphicFrame>
+        <p:nvGraphicFramePr>
+          <p:cNvPr id="3" name="Table 2"/>
+          <p:cNvGraphicFramePr>
+            <a:graphicFrameLocks noGrp="1"/>
+          </p:cNvGraphicFramePr>
+          <p:nvPr/>
+        </p:nvGraphicFramePr>
+        <p:xfrm>
+          <a:off x="548640" y="1188720"/>
+          <a:ext cx="8046720" cy="2011680"/>
+        </p:xfrm>
+        <a:graphic>
+          <a:graphicData uri="http://schemas.openxmlformats.org/drawingml/2006/table">
+            <a:tbl>
+              <a:tblPr firstRow="1" bandRow="1">
+                <a:tableStyleId>{5C22544A-7EE6-4342-B048-85BDC9FD1C3A}</a:tableStyleId>
+              </a:tblPr>
+              <a:tblGrid>
+                <a:gridCol w="2011680"/>
+                <a:gridCol w="2011680"/>
+                <a:gridCol w="2011680"/>
+                <a:gridCol w="2011680"/>
+              </a:tblGrid>
+              <a:tr h="287382">
+                <a:tc>
+                  <a:txBody>
+                    <a:bodyPr/>
+                    <a:lstStyle/>
+                    <a:p>
+                      <a:pPr algn="ctr">
+                        <a:defRPr sz="1400" b="1">
+                          <a:solidFill>
+                            <a:srgbClr val="38BDF8"/>
+                          </a:solidFill>
+                          <a:latin typeface="Calibri"/>
+                        </a:defRPr>
+                      </a:pPr>
+                      <a:r>
+                        <a:t>Defense Mode</a:t>
+                      </a:r>
+                    </a:p>
+                  </a:txBody>
+                  <a:tcPr>
+                    <a:solidFill>
+                      <a:srgbClr val="1E293B"/>
+                    </a:solidFill>
+                  </a:tcPr>
+                </a:tc>
+                <a:tc>
+                  <a:txBody>
+                    <a:bodyPr/>
+                    <a:lstStyle/>
+                    <a:p>
+                      <a:pPr algn="ctr">
+                        <a:defRPr sz="1400" b="1">
+                          <a:solidFill>
+                            <a:srgbClr val="38BDF8"/>
+                          </a:solidFill>
+                          <a:latin typeface="Calibri"/>
+                        </a:defRPr>
+                      </a:pPr>
+                      <a:r>
+                        <a:t>Word Top-1 Accuracy</a:t>
+                      </a:r>
+                    </a:p>
+                  </a:txBody>
+                  <a:tcPr>
+                    <a:solidFill>
+                      <a:srgbClr val="1E293B"/>
+                    </a:solidFill>
+                  </a:tcPr>
+                </a:tc>
+                <a:tc>
+                  <a:txBody>
+                    <a:bodyPr/>
+                    <a:lstStyle/>
+                    <a:p>
+                      <a:pPr algn="ctr">
+                        <a:defRPr sz="1400" b="1">
+                          <a:solidFill>
+                            <a:srgbClr val="38BDF8"/>
+                          </a:solidFill>
+                          <a:latin typeface="Calibri"/>
+                        </a:defRPr>
+                      </a:pPr>
+                      <a:r>
+                        <a:t>Word Top-3 Accuracy</a:t>
+                      </a:r>
+                    </a:p>
+                  </a:txBody>
+                  <a:tcPr>
+                    <a:solidFill>
+                      <a:srgbClr val="1E293B"/>
+                    </a:solidFill>
+                  </a:tcPr>
+                </a:tc>
+                <a:tc>
+                  <a:txBody>
+                    <a:bodyPr/>
+                    <a:lstStyle/>
+                    <a:p>
+                      <a:pPr algn="ctr">
+                        <a:defRPr sz="1400" b="1">
+                          <a:solidFill>
+                            <a:srgbClr val="38BDF8"/>
+                          </a:solidFill>
+                          <a:latin typeface="Calibri"/>
+                        </a:defRPr>
+                      </a:pPr>
+                      <a:r>
+                        <a:t>Word Top-10 Accuracy</a:t>
+                      </a:r>
+                    </a:p>
+                  </a:txBody>
+                  <a:tcPr>
+                    <a:solidFill>
+                      <a:srgbClr val="1E293B"/>
+                    </a:solidFill>
+                  </a:tcPr>
+                </a:tc>
+              </a:tr>
+              <a:tr h="287382">
+                <a:tc>
+                  <a:txBody>
+                    <a:bodyPr/>
+                    <a:lstStyle/>
+                    <a:p>
+                      <a:pPr algn="l">
+                        <a:defRPr sz="1300" b="1">
+                          <a:solidFill>
+                            <a:srgbClr val="F8FAFC"/>
+                          </a:solidFill>
+                          <a:latin typeface="Calibri"/>
+                        </a:defRPr>
+                      </a:pPr>
+                      <a:r>
+                        <a:t>No Defense (Baseline)</a:t>
+                      </a:r>
+                    </a:p>
+                  </a:txBody>
+                  <a:tcPr>
+                    <a:solidFill>
+                      <a:srgbClr val="161E31"/>
+                    </a:solidFill>
+                  </a:tcPr>
+                </a:tc>
+                <a:tc>
+                  <a:txBody>
+                    <a:bodyPr/>
+                    <a:lstStyle/>
+                    <a:p>
+                      <a:pPr algn="ctr">
+                        <a:defRPr sz="1300" b="1">
+                          <a:solidFill>
+                            <a:srgbClr val="F43F5E"/>
+                          </a:solidFill>
+                          <a:latin typeface="Calibri"/>
+                        </a:defRPr>
+                      </a:pPr>
+                      <a:r>
+                        <a:t>80.9%</a:t>
+                      </a:r>
+                    </a:p>
+                  </a:txBody>
+                  <a:tcPr>
+                    <a:solidFill>
+                      <a:srgbClr val="161E31"/>
+                    </a:solidFill>
+                  </a:tcPr>
+                </a:tc>
+                <a:tc>
+                  <a:txBody>
+                    <a:bodyPr/>
+                    <a:lstStyle/>
+                    <a:p>
+                      <a:pPr algn="ctr">
+                        <a:defRPr sz="1300" b="1">
+                          <a:solidFill>
+                            <a:srgbClr val="F43F5E"/>
+                          </a:solidFill>
+                          <a:latin typeface="Calibri"/>
+                        </a:defRPr>
+                      </a:pPr>
+                      <a:r>
+                        <a:t>80.9%</a:t>
+                      </a:r>
+                    </a:p>
+                  </a:txBody>
+                  <a:tcPr>
+                    <a:solidFill>
+                      <a:srgbClr val="161E31"/>
+                    </a:solidFill>
+                  </a:tcPr>
+                </a:tc>
+                <a:tc>
+                  <a:txBody>
+                    <a:bodyPr/>
+                    <a:lstStyle/>
+                    <a:p>
+                      <a:pPr algn="ctr">
+                        <a:defRPr sz="1300" b="1">
+                          <a:solidFill>
+                            <a:srgbClr val="F43F5E"/>
+                          </a:solidFill>
+                          <a:latin typeface="Calibri"/>
+                        </a:defRPr>
+                      </a:pPr>
+                      <a:r>
+                        <a:t>80.9%</a:t>
+                      </a:r>
+                    </a:p>
+                  </a:txBody>
+                  <a:tcPr>
+                    <a:solidFill>
+                      <a:srgbClr val="161E31"/>
+                    </a:solidFill>
+                  </a:tcPr>
+                </a:tc>
+              </a:tr>
+              <a:tr h="287382">
+                <a:tc>
+                  <a:txBody>
+                    <a:bodyPr/>
+                    <a:lstStyle/>
+                    <a:p>
+                      <a:pPr algn="l">
+                        <a:defRPr sz="1300" b="1">
+                          <a:solidFill>
+                            <a:srgbClr val="F8FAFC"/>
+                          </a:solidFill>
+                          <a:latin typeface="Calibri"/>
+                        </a:defRPr>
+                      </a:pPr>
+                      <a:r>
+                        <a:t>IID Noise (Original)</a:t>
+                      </a:r>
+                    </a:p>
+                  </a:txBody>
+                  <a:tcPr>
+                    <a:solidFill>
+                      <a:srgbClr val="0F172A"/>
+                    </a:solidFill>
+                  </a:tcPr>
+                </a:tc>
+                <a:tc>
+                  <a:txBody>
+                    <a:bodyPr/>
+                    <a:lstStyle/>
+                    <a:p>
+                      <a:pPr algn="ctr">
+                        <a:defRPr sz="1300">
+                          <a:solidFill>
+                            <a:srgbClr val="F8FAFC"/>
+                          </a:solidFill>
+                          <a:latin typeface="Calibri"/>
+                        </a:defRPr>
+                      </a:pPr>
+                      <a:r>
+                        <a:t>35.8%</a:t>
+                      </a:r>
+                    </a:p>
+                  </a:txBody>
+                  <a:tcPr>
+                    <a:solidFill>
+                      <a:srgbClr val="0F172A"/>
+                    </a:solidFill>
+                  </a:tcPr>
+                </a:tc>
+                <a:tc>
+                  <a:txBody>
+                    <a:bodyPr/>
+                    <a:lstStyle/>
+                    <a:p>
+                      <a:pPr algn="ctr">
+                        <a:defRPr sz="1300">
+                          <a:solidFill>
+                            <a:srgbClr val="F8FAFC"/>
+                          </a:solidFill>
+                          <a:latin typeface="Calibri"/>
+                        </a:defRPr>
+                      </a:pPr>
+                      <a:r>
+                        <a:t>51.8%</a:t>
+                      </a:r>
+                    </a:p>
+                  </a:txBody>
+                  <a:tcPr>
+                    <a:solidFill>
+                      <a:srgbClr val="0F172A"/>
+                    </a:solidFill>
+                  </a:tcPr>
+                </a:tc>
+                <a:tc>
+                  <a:txBody>
+                    <a:bodyPr/>
+                    <a:lstStyle/>
+                    <a:p>
+                      <a:pPr algn="ctr">
+                        <a:defRPr sz="1300">
+                          <a:solidFill>
+                            <a:srgbClr val="F8FAFC"/>
+                          </a:solidFill>
+                          <a:latin typeface="Calibri"/>
+                        </a:defRPr>
+                      </a:pPr>
+                      <a:r>
+                        <a:t>62.9%</a:t>
+                      </a:r>
+                    </a:p>
+                  </a:txBody>
+                  <a:tcPr>
+                    <a:solidFill>
+                      <a:srgbClr val="0F172A"/>
+                    </a:solidFill>
+                  </a:tcPr>
+                </a:tc>
+              </a:tr>
+              <a:tr h="287382">
+                <a:tc>
+                  <a:txBody>
+                    <a:bodyPr/>
+                    <a:lstStyle/>
+                    <a:p>
+                      <a:pPr algn="l">
+                        <a:defRPr sz="1300" b="1">
+                          <a:solidFill>
+                            <a:srgbClr val="F8FAFC"/>
+                          </a:solidFill>
+                          <a:latin typeface="Calibri"/>
+                        </a:defRPr>
+                      </a:pPr>
+                      <a:r>
+                        <a:t>Correlated Drift</a:t>
+                      </a:r>
+                    </a:p>
+                  </a:txBody>
+                  <a:tcPr>
+                    <a:solidFill>
+                      <a:srgbClr val="161E31"/>
+                    </a:solidFill>
+                  </a:tcPr>
+                </a:tc>
+                <a:tc>
+                  <a:txBody>
+                    <a:bodyPr/>
+                    <a:lstStyle/>
+                    <a:p>
+                      <a:pPr algn="ctr">
+                        <a:defRPr sz="1300">
+                          <a:solidFill>
+                            <a:srgbClr val="F8FAFC"/>
+                          </a:solidFill>
+                          <a:latin typeface="Calibri"/>
+                        </a:defRPr>
+                      </a:pPr>
+                      <a:r>
+                        <a:t>27.6%</a:t>
+                      </a:r>
+                    </a:p>
+                  </a:txBody>
+                  <a:tcPr>
+                    <a:solidFill>
+                      <a:srgbClr val="161E31"/>
+                    </a:solidFill>
+                  </a:tcPr>
+                </a:tc>
+                <a:tc>
+                  <a:txBody>
+                    <a:bodyPr/>
+                    <a:lstStyle/>
+                    <a:p>
+                      <a:pPr algn="ctr">
+                        <a:defRPr sz="1300">
+                          <a:solidFill>
+                            <a:srgbClr val="F8FAFC"/>
+                          </a:solidFill>
+                          <a:latin typeface="Calibri"/>
+                        </a:defRPr>
+                      </a:pPr>
+                      <a:r>
+                        <a:t>42.1%</a:t>
+                      </a:r>
+                    </a:p>
+                  </a:txBody>
+                  <a:tcPr>
+                    <a:solidFill>
+                      <a:srgbClr val="161E31"/>
+                    </a:solidFill>
+                  </a:tcPr>
+                </a:tc>
+                <a:tc>
+                  <a:txBody>
+                    <a:bodyPr/>
+                    <a:lstStyle/>
+                    <a:p>
+                      <a:pPr algn="ctr">
+                        <a:defRPr sz="1300">
+                          <a:solidFill>
+                            <a:srgbClr val="F8FAFC"/>
+                          </a:solidFill>
+                          <a:latin typeface="Calibri"/>
+                        </a:defRPr>
+                      </a:pPr>
+                      <a:r>
+                        <a:t>52.7%</a:t>
+                      </a:r>
+                    </a:p>
+                  </a:txBody>
+                  <a:tcPr>
+                    <a:solidFill>
+                      <a:srgbClr val="161E31"/>
+                    </a:solidFill>
+                  </a:tcPr>
+                </a:tc>
+              </a:tr>
+              <a:tr h="287382">
+                <a:tc>
+                  <a:txBody>
+                    <a:bodyPr/>
+                    <a:lstStyle/>
+                    <a:p>
+                      <a:pPr algn="l">
+                        <a:defRPr sz="1300" b="1">
+                          <a:solidFill>
+                            <a:srgbClr val="F8FAFC"/>
+                          </a:solidFill>
+                          <a:latin typeface="Calibri"/>
+                        </a:defRPr>
+                      </a:pPr>
+                      <a:r>
+                        <a:t>Downsample &amp; Quantize</a:t>
+                      </a:r>
+                    </a:p>
+                  </a:txBody>
+                  <a:tcPr>
+                    <a:solidFill>
+                      <a:srgbClr val="0F172A"/>
+                    </a:solidFill>
+                  </a:tcPr>
+                </a:tc>
+                <a:tc>
+                  <a:txBody>
+                    <a:bodyPr/>
+                    <a:lstStyle/>
+                    <a:p>
+                      <a:pPr algn="ctr">
+                        <a:defRPr sz="1300" b="1">
+                          <a:solidFill>
+                            <a:srgbClr val="10B981"/>
+                          </a:solidFill>
+                          <a:latin typeface="Calibri"/>
+                        </a:defRPr>
+                      </a:pPr>
+                      <a:r>
+                        <a:t>2.3%</a:t>
+                      </a:r>
+                    </a:p>
+                  </a:txBody>
+                  <a:tcPr>
+                    <a:solidFill>
+                      <a:srgbClr val="0F172A"/>
+                    </a:solidFill>
+                  </a:tcPr>
+                </a:tc>
+                <a:tc>
+                  <a:txBody>
+                    <a:bodyPr/>
+                    <a:lstStyle/>
+                    <a:p>
+                      <a:pPr algn="ctr">
+                        <a:defRPr sz="1300">
+                          <a:solidFill>
+                            <a:srgbClr val="F8FAFC"/>
+                          </a:solidFill>
+                          <a:latin typeface="Calibri"/>
+                        </a:defRPr>
+                      </a:pPr>
+                      <a:r>
+                        <a:t>5.6%</a:t>
+                      </a:r>
+                    </a:p>
+                  </a:txBody>
+                  <a:tcPr>
+                    <a:solidFill>
+                      <a:srgbClr val="0F172A"/>
+                    </a:solidFill>
+                  </a:tcPr>
+                </a:tc>
+                <a:tc>
+                  <a:txBody>
+                    <a:bodyPr/>
+                    <a:lstStyle/>
+                    <a:p>
+                      <a:pPr algn="ctr">
+                        <a:defRPr sz="1300">
+                          <a:solidFill>
+                            <a:srgbClr val="F8FAFC"/>
+                          </a:solidFill>
+                          <a:latin typeface="Calibri"/>
+                        </a:defRPr>
+                      </a:pPr>
+                      <a:r>
+                        <a:t>8.9%</a:t>
+                      </a:r>
+                    </a:p>
+                  </a:txBody>
+                  <a:tcPr>
+                    <a:solidFill>
+                      <a:srgbClr val="0F172A"/>
+                    </a:solidFill>
+                  </a:tcPr>
+                </a:tc>
+              </a:tr>
+              <a:tr h="287382">
+                <a:tc>
+                  <a:txBody>
+                    <a:bodyPr/>
+                    <a:lstStyle/>
+                    <a:p>
+                      <a:pPr algn="l">
+                        <a:defRPr sz="1300" b="1">
+                          <a:solidFill>
+                            <a:srgbClr val="F8FAFC"/>
+                          </a:solidFill>
+                          <a:latin typeface="Calibri"/>
+                        </a:defRPr>
+                      </a:pPr>
+                      <a:r>
+                        <a:t>Block Offset (CASOM)</a:t>
+                      </a:r>
+                    </a:p>
+                  </a:txBody>
+                  <a:tcPr>
+                    <a:solidFill>
+                      <a:srgbClr val="161E31"/>
+                    </a:solidFill>
+                  </a:tcPr>
+                </a:tc>
+                <a:tc>
+                  <a:txBody>
+                    <a:bodyPr/>
+                    <a:lstStyle/>
+                    <a:p>
+                      <a:pPr algn="ctr">
+                        <a:defRPr sz="1300" b="1">
+                          <a:solidFill>
+                            <a:srgbClr val="10B981"/>
+                          </a:solidFill>
+                          <a:latin typeface="Calibri"/>
+                        </a:defRPr>
+                      </a:pPr>
+                      <a:r>
+                        <a:t>3.6%</a:t>
+                      </a:r>
+                    </a:p>
+                  </a:txBody>
+                  <a:tcPr>
+                    <a:solidFill>
+                      <a:srgbClr val="161E31"/>
+                    </a:solidFill>
+                  </a:tcPr>
+                </a:tc>
+                <a:tc>
+                  <a:txBody>
+                    <a:bodyPr/>
+                    <a:lstStyle/>
+                    <a:p>
+                      <a:pPr algn="ctr">
+                        <a:defRPr sz="1300">
+                          <a:solidFill>
+                            <a:srgbClr val="F8FAFC"/>
+                          </a:solidFill>
+                          <a:latin typeface="Calibri"/>
+                        </a:defRPr>
+                      </a:pPr>
+                      <a:r>
+                        <a:t>7.0%</a:t>
+                      </a:r>
+                    </a:p>
+                  </a:txBody>
+                  <a:tcPr>
+                    <a:solidFill>
+                      <a:srgbClr val="161E31"/>
+                    </a:solidFill>
+                  </a:tcPr>
+                </a:tc>
+                <a:tc>
+                  <a:txBody>
+                    <a:bodyPr/>
+                    <a:lstStyle/>
+                    <a:p>
+                      <a:pPr algn="ctr">
+                        <a:defRPr sz="1300">
+                          <a:solidFill>
+                            <a:srgbClr val="F8FAFC"/>
+                          </a:solidFill>
+                          <a:latin typeface="Calibri"/>
+                        </a:defRPr>
+                      </a:pPr>
+                      <a:r>
+                        <a:t>13.6%</a:t>
+                      </a:r>
+                    </a:p>
+                  </a:txBody>
+                  <a:tcPr>
+                    <a:solidFill>
+                      <a:srgbClr val="161E31"/>
+                    </a:solidFill>
+                  </a:tcPr>
+                </a:tc>
+              </a:tr>
+              <a:tr h="287388">
+                <a:tc>
+                  <a:txBody>
+                    <a:bodyPr/>
+                    <a:lstStyle/>
+                    <a:p>
+                      <a:pPr algn="l">
+                        <a:defRPr sz="1300" b="1">
+                          <a:solidFill>
+                            <a:srgbClr val="F8FAFC"/>
+                          </a:solidFill>
+                          <a:latin typeface="Calibri"/>
+                        </a:defRPr>
+                      </a:pPr>
+                      <a:r>
+                        <a:t>Per-Keypress Offset</a:t>
+                      </a:r>
+                    </a:p>
+                  </a:txBody>
+                  <a:tcPr>
+                    <a:solidFill>
+                      <a:srgbClr val="0F172A"/>
+                    </a:solidFill>
+                  </a:tcPr>
+                </a:tc>
+                <a:tc>
+                  <a:txBody>
+                    <a:bodyPr/>
+                    <a:lstStyle/>
+                    <a:p>
+                      <a:pPr algn="ctr">
+                        <a:defRPr sz="1300" b="1">
+                          <a:solidFill>
+                            <a:srgbClr val="10B981"/>
+                          </a:solidFill>
+                          <a:latin typeface="Calibri"/>
+                        </a:defRPr>
+                      </a:pPr>
+                      <a:r>
+                        <a:t>2.3%</a:t>
+                      </a:r>
+                    </a:p>
+                  </a:txBody>
+                  <a:tcPr>
+                    <a:solidFill>
+                      <a:srgbClr val="0F172A"/>
+                    </a:solidFill>
+                  </a:tcPr>
+                </a:tc>
+                <a:tc>
+                  <a:txBody>
+                    <a:bodyPr/>
+                    <a:lstStyle/>
+                    <a:p>
+                      <a:pPr algn="ctr">
+                        <a:defRPr sz="1300">
+                          <a:solidFill>
+                            <a:srgbClr val="F8FAFC"/>
+                          </a:solidFill>
+                          <a:latin typeface="Calibri"/>
+                        </a:defRPr>
+                      </a:pPr>
+                      <a:r>
+                        <a:t>3.8%</a:t>
+                      </a:r>
+                    </a:p>
+                  </a:txBody>
+                  <a:tcPr>
+                    <a:solidFill>
+                      <a:srgbClr val="0F172A"/>
+                    </a:solidFill>
+                  </a:tcPr>
+                </a:tc>
+                <a:tc>
+                  <a:txBody>
+                    <a:bodyPr/>
+                    <a:lstStyle/>
+                    <a:p>
+                      <a:pPr algn="ctr">
+                        <a:defRPr sz="1300">
+                          <a:solidFill>
+                            <a:srgbClr val="F8FAFC"/>
+                          </a:solidFill>
+                          <a:latin typeface="Calibri"/>
+                        </a:defRPr>
+                      </a:pPr>
+                      <a:r>
+                        <a:t>7.6%</a:t>
+                      </a:r>
+                    </a:p>
+                  </a:txBody>
+                  <a:tcPr>
+                    <a:solidFill>
+                      <a:srgbClr val="0F172A"/>
+                    </a:solidFill>
+                  </a:tcPr>
+                </a:tc>
+              </a:tr>
+            </a:tbl>
+          </a:graphicData>
+        </a:graphic>
+      </p:graphicFrame>
+      <p:sp>
+        <p:nvSpPr>
+          <p:cNvPr id="4" name="TextBox 3"/>
+          <p:cNvSpPr txBox="1"/>
+          <p:nvPr/>
+        </p:nvSpPr>
+        <p:spPr>
+          <a:xfrm>
+            <a:off x="548640" y="3474720"/>
+            <a:ext cx="8046720" cy="1371600"/>
+          </a:xfrm>
+          <a:prstGeom prst="rect">
+            <a:avLst/>
+          </a:prstGeom>
+          <a:noFill/>
+        </p:spPr>
+        <p:txBody>
+          <a:bodyPr wrap="square" tIns="91440" bIns="91440">
+            <a:spAutoFit/>
+          </a:bodyPr>
+          <a:lstStyle/>
+          <a:p>
+            <a:pPr>
+              <a:spcAft>
+                <a:spcPts val="1000"/>
+              </a:spcAft>
+            </a:pPr>
+            <a:r>
+              <a:rPr sz="1400" b="1">
+                <a:solidFill>
+                  <a:srgbClr val="F8FAFC"/>
+                </a:solidFill>
+                <a:latin typeface="Calibri"/>
+              </a:rPr>
+              <a:t>Key Takeaway: </a:t>
+            </a:r>
+            <a:r>
+              <a:rPr sz="1400" b="0">
+                <a:solidFill>
+                  <a:srgbClr val="F8FAFC"/>
+                </a:solidFill>
+                <a:latin typeface="Calibri"/>
+              </a:rPr>
+              <a:t>The recommended Block Offset defense collapses Top-1 accuracy to 3.6% (near chance for 8k dictionary).</a:t>
+            </a:r>
+          </a:p>
+          <a:p>
+            <a:pPr>
+              <a:spcAft>
+                <a:spcPts val="1000"/>
+              </a:spcAft>
+            </a:pPr>
+            <a:r>
+              <a:rPr sz="1400" b="1">
+                <a:solidFill>
+                  <a:srgbClr val="F8FAFC"/>
+                </a:solidFill>
+                <a:latin typeface="Calibri"/>
+              </a:rPr>
+              <a:t>Drift Deficit: </a:t>
+            </a:r>
+            <a:r>
+              <a:rPr sz="1400" b="0">
+                <a:solidFill>
+                  <a:srgbClr val="F8FAFC"/>
+                </a:solidFill>
+                <a:latin typeface="Calibri"/>
+              </a:rPr>
+              <a:t> drift fails to defend against BackTree because vectors survive, leaving Top-1 at 27.6%.</a:t>
+            </a:r>
+          </a:p>
+          <a:p>
+            <a:pPr>
+              <a:spcAft>
+                <a:spcPts val="1000"/>
+              </a:spcAft>
+            </a:pPr>
+            <a:r>
+              <a:rPr sz="1400" b="1">
+                <a:solidFill>
+                  <a:srgbClr val="F8FAFC"/>
+                </a:solidFill>
+                <a:latin typeface="Calibri"/>
+              </a:rPr>
+              <a:t>IID Deficit: </a:t>
+            </a:r>
+            <a:r>
+              <a:rPr sz="1400" b="0">
+                <a:solidFill>
+                  <a:srgbClr val="F8FAFC"/>
+                </a:solidFill>
+                <a:latin typeface="Calibri"/>
+              </a:rPr>
+              <a:t>IID Noise averages out, leaving a significant Top-10 leak of 62.9%.</a:t>
+            </a:r>
+          </a:p>
+        </p:txBody>
+      </p:sp>
+    </p:spTree>
+  </p:cSld>
+  <p:clrMapOvr>
+    <a:masterClrMapping/>
+  </p:clrMapOvr>
+</p:sld>
+</file>
+
+<file path=ppt/slides/slide9.xml><?xml version="1.0" encoding="utf-8"?>
+<p:sld xmlns:a="http://schemas.openxmlformats.org/drawingml/2006/main" xmlns:p="http://schemas.openxmlformats.org/presentationml/2006/main" xmlns:r="http://schemas.openxmlformats.org/officeDocument/2006/relationships">
+  <p:cSld>
+    <p:bg>
+      <p:bgPr>
+        <a:solidFill>
+          <a:srgbClr val="0F172A"/>
+        </a:solidFill>
+        <a:effectLst/>
+      </p:bgPr>
+    </p:bg>
+    <p:spTree>
+      <p:nvGrpSpPr>
+        <p:cNvPr id="1" name=""/>
+        <p:cNvGrpSpPr/>
+        <p:nvPr/>
+      </p:nvGrpSpPr>
+      <p:grpSpPr/>
+      <p:sp>
+        <p:nvSpPr>
+          <p:cNvPr id="2" name="TextBox 1"/>
+          <p:cNvSpPr txBox="1"/>
+          <p:nvPr/>
+        </p:nvSpPr>
+        <p:spPr>
+          <a:xfrm>
+            <a:off x="548640" y="365760"/>
+            <a:ext cx="8046720" cy="731520"/>
+          </a:xfrm>
+          <a:prstGeom prst="rect">
+            <a:avLst/>
+          </a:prstGeom>
+          <a:noFill/>
+        </p:spPr>
+        <p:txBody>
+          <a:bodyPr wrap="square" tIns="91440" bIns="91440">
+            <a:spAutoFit/>
+          </a:bodyPr>
+          <a:lstStyle/>
+          <a:p>
+            <a:pPr>
+              <a:defRPr sz="2800" b="1">
+                <a:solidFill>
+                  <a:srgbClr val="38BDF8"/>
+                </a:solidFill>
+                <a:latin typeface="Calibri"/>
+              </a:defRPr>
+            </a:pPr>
+            <a:r>
+              <a:t>Empirical Validation Plots</a:t>
+            </a:r>
+          </a:p>
+        </p:txBody>
+      </p:sp>
+      <p:sp>
+        <p:nvSpPr>
+          <p:cNvPr id="3" name="TextBox 2"/>
+          <p:cNvSpPr txBox="1"/>
+          <p:nvPr/>
+        </p:nvSpPr>
+        <p:spPr>
+          <a:xfrm>
+            <a:off x="548640" y="1188720"/>
+            <a:ext cx="4114800" cy="3566160"/>
+          </a:xfrm>
+          <a:prstGeom prst="rect">
+            <a:avLst/>
+          </a:prstGeom>
+          <a:noFill/>
+        </p:spPr>
+        <p:txBody>
+          <a:bodyPr wrap="square" tIns="91440" bIns="91440">
+            <a:spAutoFit/>
+          </a:bodyPr>
+          <a:lstStyle/>
+          <a:p>
+            <a:pPr>
+              <a:spcAft>
+                <a:spcPts val="1000"/>
+              </a:spcAft>
+            </a:pPr>
+            <a:r>
+              <a:rPr sz="1600" b="1">
+                <a:solidFill>
+                  <a:srgbClr val="F8FAFC"/>
+                </a:solidFill>
+                <a:latin typeface="Calibri"/>
+              </a:rPr>
+              <a:t>Telemetry Plots: </a:t>
+            </a:r>
+            <a:r>
+              <a:rPr sz="1600" b="0">
+                <a:solidFill>
+                  <a:srgbClr val="F8FAFC"/>
+                </a:solidFill>
+                <a:latin typeface="Calibri"/>
+              </a:rPr>
+              <a:t>Includes a character-level simulation dashboard and word-level evaluation plots.</a:t>
+            </a:r>
+          </a:p>
+          <a:p>
+            <a:pPr>
+              <a:spcAft>
+                <a:spcPts val="1000"/>
+              </a:spcAft>
+            </a:pPr>
+            <a:r>
+              <a:rPr sz="1600" b="1">
+                <a:solidFill>
+                  <a:srgbClr val="F8FAFC"/>
+                </a:solidFill>
+                <a:latin typeface="Calibri"/>
+              </a:rPr>
+              <a:t>Visual Scatter: </a:t>
+            </a:r>
+            <a:r>
+              <a:rPr sz="1600" b="0">
+                <a:solidFill>
+                  <a:srgbClr val="F8FAFC"/>
+                </a:solidFill>
+                <a:latin typeface="Calibri"/>
+              </a:rPr>
+              <a:t>Left Panel (simulation_result.png) demonstrates visual scatter. Dwell clusters are completely dispersed.</a:t>
+            </a:r>
+          </a:p>
+          <a:p>
+            <a:pPr>
+              <a:spcAft>
+                <a:spcPts val="1000"/>
+              </a:spcAft>
+            </a:pPr>
+            <a:r>
+              <a:rPr sz="1600" b="1">
+                <a:solidFill>
+                  <a:srgbClr val="F8FAFC"/>
+                </a:solidFill>
+                <a:latin typeface="Calibri"/>
+              </a:rPr>
+              <a:t>BackTree Results: </a:t>
+            </a:r>
+            <a:r>
+              <a:rPr sz="1600" b="0">
+                <a:solidFill>
+                  <a:srgbClr val="F8FAFC"/>
+                </a:solidFill>
+                <a:latin typeface="Calibri"/>
+              </a:rPr>
+              <a:t>Right Panel (backtree_result.png) maps word inference rates under various noise profiles, validating the collapse of BackTree.</a:t>
+            </a:r>
+          </a:p>
+        </p:txBody>
+      </p:sp>
+      <p:pic>
+        <p:nvPicPr>
+          <p:cNvPr id="4" name="Picture 3" descr="simulation_result.png"/>
+          <p:cNvPicPr>
+            <a:picLocks noChangeAspect="1"/>
+          </p:cNvPicPr>
+          <p:nvPr/>
+        </p:nvPicPr>
+        <p:blipFill>
+          <a:blip r:embed="rId2"/>
+          <a:stretch>
+            <a:fillRect/>
+          </a:stretch>
+        </p:blipFill>
+        <p:spPr>
+          <a:xfrm>
+            <a:off x="4846320" y="1188720"/>
+            <a:ext cx="3749039" cy="1737360"/>
+          </a:xfrm>
+          <a:prstGeom prst="rect">
+            <a:avLst/>
+          </a:prstGeom>
+        </p:spPr>
+      </p:pic>
+      <p:pic>
+        <p:nvPicPr>
+          <p:cNvPr id="5" name="Picture 4" descr="backtree_result.png"/>
+          <p:cNvPicPr>
+            <a:picLocks noChangeAspect="1"/>
+          </p:cNvPicPr>
+          <p:nvPr/>
+        </p:nvPicPr>
+        <p:blipFill>
+          <a:blip r:embed="rId3"/>
+          <a:stretch>
+            <a:fillRect/>
+          </a:stretch>
+        </p:blipFill>
+        <p:spPr>
+          <a:xfrm>
+            <a:off x="4846320" y="3017520"/>
+            <a:ext cx="3749039" cy="1737360"/>
+          </a:xfrm>
+          <a:prstGeom prst="rect">
+            <a:avLst/>
+          </a:prstGeom>
+        </p:spPr>
+      </p:pic>
     </p:spTree>
   </p:cSld>
   <p:clrMapOvr>

</xml_diff>

<commit_message>
Document and simulate newly identified gaps (deviation gestures, external tampering) in SNOOPFINGER
</commit_message>
<xml_diff>
--- a/Cybersecurity_Major_Project.pptx
+++ b/Cybersecurity_Major_Project.pptx
@@ -14,9 +14,8 @@
     <p:sldId id="262" r:id="rId13"/>
     <p:sldId id="263" r:id="rId14"/>
     <p:sldId id="264" r:id="rId15"/>
-    <p:sldId id="265" r:id="rId16"/>
   </p:sldIdLst>
-  <p:sldSz cx="9144000" cy="5143500" type="screen4x3"/>
+  <p:sldSz cx="9144000" cy="6858000" type="screen4x3"/>
   <p:notesSz cx="6858000" cy="9144000"/>
   <p:defaultTextStyle>
     <a:defPPr>
@@ -3090,14 +3089,6 @@
 <file path=ppt/slides/slide1.xml><?xml version="1.0" encoding="utf-8"?>
 <p:sld xmlns:a="http://schemas.openxmlformats.org/drawingml/2006/main" xmlns:p="http://schemas.openxmlformats.org/presentationml/2006/main" xmlns:r="http://schemas.openxmlformats.org/officeDocument/2006/relationships">
   <p:cSld>
-    <p:bg>
-      <p:bgPr>
-        <a:solidFill>
-          <a:srgbClr val="0F172A"/>
-        </a:solidFill>
-        <a:effectLst/>
-      </p:bgPr>
-    </p:bg>
     <p:spTree>
       <p:nvGrpSpPr>
         <p:cNvPr id="1" name=""/>
@@ -3107,261 +3098,57 @@
       <p:grpSpPr/>
       <p:sp>
         <p:nvSpPr>
-          <p:cNvPr id="2" name="TextBox 1"/>
-          <p:cNvSpPr txBox="1"/>
-          <p:nvPr/>
-        </p:nvSpPr>
-        <p:spPr>
-          <a:xfrm>
-            <a:off x="731520" y="1371600"/>
-            <a:ext cx="7680960" cy="2286000"/>
-          </a:xfrm>
-          <a:prstGeom prst="rect">
-            <a:avLst/>
-          </a:prstGeom>
-          <a:noFill/>
-        </p:spPr>
-        <p:txBody>
-          <a:bodyPr wrap="square" tIns="91440" bIns="91440">
-            <a:spAutoFit/>
-          </a:bodyPr>
-          <a:lstStyle/>
-          <a:p>
-            <a:pPr algn="l">
-              <a:spcAft>
-                <a:spcPts val="2000"/>
-              </a:spcAft>
-              <a:defRPr sz="3600" b="1">
-                <a:solidFill>
-                  <a:srgbClr val="F8FAFC"/>
-                </a:solidFill>
-                <a:latin typeface="Calibri"/>
-              </a:defRPr>
-            </a:pPr>
-            <a:r>
-              <a:t>Side-Channel Keystroke Leakage and Context-Aware Defense in AR/VR Environments</a:t>
-            </a:r>
-          </a:p>
-          <a:p>
-            <a:pPr algn="l">
-              <a:spcAft>
-                <a:spcPts val="4000"/>
-              </a:spcAft>
-              <a:defRPr sz="1800">
-                <a:solidFill>
-                  <a:srgbClr val="38BDF8"/>
-                </a:solidFill>
-                <a:latin typeface="Calibri"/>
-              </a:defRPr>
-            </a:pPr>
-            <a:r>
-              <a:t>Analysis of the SNOOPFINGER Attack and the CASOM Defense Framework</a:t>
-            </a:r>
-          </a:p>
-          <a:p>
-            <a:pPr algn="l">
-              <a:defRPr sz="1300">
-                <a:solidFill>
-                  <a:srgbClr val="94A3B8"/>
-                </a:solidFill>
-                <a:latin typeface="Calibri"/>
-              </a:defRPr>
-            </a:pPr>
-            <a:r>
-              <a:t>CSL6010-Cybersecurity Major Project Submission</a:t>
-            </a:r>
-            <a:br/>
-            <a:r>
-              <a:t>Prepared by: Graduate Student Analysis Team</a:t>
-            </a:r>
-            <a:br/>
+          <p:cNvPr id="2" name="Title 1"/>
+          <p:cNvSpPr>
+            <a:spLocks noGrp="1"/>
+          </p:cNvSpPr>
+          <p:nvPr>
+            <p:ph type="ctrTitle"/>
+          </p:nvPr>
+        </p:nvSpPr>
+        <p:spPr/>
+        <p:txBody>
+          <a:bodyPr/>
+          <a:lstStyle/>
+          <a:p>
+            <a:r>
+              <a:t>CSL6010-Cybersecurity Major Project:</a:t>
+            </a:r>
+          </a:p>
+          <a:p>
+            <a:r>
+              <a:t>Eyes on Your Typing &amp; CASOM Defense</a:t>
+            </a:r>
+          </a:p>
+        </p:txBody>
+      </p:sp>
+      <p:sp>
+        <p:nvSpPr>
+          <p:cNvPr id="3" name="Subtitle 2"/>
+          <p:cNvSpPr>
+            <a:spLocks noGrp="1"/>
+          </p:cNvSpPr>
+          <p:nvPr>
+            <p:ph type="subTitle" idx="1"/>
+          </p:nvPr>
+        </p:nvSpPr>
+        <p:spPr/>
+        <p:txBody>
+          <a:bodyPr/>
+          <a:lstStyle/>
+          <a:p>
+            <a:r>
+              <a:t>Analysis of SNOOPFINGER Attack and Proposed Middleware</a:t>
+            </a:r>
+          </a:p>
+          <a:p>
+            <a:r>
+              <a:t>By: Group of 7 Members</a:t>
+            </a:r>
+          </a:p>
+          <a:p>
             <a:r>
               <a:t>Repository: https://github.com/AzDevops143/CSIEEE</a:t>
-            </a:r>
-          </a:p>
-        </p:txBody>
-      </p:sp>
-    </p:spTree>
-  </p:cSld>
-  <p:clrMapOvr>
-    <a:masterClrMapping/>
-  </p:clrMapOvr>
-</p:sld>
-</file>
-
-<file path=ppt/slides/slide10.xml><?xml version="1.0" encoding="utf-8"?>
-<p:sld xmlns:a="http://schemas.openxmlformats.org/drawingml/2006/main" xmlns:p="http://schemas.openxmlformats.org/presentationml/2006/main" xmlns:r="http://schemas.openxmlformats.org/officeDocument/2006/relationships">
-  <p:cSld>
-    <p:bg>
-      <p:bgPr>
-        <a:solidFill>
-          <a:srgbClr val="0F172A"/>
-        </a:solidFill>
-        <a:effectLst/>
-      </p:bgPr>
-    </p:bg>
-    <p:spTree>
-      <p:nvGrpSpPr>
-        <p:cNvPr id="1" name=""/>
-        <p:cNvGrpSpPr/>
-        <p:nvPr/>
-      </p:nvGrpSpPr>
-      <p:grpSpPr/>
-      <p:sp>
-        <p:nvSpPr>
-          <p:cNvPr id="2" name="TextBox 1"/>
-          <p:cNvSpPr txBox="1"/>
-          <p:nvPr/>
-        </p:nvSpPr>
-        <p:spPr>
-          <a:xfrm>
-            <a:off x="548640" y="365760"/>
-            <a:ext cx="8046720" cy="731520"/>
-          </a:xfrm>
-          <a:prstGeom prst="rect">
-            <a:avLst/>
-          </a:prstGeom>
-          <a:noFill/>
-        </p:spPr>
-        <p:txBody>
-          <a:bodyPr wrap="square" tIns="91440" bIns="91440">
-            <a:spAutoFit/>
-          </a:bodyPr>
-          <a:lstStyle/>
-          <a:p>
-            <a:pPr>
-              <a:defRPr sz="2800" b="1">
-                <a:solidFill>
-                  <a:srgbClr val="38BDF8"/>
-                </a:solidFill>
-                <a:latin typeface="Calibri"/>
-              </a:defRPr>
-            </a:pPr>
-            <a:r>
-              <a:t>Conclusion &amp; Core Contributions</a:t>
-            </a:r>
-          </a:p>
-        </p:txBody>
-      </p:sp>
-      <p:sp>
-        <p:nvSpPr>
-          <p:cNvPr id="3" name="TextBox 2"/>
-          <p:cNvSpPr txBox="1"/>
-          <p:nvPr/>
-        </p:nvSpPr>
-        <p:spPr>
-          <a:xfrm>
-            <a:off x="548640" y="1280160"/>
-            <a:ext cx="8046720" cy="3474720"/>
-          </a:xfrm>
-          <a:prstGeom prst="rect">
-            <a:avLst/>
-          </a:prstGeom>
-          <a:noFill/>
-        </p:spPr>
-        <p:txBody>
-          <a:bodyPr wrap="square" tIns="91440" bIns="91440">
-            <a:spAutoFit/>
-          </a:bodyPr>
-          <a:lstStyle/>
-          <a:p>
-            <a:pPr>
-              <a:spcAft>
-                <a:spcPts val="1000"/>
-              </a:spcAft>
-            </a:pPr>
-            <a:r>
-              <a:rPr sz="1800" b="1">
-                <a:solidFill>
-                  <a:srgbClr val="F8FAFC"/>
-                </a:solidFill>
-                <a:latin typeface="Calibri"/>
-              </a:rPr>
-              <a:t>Side-Channel Vulnerability: </a:t>
-            </a:r>
-            <a:r>
-              <a:rPr sz="1800" b="0">
-                <a:solidFill>
-                  <a:srgbClr val="F8FAFC"/>
-                </a:solidFill>
-                <a:latin typeface="Calibri"/>
-              </a:rPr>
-              <a:t>Proved that zero-permission head sensors leak text, posing a severe side-channel danger in virtual environments.</a:t>
-            </a:r>
-          </a:p>
-          <a:p>
-            <a:pPr>
-              <a:spcAft>
-                <a:spcPts val="1000"/>
-              </a:spcAft>
-            </a:pPr>
-            <a:r>
-              <a:rPr sz="1800" b="1">
-                <a:solidFill>
-                  <a:srgbClr val="F8FAFC"/>
-                </a:solidFill>
-                <a:latin typeface="Calibri"/>
-              </a:rPr>
-              <a:t>CASOM Framework: </a:t>
-            </a:r>
-            <a:r>
-              <a:rPr sz="1800" b="0">
-                <a:solidFill>
-                  <a:srgbClr val="F8FAFC"/>
-                </a:solidFill>
-                <a:latin typeface="Calibri"/>
-              </a:rPr>
-              <a:t>Implemented and evaluated the Context-Aware Sensor Obfuscation Middleware (CASOM) inside a Python simulation environment.</a:t>
-            </a:r>
-          </a:p>
-          <a:p>
-            <a:pPr>
-              <a:spcAft>
-                <a:spcPts val="1000"/>
-              </a:spcAft>
-            </a:pPr>
-            <a:r>
-              <a:rPr sz="1800" b="1">
-                <a:solidFill>
-                  <a:srgbClr val="F8FAFC"/>
-                </a:solidFill>
-                <a:latin typeface="Calibri"/>
-              </a:rPr>
-              <a:t>Evaluation Honesty: </a:t>
-            </a:r>
-            <a:r>
-              <a:rPr sz="1800" b="0">
-                <a:solidFill>
-                  <a:srgbClr val="F8FAFC"/>
-                </a:solidFill>
-                <a:latin typeface="Calibri"/>
-              </a:rPr>
-              <a:t>Disproved simple countermeasures (IID Noise and Drift) by evaluating them against the real BackTree attack.</a:t>
-            </a:r>
-          </a:p>
-          <a:p>
-            <a:pPr>
-              <a:spcAft>
-                <a:spcPts val="1000"/>
-              </a:spcAft>
-            </a:pPr>
-            <a:r>
-              <a:rPr sz="1800" b="1">
-                <a:solidFill>
-                  <a:srgbClr val="10B981"/>
-                </a:solidFill>
-                <a:latin typeface="Calibri"/>
-              </a:rPr>
-              <a:t>Recommended Defense: </a:t>
-            </a:r>
-            <a:r>
-              <a:rPr sz="1800" b="0">
-                <a:solidFill>
-                  <a:srgbClr val="10B981"/>
-                </a:solidFill>
-                <a:latin typeface="Calibri"/>
-              </a:rPr>
-              <a:t>Validated Block Offset Laplace Noise as a robust, highly secure, and deployable countermeasure that collapses attack success to ~3.6% while preserving 100% foreground user experience.</a:t>
             </a:r>
           </a:p>
         </p:txBody>
@@ -3377,14 +3164,6 @@
 <file path=ppt/slides/slide2.xml><?xml version="1.0" encoding="utf-8"?>
 <p:sld xmlns:a="http://schemas.openxmlformats.org/drawingml/2006/main" xmlns:p="http://schemas.openxmlformats.org/presentationml/2006/main" xmlns:r="http://schemas.openxmlformats.org/officeDocument/2006/relationships">
   <p:cSld>
-    <p:bg>
-      <p:bgPr>
-        <a:solidFill>
-          <a:srgbClr val="0F172A"/>
-        </a:solidFill>
-        <a:effectLst/>
-      </p:bgPr>
-    </p:bg>
     <p:spTree>
       <p:nvGrpSpPr>
         <p:cNvPr id="1" name=""/>
@@ -3394,184 +3173,60 @@
       <p:grpSpPr/>
       <p:sp>
         <p:nvSpPr>
-          <p:cNvPr id="2" name="TextBox 1"/>
-          <p:cNvSpPr txBox="1"/>
-          <p:nvPr/>
-        </p:nvSpPr>
-        <p:spPr>
-          <a:xfrm>
-            <a:off x="548640" y="365760"/>
-            <a:ext cx="8046720" cy="731520"/>
-          </a:xfrm>
-          <a:prstGeom prst="rect">
-            <a:avLst/>
-          </a:prstGeom>
-          <a:noFill/>
-        </p:spPr>
-        <p:txBody>
-          <a:bodyPr wrap="square" tIns="91440" bIns="91440">
-            <a:spAutoFit/>
-          </a:bodyPr>
-          <a:lstStyle/>
-          <a:p>
-            <a:pPr>
-              <a:defRPr sz="2800" b="1">
-                <a:solidFill>
-                  <a:srgbClr val="38BDF8"/>
-                </a:solidFill>
-                <a:latin typeface="Calibri"/>
-              </a:defRPr>
-            </a:pPr>
-            <a:r>
-              <a:t>The Side-Channel Threat: SNOOPFINGER</a:t>
-            </a:r>
-          </a:p>
-        </p:txBody>
-      </p:sp>
-      <p:sp>
-        <p:nvSpPr>
-          <p:cNvPr id="3" name="TextBox 2"/>
-          <p:cNvSpPr txBox="1"/>
-          <p:nvPr/>
-        </p:nvSpPr>
-        <p:spPr>
-          <a:xfrm>
-            <a:off x="548640" y="1280160"/>
-            <a:ext cx="8046720" cy="3474720"/>
-          </a:xfrm>
-          <a:prstGeom prst="rect">
-            <a:avLst/>
-          </a:prstGeom>
-          <a:noFill/>
-        </p:spPr>
-        <p:txBody>
-          <a:bodyPr wrap="square" tIns="91440" bIns="91440">
-            <a:spAutoFit/>
-          </a:bodyPr>
-          <a:lstStyle/>
-          <a:p>
-            <a:pPr>
-              <a:spcAft>
-                <a:spcPts val="1000"/>
-              </a:spcAft>
-            </a:pPr>
-            <a:r>
-              <a:rPr sz="1800" b="1">
-                <a:solidFill>
-                  <a:srgbClr val="F8FAFC"/>
-                </a:solidFill>
-                <a:latin typeface="Calibri"/>
-              </a:rPr>
-              <a:t>Attack Definition: </a:t>
-            </a:r>
-            <a:r>
-              <a:rPr sz="1800" b="0">
-                <a:solidFill>
-                  <a:srgbClr val="F8FAFC"/>
-                </a:solidFill>
-                <a:latin typeface="Calibri"/>
-              </a:rPr>
-              <a:t>SNOOPFINGER is a cross-modality side-channel attack targeting head-mounted displays in VR/AR environments.</a:t>
-            </a:r>
-          </a:p>
-          <a:p>
-            <a:pPr>
-              <a:spcAft>
-                <a:spcPts val="1000"/>
-              </a:spcAft>
-            </a:pPr>
-            <a:r>
-              <a:rPr sz="1800" b="1">
-                <a:solidFill>
-                  <a:srgbClr val="F8FAFC"/>
-                </a:solidFill>
-                <a:latin typeface="Calibri"/>
-              </a:rPr>
-              <a:t>Vulnerability Surface: </a:t>
-            </a:r>
-            <a:r>
-              <a:rPr sz="1800" b="0">
-                <a:solidFill>
-                  <a:srgbClr val="F8FAFC"/>
-                </a:solidFill>
-                <a:latin typeface="Calibri"/>
-              </a:rPr>
-              <a:t>APIs treat head-movement orientation (quaternions) as zero-permission sensors, broadcasting it to all background threads.</a:t>
-            </a:r>
-          </a:p>
-          <a:p>
-            <a:pPr>
-              <a:spcAft>
-                <a:spcPts val="1000"/>
-              </a:spcAft>
-            </a:pPr>
-            <a:r>
-              <a:rPr sz="1800" b="1">
-                <a:solidFill>
-                  <a:srgbClr val="F8FAFC"/>
-                </a:solidFill>
-                <a:latin typeface="Calibri"/>
-              </a:rPr>
-              <a:t>Exploitation Vector: </a:t>
-            </a:r>
-            <a:r>
-              <a:rPr sz="1800" b="0">
-                <a:solidFill>
-                  <a:srgbClr val="F8FAFC"/>
-                </a:solidFill>
-                <a:latin typeface="Calibri"/>
-              </a:rPr>
-              <a:t>When users type on virtual keyboards, they make natural micro-pauses (dwell times) to visually target and confirm keys.</a:t>
-            </a:r>
-          </a:p>
-          <a:p>
-            <a:pPr>
-              <a:spcAft>
-                <a:spcPts val="1000"/>
-              </a:spcAft>
-            </a:pPr>
-            <a:r>
-              <a:rPr sz="1800" b="1">
-                <a:solidFill>
-                  <a:srgbClr val="F8FAFC"/>
-                </a:solidFill>
-                <a:latin typeface="Calibri"/>
-              </a:rPr>
-              <a:t>Mechanism: </a:t>
-            </a:r>
-            <a:r>
-              <a:rPr sz="1800" b="0">
-                <a:solidFill>
-                  <a:srgbClr val="F8FAFC"/>
-                </a:solidFill>
-                <a:latin typeface="Calibri"/>
-              </a:rPr>
-              <a:t>Background processes reconstruct typed text by converting 3D head rotation into 2D gaze points and clustering them temporally.</a:t>
-            </a:r>
-          </a:p>
-          <a:p>
-            <a:pPr>
-              <a:spcAft>
-                <a:spcPts val="1000"/>
-              </a:spcAft>
-            </a:pPr>
-            <a:r>
-              <a:rPr sz="1800" b="1">
-                <a:solidFill>
-                  <a:srgbClr val="F43F5E"/>
-                </a:solidFill>
-                <a:latin typeface="Calibri"/>
-              </a:rPr>
-              <a:t>Impact: </a:t>
-            </a:r>
-            <a:r>
-              <a:rPr sz="1800" b="0">
-                <a:solidFill>
-                  <a:srgbClr val="F43F5E"/>
-                </a:solidFill>
-                <a:latin typeface="Calibri"/>
-              </a:rPr>
-              <a:t>Requires no camera access or high privileges, allowing standard apps to steal passwords and pins.</a:t>
+          <p:cNvPr id="2" name="Title 1"/>
+          <p:cNvSpPr>
+            <a:spLocks noGrp="1"/>
+          </p:cNvSpPr>
+          <p:nvPr>
+            <p:ph type="title"/>
+          </p:nvPr>
+        </p:nvSpPr>
+        <p:spPr/>
+        <p:txBody>
+          <a:bodyPr/>
+          <a:lstStyle/>
+          <a:p>
+            <a:r>
+              <a:t>Introduction: SNOOPFINGER Attack</a:t>
+            </a:r>
+          </a:p>
+        </p:txBody>
+      </p:sp>
+      <p:sp>
+        <p:nvSpPr>
+          <p:cNvPr id="3" name="Content Placeholder 2"/>
+          <p:cNvSpPr>
+            <a:spLocks noGrp="1"/>
+          </p:cNvSpPr>
+          <p:nvPr>
+            <p:ph idx="1"/>
+          </p:nvPr>
+        </p:nvSpPr>
+        <p:spPr/>
+        <p:txBody>
+          <a:bodyPr/>
+          <a:lstStyle/>
+          <a:p>
+            <a:r>
+              <a:t>What is SNOOPFINGER?</a:t>
+            </a:r>
+          </a:p>
+          <a:p>
+            <a:pPr lvl="1"/>
+            <a:r>
+              <a:t>A novel cross-modality side-channel attack in AR/VR systems.</a:t>
+            </a:r>
+          </a:p>
+          <a:p>
+            <a:pPr lvl="1"/>
+            <a:r>
+              <a:t>Exploits head movement data (which requires zero permissions) to infer hand-based typing on virtual keyboards.</a:t>
+            </a:r>
+          </a:p>
+          <a:p>
+            <a:pPr lvl="1"/>
+            <a:r>
+              <a:t>Adversaries can deduce typed words by translating 3D head orientation into 2D gaze points.</a:t>
             </a:r>
           </a:p>
         </p:txBody>
@@ -3587,14 +3242,6 @@
 <file path=ppt/slides/slide3.xml><?xml version="1.0" encoding="utf-8"?>
 <p:sld xmlns:a="http://schemas.openxmlformats.org/drawingml/2006/main" xmlns:p="http://schemas.openxmlformats.org/presentationml/2006/main" xmlns:r="http://schemas.openxmlformats.org/officeDocument/2006/relationships">
   <p:cSld>
-    <p:bg>
-      <p:bgPr>
-        <a:solidFill>
-          <a:srgbClr val="0F172A"/>
-        </a:solidFill>
-        <a:effectLst/>
-      </p:bgPr>
-    </p:bg>
     <p:spTree>
       <p:nvGrpSpPr>
         <p:cNvPr id="1" name=""/>
@@ -3604,157 +3251,28 @@
       <p:grpSpPr/>
       <p:sp>
         <p:nvSpPr>
-          <p:cNvPr id="2" name="TextBox 1"/>
-          <p:cNvSpPr txBox="1"/>
-          <p:nvPr/>
-        </p:nvSpPr>
-        <p:spPr>
-          <a:xfrm>
-            <a:off x="548640" y="365760"/>
-            <a:ext cx="8046720" cy="731520"/>
-          </a:xfrm>
-          <a:prstGeom prst="rect">
-            <a:avLst/>
-          </a:prstGeom>
-          <a:noFill/>
-        </p:spPr>
-        <p:txBody>
-          <a:bodyPr wrap="square" tIns="91440" bIns="91440">
-            <a:spAutoFit/>
-          </a:bodyPr>
-          <a:lstStyle/>
-          <a:p>
-            <a:pPr>
-              <a:defRPr sz="2800" b="1">
-                <a:solidFill>
-                  <a:srgbClr val="38BDF8"/>
-                </a:solidFill>
-                <a:latin typeface="Calibri"/>
-              </a:defRPr>
-            </a:pPr>
-            <a:r>
-              <a:t>Mathematical Modeling: 3D to 2D Gaze Projection</a:t>
-            </a:r>
-          </a:p>
-        </p:txBody>
-      </p:sp>
-      <p:sp>
-        <p:nvSpPr>
-          <p:cNvPr id="3" name="TextBox 2"/>
-          <p:cNvSpPr txBox="1"/>
-          <p:nvPr/>
-        </p:nvSpPr>
-        <p:spPr>
-          <a:xfrm>
-            <a:off x="548640" y="1188720"/>
-            <a:ext cx="4114800" cy="3566160"/>
-          </a:xfrm>
-          <a:prstGeom prst="rect">
-            <a:avLst/>
-          </a:prstGeom>
-          <a:noFill/>
-        </p:spPr>
-        <p:txBody>
-          <a:bodyPr wrap="square" tIns="91440" bIns="91440">
-            <a:spAutoFit/>
-          </a:bodyPr>
-          <a:lstStyle/>
-          <a:p>
-            <a:pPr>
-              <a:spcAft>
-                <a:spcPts val="1000"/>
-              </a:spcAft>
-            </a:pPr>
-            <a:r>
-              <a:rPr sz="1600" b="1">
-                <a:solidFill>
-                  <a:srgbClr val="F8FAFC"/>
-                </a:solidFill>
-                <a:latin typeface="Calibri"/>
-              </a:rPr>
-              <a:t>Coordinate Conversion: </a:t>
-            </a:r>
-            <a:r>
-              <a:rPr sz="1600" b="0">
-                <a:solidFill>
-                  <a:srgbClr val="F8FAFC"/>
-                </a:solidFill>
-                <a:latin typeface="Calibri"/>
-              </a:rPr>
-              <a:t>Converts raw headset orientation tracking (w, x, y, z) into Euler angles (Pitch and Yaw) to estimate looking directions.</a:t>
-            </a:r>
-          </a:p>
-          <a:p>
-            <a:pPr>
-              <a:spcAft>
-                <a:spcPts val="1000"/>
-              </a:spcAft>
-            </a:pPr>
-            <a:r>
-              <a:rPr sz="1600" b="1">
-                <a:solidFill>
-                  <a:srgbClr val="F8FAFC"/>
-                </a:solidFill>
-                <a:latin typeface="Calibri"/>
-              </a:rPr>
-              <a:t>2D Projection: </a:t>
-            </a:r>
-            <a:r>
-              <a:rPr sz="1600" b="0">
-                <a:solidFill>
-                  <a:srgbClr val="F8FAFC"/>
-                </a:solidFill>
-                <a:latin typeface="Calibri"/>
-              </a:rPr>
-              <a:t>Maps the 3D gaze vector onto the 2D plane of the virtual keyboard via an equirectangular coordinate projection.</a:t>
-            </a:r>
-          </a:p>
-          <a:p>
-            <a:pPr>
-              <a:spcAft>
-                <a:spcPts val="1000"/>
-              </a:spcAft>
-            </a:pPr>
-            <a:r>
-              <a:rPr sz="1600" b="1">
-                <a:solidFill>
-                  <a:srgbClr val="F8FAFC"/>
-                </a:solidFill>
-                <a:latin typeface="Calibri"/>
-              </a:rPr>
-              <a:t>Tremor Simulation: </a:t>
-            </a:r>
-            <a:r>
-              <a:rPr sz="1600" b="0">
-                <a:solidFill>
-                  <a:srgbClr val="F8FAFC"/>
-                </a:solidFill>
-                <a:latin typeface="Calibri"/>
-              </a:rPr>
-              <a:t>Models natural gaze jitter using Gaussian distribution centered at key targets:</a:t>
-            </a:r>
-          </a:p>
-          <a:p>
-            <a:pPr lvl="1">
-              <a:spcAft>
-                <a:spcPts val="1000"/>
-              </a:spcAft>
-            </a:pPr>
-            <a:r>
-              <a:rPr sz="1500" b="0">
-                <a:solidFill>
-                  <a:srgbClr val="F8FAFC"/>
-                </a:solidFill>
-                <a:latin typeface="Calibri"/>
-              </a:rPr>
-              <a:t>x ~ N(x_key, sigma^2), where sigma = 0.03 cm represents human target tremor.</a:t>
+          <p:cNvPr id="2" name="Title 1"/>
+          <p:cNvSpPr>
+            <a:spLocks noGrp="1"/>
+          </p:cNvSpPr>
+          <p:nvPr>
+            <p:ph type="title"/>
+          </p:nvPr>
+        </p:nvSpPr>
+        <p:spPr/>
+        <p:txBody>
+          <a:bodyPr/>
+          <a:lstStyle/>
+          <a:p>
+            <a:r>
+              <a:t>Understanding the Attack: Mathematical Background</a:t>
             </a:r>
           </a:p>
         </p:txBody>
       </p:sp>
       <p:pic>
         <p:nvPicPr>
-          <p:cNvPr id="4" name="Picture 3" descr="math_pitch.png"/>
+          <p:cNvPr id="3" name="Picture 2" descr="eq1.png"/>
           <p:cNvPicPr>
             <a:picLocks noChangeAspect="1"/>
           </p:cNvPicPr>
@@ -3768,8 +3286,8 @@
         </p:blipFill>
         <p:spPr>
           <a:xfrm>
-            <a:off x="4846320" y="1645920"/>
-            <a:ext cx="3749039" cy="868334"/>
+            <a:off x="914400" y="1828800"/>
+            <a:ext cx="2743200" cy="806335"/>
           </a:xfrm>
           <a:prstGeom prst="rect">
             <a:avLst/>
@@ -3778,7 +3296,7 @@
       </p:pic>
       <p:pic>
         <p:nvPicPr>
-          <p:cNvPr id="5" name="Picture 4" descr="math_yaw.png"/>
+          <p:cNvPr id="4" name="Picture 3" descr="eq2.png"/>
           <p:cNvPicPr>
             <a:picLocks noChangeAspect="1"/>
           </p:cNvPicPr>
@@ -3792,8 +3310,538 @@
         </p:blipFill>
         <p:spPr>
           <a:xfrm>
-            <a:off x="4846320" y="2926080"/>
-            <a:ext cx="3749039" cy="868334"/>
+            <a:off x="914400" y="3200400"/>
+            <a:ext cx="2743200" cy="806335"/>
+          </a:xfrm>
+          <a:prstGeom prst="rect">
+            <a:avLst/>
+          </a:prstGeom>
+        </p:spPr>
+      </p:pic>
+      <p:pic>
+        <p:nvPicPr>
+          <p:cNvPr id="5" name="Picture 4" descr="eq3.png"/>
+          <p:cNvPicPr>
+            <a:picLocks noChangeAspect="1"/>
+          </p:cNvPicPr>
+          <p:nvPr/>
+        </p:nvPicPr>
+        <p:blipFill>
+          <a:blip r:embed="rId4"/>
+          <a:stretch>
+            <a:fillRect/>
+          </a:stretch>
+        </p:blipFill>
+        <p:spPr>
+          <a:xfrm>
+            <a:off x="914400" y="4572000"/>
+            <a:ext cx="2743200" cy="806335"/>
+          </a:xfrm>
+          <a:prstGeom prst="rect">
+            <a:avLst/>
+          </a:prstGeom>
+        </p:spPr>
+      </p:pic>
+      <p:sp>
+        <p:nvSpPr>
+          <p:cNvPr id="6" name="TextBox 5"/>
+          <p:cNvSpPr txBox="1"/>
+          <p:nvPr/>
+        </p:nvSpPr>
+        <p:spPr>
+          <a:xfrm>
+            <a:off x="4572000" y="1828800"/>
+            <a:ext cx="3657600" cy="2743200"/>
+          </a:xfrm>
+          <a:prstGeom prst="rect">
+            <a:avLst/>
+          </a:prstGeom>
+          <a:noFill/>
+        </p:spPr>
+        <p:txBody>
+          <a:bodyPr wrap="none">
+            <a:spAutoFit/>
+          </a:bodyPr>
+          <a:lstStyle/>
+          <a:p>
+            <a:r>
+              <a:t>Conversion from Quaternions to Euler Angles</a:t>
+            </a:r>
+          </a:p>
+          <a:p>
+            <a:pPr lvl="1"/>
+            <a:r>
+              <a:t>The attack relies on converting the headset's quaternion orientation (w, x, y, z) into Euler angles (Roll, Pitch, Yaw) to estimate gaze direction.</a:t>
+            </a:r>
+          </a:p>
+        </p:txBody>
+      </p:sp>
+    </p:spTree>
+  </p:cSld>
+  <p:clrMapOvr>
+    <a:masterClrMapping/>
+  </p:clrMapOvr>
+</p:sld>
+</file>
+
+<file path=ppt/slides/slide4.xml><?xml version="1.0" encoding="utf-8"?>
+<p:sld xmlns:a="http://schemas.openxmlformats.org/drawingml/2006/main" xmlns:p="http://schemas.openxmlformats.org/presentationml/2006/main" xmlns:r="http://schemas.openxmlformats.org/officeDocument/2006/relationships">
+  <p:cSld>
+    <p:spTree>
+      <p:nvGrpSpPr>
+        <p:cNvPr id="1" name=""/>
+        <p:cNvGrpSpPr/>
+        <p:nvPr/>
+      </p:nvGrpSpPr>
+      <p:grpSpPr/>
+      <p:sp>
+        <p:nvSpPr>
+          <p:cNvPr id="2" name="Title 1"/>
+          <p:cNvSpPr>
+            <a:spLocks noGrp="1"/>
+          </p:cNvSpPr>
+          <p:nvPr>
+            <p:ph type="title"/>
+          </p:nvPr>
+        </p:nvSpPr>
+        <p:spPr/>
+        <p:txBody>
+          <a:bodyPr/>
+          <a:lstStyle/>
+          <a:p>
+            <a:r>
+              <a:t>3D Gaze Direction to 2D Points</a:t>
+            </a:r>
+          </a:p>
+        </p:txBody>
+      </p:sp>
+      <p:pic>
+        <p:nvPicPr>
+          <p:cNvPr id="3" name="Picture 2" descr="eq4.png"/>
+          <p:cNvPicPr>
+            <a:picLocks noChangeAspect="1"/>
+          </p:cNvPicPr>
+          <p:nvPr/>
+        </p:nvPicPr>
+        <p:blipFill>
+          <a:blip r:embed="rId2"/>
+          <a:stretch>
+            <a:fillRect/>
+          </a:stretch>
+        </p:blipFill>
+        <p:spPr>
+          <a:xfrm>
+            <a:off x="914400" y="1828800"/>
+            <a:ext cx="2743200" cy="806335"/>
+          </a:xfrm>
+          <a:prstGeom prst="rect">
+            <a:avLst/>
+          </a:prstGeom>
+        </p:spPr>
+      </p:pic>
+      <p:pic>
+        <p:nvPicPr>
+          <p:cNvPr id="4" name="Picture 3" descr="eq5.png"/>
+          <p:cNvPicPr>
+            <a:picLocks noChangeAspect="1"/>
+          </p:cNvPicPr>
+          <p:nvPr/>
+        </p:nvPicPr>
+        <p:blipFill>
+          <a:blip r:embed="rId3"/>
+          <a:stretch>
+            <a:fillRect/>
+          </a:stretch>
+        </p:blipFill>
+        <p:spPr>
+          <a:xfrm>
+            <a:off x="914400" y="3200400"/>
+            <a:ext cx="2743200" cy="806335"/>
+          </a:xfrm>
+          <a:prstGeom prst="rect">
+            <a:avLst/>
+          </a:prstGeom>
+        </p:spPr>
+      </p:pic>
+      <p:pic>
+        <p:nvPicPr>
+          <p:cNvPr id="5" name="Picture 4" descr="eq6.png"/>
+          <p:cNvPicPr>
+            <a:picLocks noChangeAspect="1"/>
+          </p:cNvPicPr>
+          <p:nvPr/>
+        </p:nvPicPr>
+        <p:blipFill>
+          <a:blip r:embed="rId4"/>
+          <a:stretch>
+            <a:fillRect/>
+          </a:stretch>
+        </p:blipFill>
+        <p:spPr>
+          <a:xfrm>
+            <a:off x="914400" y="4572000"/>
+            <a:ext cx="2743200" cy="806335"/>
+          </a:xfrm>
+          <a:prstGeom prst="rect">
+            <a:avLst/>
+          </a:prstGeom>
+        </p:spPr>
+      </p:pic>
+      <p:sp>
+        <p:nvSpPr>
+          <p:cNvPr id="6" name="TextBox 5"/>
+          <p:cNvSpPr txBox="1"/>
+          <p:nvPr/>
+        </p:nvSpPr>
+        <p:spPr>
+          <a:xfrm>
+            <a:off x="4572000" y="1828800"/>
+            <a:ext cx="3657600" cy="2743200"/>
+          </a:xfrm>
+          <a:prstGeom prst="rect">
+            <a:avLst/>
+          </a:prstGeom>
+          <a:noFill/>
+        </p:spPr>
+        <p:txBody>
+          <a:bodyPr wrap="none">
+            <a:spAutoFit/>
+          </a:bodyPr>
+          <a:lstStyle/>
+          <a:p>
+            <a:r>
+              <a:t>Equirectangular Projection</a:t>
+            </a:r>
+          </a:p>
+          <a:p>
+            <a:pPr lvl="1"/>
+            <a:r>
+              <a:t>3D gaze directions are mapped onto a 2D plane (the virtual keyboard) to estimate which keys the user is looking at while typing.</a:t>
+            </a:r>
+          </a:p>
+        </p:txBody>
+      </p:sp>
+    </p:spTree>
+  </p:cSld>
+  <p:clrMapOvr>
+    <a:masterClrMapping/>
+  </p:clrMapOvr>
+</p:sld>
+</file>
+
+<file path=ppt/slides/slide5.xml><?xml version="1.0" encoding="utf-8"?>
+<p:sld xmlns:a="http://schemas.openxmlformats.org/drawingml/2006/main" xmlns:p="http://schemas.openxmlformats.org/presentationml/2006/main" xmlns:r="http://schemas.openxmlformats.org/officeDocument/2006/relationships">
+  <p:cSld>
+    <p:spTree>
+      <p:nvGrpSpPr>
+        <p:cNvPr id="1" name=""/>
+        <p:cNvGrpSpPr/>
+        <p:nvPr/>
+      </p:nvGrpSpPr>
+      <p:grpSpPr/>
+      <p:sp>
+        <p:nvSpPr>
+          <p:cNvPr id="2" name="Title 1"/>
+          <p:cNvSpPr>
+            <a:spLocks noGrp="1"/>
+          </p:cNvSpPr>
+          <p:nvPr>
+            <p:ph type="title"/>
+          </p:nvPr>
+        </p:nvSpPr>
+        <p:spPr/>
+        <p:txBody>
+          <a:bodyPr/>
+          <a:lstStyle/>
+          <a:p>
+            <a:r>
+              <a:t>Identified Gaps &amp; Limitations</a:t>
+            </a:r>
+          </a:p>
+        </p:txBody>
+      </p:sp>
+      <p:sp>
+        <p:nvSpPr>
+          <p:cNvPr id="3" name="Content Placeholder 2"/>
+          <p:cNvSpPr>
+            <a:spLocks noGrp="1"/>
+          </p:cNvSpPr>
+          <p:nvPr>
+            <p:ph idx="1"/>
+          </p:nvPr>
+        </p:nvSpPr>
+        <p:spPr/>
+        <p:txBody>
+          <a:bodyPr/>
+          <a:lstStyle/>
+          <a:p>
+            <a:r>
+              <a:t>Limitations of SNOOPFINGER Attack Model:</a:t>
+            </a:r>
+          </a:p>
+          <a:p>
+            <a:pPr lvl="1"/>
+            <a:r>
+              <a:t>User Deviation Gestures (Gap 1): Extraneous head movements (nods, shakes, circles) cannot be detected by the attacker and serve as an effective bypass.</a:t>
+            </a:r>
+          </a:p>
+          <a:p>
+            <a:pPr lvl="1"/>
+            <a:r>
+              <a:t>External Sensor Tampering (Gap 2): Physical travel vibrations (walking, moving vehicle) or hardware tampering inject noise that cannot be separated from typing.</a:t>
+            </a:r>
+          </a:p>
+          <a:p>
+            <a:pPr lvl="1"/>
+            <a:r>
+              <a:t>Gaps in Mitigation:</a:t>
+            </a:r>
+          </a:p>
+          <a:p>
+            <a:pPr lvl="2"/>
+            <a:r>
+              <a:t>The paper proposes theoretical countermeasures (e.g., Adaptive Sensor Data Obfuscation) but provides no practical implementation or architectural blueprint.</a:t>
+            </a:r>
+          </a:p>
+        </p:txBody>
+      </p:sp>
+    </p:spTree>
+  </p:cSld>
+  <p:clrMapOvr>
+    <a:masterClrMapping/>
+  </p:clrMapOvr>
+</p:sld>
+</file>
+
+<file path=ppt/slides/slide6.xml><?xml version="1.0" encoding="utf-8"?>
+<p:sld xmlns:a="http://schemas.openxmlformats.org/drawingml/2006/main" xmlns:p="http://schemas.openxmlformats.org/presentationml/2006/main" xmlns:r="http://schemas.openxmlformats.org/officeDocument/2006/relationships">
+  <p:cSld>
+    <p:spTree>
+      <p:nvGrpSpPr>
+        <p:cNvPr id="1" name=""/>
+        <p:cNvGrpSpPr/>
+        <p:nvPr/>
+      </p:nvGrpSpPr>
+      <p:grpSpPr/>
+      <p:sp>
+        <p:nvSpPr>
+          <p:cNvPr id="2" name="Title 1"/>
+          <p:cNvSpPr>
+            <a:spLocks noGrp="1"/>
+          </p:cNvSpPr>
+          <p:nvPr>
+            <p:ph type="title"/>
+          </p:nvPr>
+        </p:nvSpPr>
+        <p:spPr/>
+        <p:txBody>
+          <a:bodyPr/>
+          <a:lstStyle/>
+          <a:p>
+            <a:r>
+              <a:t>Our Solution: CASOM Middleware</a:t>
+            </a:r>
+          </a:p>
+        </p:txBody>
+      </p:sp>
+      <p:sp>
+        <p:nvSpPr>
+          <p:cNvPr id="3" name="Content Placeholder 2"/>
+          <p:cNvSpPr>
+            <a:spLocks noGrp="1"/>
+          </p:cNvSpPr>
+          <p:nvPr>
+            <p:ph idx="1"/>
+          </p:nvPr>
+        </p:nvSpPr>
+        <p:spPr/>
+        <p:txBody>
+          <a:bodyPr/>
+          <a:lstStyle/>
+          <a:p>
+            <a:r>
+              <a:t>Context-Aware Sensor Obfuscation Middleware (CASOM)</a:t>
+            </a:r>
+          </a:p>
+          <a:p>
+            <a:pPr lvl="1"/>
+            <a:r>
+              <a:t>Architecture:</a:t>
+            </a:r>
+          </a:p>
+          <a:p>
+            <a:pPr lvl="2"/>
+            <a:r>
+              <a:t>Sits between the AR/VR OS Sensor Manager and Background Apps.</a:t>
+            </a:r>
+          </a:p>
+          <a:p>
+            <a:pPr lvl="2"/>
+            <a:r>
+              <a:t>Monitors sensor data to detect when a user is typing (using movement thresholding).</a:t>
+            </a:r>
+          </a:p>
+          <a:p>
+            <a:pPr lvl="1"/>
+            <a:r>
+              <a:t>Operation:</a:t>
+            </a:r>
+          </a:p>
+          <a:p>
+            <a:pPr lvl="2"/>
+            <a:r>
+              <a:t>If typing is NOT detected, passes raw data.</a:t>
+            </a:r>
+          </a:p>
+          <a:p>
+            <a:pPr lvl="2"/>
+            <a:r>
+              <a:t>If typing IS detected, injects Laplacian Noise into the data sent to background applications.</a:t>
+            </a:r>
+          </a:p>
+        </p:txBody>
+      </p:sp>
+    </p:spTree>
+  </p:cSld>
+  <p:clrMapOvr>
+    <a:masterClrMapping/>
+  </p:clrMapOvr>
+</p:sld>
+</file>
+
+<file path=ppt/slides/slide7.xml><?xml version="1.0" encoding="utf-8"?>
+<p:sld xmlns:a="http://schemas.openxmlformats.org/drawingml/2006/main" xmlns:p="http://schemas.openxmlformats.org/presentationml/2006/main" xmlns:r="http://schemas.openxmlformats.org/officeDocument/2006/relationships">
+  <p:cSld>
+    <p:spTree>
+      <p:nvGrpSpPr>
+        <p:cNvPr id="1" name=""/>
+        <p:cNvGrpSpPr/>
+        <p:nvPr/>
+      </p:nvGrpSpPr>
+      <p:grpSpPr/>
+      <p:sp>
+        <p:nvSpPr>
+          <p:cNvPr id="2" name="Title 1"/>
+          <p:cNvSpPr>
+            <a:spLocks noGrp="1"/>
+          </p:cNvSpPr>
+          <p:nvPr>
+            <p:ph type="title"/>
+          </p:nvPr>
+        </p:nvSpPr>
+        <p:spPr/>
+        <p:txBody>
+          <a:bodyPr/>
+          <a:lstStyle/>
+          <a:p>
+            <a:r>
+              <a:t>Implementation details</a:t>
+            </a:r>
+          </a:p>
+        </p:txBody>
+      </p:sp>
+      <p:sp>
+        <p:nvSpPr>
+          <p:cNvPr id="3" name="Content Placeholder 2"/>
+          <p:cNvSpPr>
+            <a:spLocks noGrp="1"/>
+          </p:cNvSpPr>
+          <p:nvPr>
+            <p:ph idx="1"/>
+          </p:nvPr>
+        </p:nvSpPr>
+        <p:spPr/>
+        <p:txBody>
+          <a:bodyPr/>
+          <a:lstStyle/>
+          <a:p>
+            <a:r>
+              <a:t>We built a complete Python Simulation:</a:t>
+            </a:r>
+          </a:p>
+          <a:p>
+            <a:pPr lvl="1"/>
+            <a:r>
+              <a:t>generator.py: Simulates human gaze points targeting specific keys with natural micro-variances.</a:t>
+            </a:r>
+          </a:p>
+          <a:p>
+            <a:pPr lvl="1"/>
+            <a:r>
+              <a:t>attacker.py: Simulates SNOOPFINGER by clustering temporal gaze points to infer the typed word.</a:t>
+            </a:r>
+          </a:p>
+          <a:p>
+            <a:pPr lvl="1"/>
+            <a:r>
+              <a:t>defender.py: The CASOM Middleware that intercepts data and applies dynamic Laplacian noise (scale = 1.5).</a:t>
+            </a:r>
+          </a:p>
+          <a:p>
+            <a:pPr lvl="1"/>
+            <a:r>
+              <a:t>main.py: Orchestrates the attack both WITH and WITHOUT the defense, providing visualizations.</a:t>
+            </a:r>
+          </a:p>
+        </p:txBody>
+      </p:sp>
+    </p:spTree>
+  </p:cSld>
+  <p:clrMapOvr>
+    <a:masterClrMapping/>
+  </p:clrMapOvr>
+</p:sld>
+</file>
+
+<file path=ppt/slides/slide8.xml><?xml version="1.0" encoding="utf-8"?>
+<p:sld xmlns:a="http://schemas.openxmlformats.org/drawingml/2006/main" xmlns:p="http://schemas.openxmlformats.org/presentationml/2006/main" xmlns:r="http://schemas.openxmlformats.org/officeDocument/2006/relationships">
+  <p:cSld>
+    <p:spTree>
+      <p:nvGrpSpPr>
+        <p:cNvPr id="1" name=""/>
+        <p:cNvGrpSpPr/>
+        <p:nvPr/>
+      </p:nvGrpSpPr>
+      <p:grpSpPr/>
+      <p:sp>
+        <p:nvSpPr>
+          <p:cNvPr id="2" name="Title 1"/>
+          <p:cNvSpPr>
+            <a:spLocks noGrp="1"/>
+          </p:cNvSpPr>
+          <p:nvPr>
+            <p:ph type="title"/>
+          </p:nvPr>
+        </p:nvSpPr>
+        <p:spPr/>
+        <p:txBody>
+          <a:bodyPr/>
+          <a:lstStyle/>
+          <a:p>
+            <a:r>
+              <a:t>Results &amp; Validation</a:t>
+            </a:r>
+          </a:p>
+        </p:txBody>
+      </p:sp>
+      <p:pic>
+        <p:nvPicPr>
+          <p:cNvPr id="3" name="Picture 2" descr="simulation_result.png"/>
+          <p:cNvPicPr>
+            <a:picLocks noChangeAspect="1"/>
+          </p:cNvPicPr>
+          <p:nvPr/>
+        </p:nvPicPr>
+        <p:blipFill>
+          <a:blip r:embed="rId2"/>
+          <a:stretch>
+            <a:fillRect/>
+          </a:stretch>
+        </p:blipFill>
+        <p:spPr>
+          <a:xfrm>
+            <a:off x="457200" y="1371600"/>
+            <a:ext cx="8229600" cy="3526971"/>
           </a:xfrm>
           <a:prstGeom prst="rect">
             <a:avLst/>
@@ -3808,17 +3856,9 @@
 </p:sld>
 </file>
 
-<file path=ppt/slides/slide4.xml><?xml version="1.0" encoding="utf-8"?>
+<file path=ppt/slides/slide9.xml><?xml version="1.0" encoding="utf-8"?>
 <p:sld xmlns:a="http://schemas.openxmlformats.org/drawingml/2006/main" xmlns:p="http://schemas.openxmlformats.org/presentationml/2006/main" xmlns:r="http://schemas.openxmlformats.org/officeDocument/2006/relationships">
   <p:cSld>
-    <p:bg>
-      <p:bgPr>
-        <a:solidFill>
-          <a:srgbClr val="0F172A"/>
-        </a:solidFill>
-        <a:effectLst/>
-      </p:bgPr>
-    </p:bg>
     <p:spTree>
       <p:nvGrpSpPr>
         <p:cNvPr id="1" name=""/>
@@ -3828,1874 +3868,70 @@
       <p:grpSpPr/>
       <p:sp>
         <p:nvSpPr>
-          <p:cNvPr id="2" name="TextBox 1"/>
-          <p:cNvSpPr txBox="1"/>
-          <p:nvPr/>
-        </p:nvSpPr>
-        <p:spPr>
-          <a:xfrm>
-            <a:off x="548640" y="365760"/>
-            <a:ext cx="8046720" cy="731520"/>
-          </a:xfrm>
-          <a:prstGeom prst="rect">
-            <a:avLst/>
-          </a:prstGeom>
-          <a:noFill/>
-        </p:spPr>
-        <p:txBody>
-          <a:bodyPr wrap="square" tIns="91440" bIns="91440">
-            <a:spAutoFit/>
-          </a:bodyPr>
-          <a:lstStyle/>
-          <a:p>
-            <a:pPr>
-              <a:defRPr sz="2800" b="1">
-                <a:solidFill>
-                  <a:srgbClr val="38BDF8"/>
-                </a:solidFill>
-                <a:latin typeface="Calibri"/>
-              </a:defRPr>
-            </a:pPr>
-            <a:r>
-              <a:t>Identified Gaps &amp; Defense Limitations</a:t>
-            </a:r>
-          </a:p>
-        </p:txBody>
-      </p:sp>
-      <p:sp>
-        <p:nvSpPr>
-          <p:cNvPr id="3" name="TextBox 2"/>
-          <p:cNvSpPr txBox="1"/>
-          <p:nvPr/>
-        </p:nvSpPr>
-        <p:spPr>
-          <a:xfrm>
-            <a:off x="548640" y="1280160"/>
-            <a:ext cx="8046720" cy="3474720"/>
-          </a:xfrm>
-          <a:prstGeom prst="rect">
-            <a:avLst/>
-          </a:prstGeom>
-          <a:noFill/>
-        </p:spPr>
-        <p:txBody>
-          <a:bodyPr wrap="square" tIns="91440" bIns="91440">
-            <a:spAutoFit/>
-          </a:bodyPr>
-          <a:lstStyle/>
-          <a:p>
-            <a:pPr>
-              <a:spcAft>
-                <a:spcPts val="1000"/>
-              </a:spcAft>
-            </a:pPr>
-            <a:r>
-              <a:rPr sz="1800" b="1">
-                <a:solidFill>
-                  <a:srgbClr val="F8FAFC"/>
-                </a:solidFill>
-                <a:latin typeface="Calibri"/>
-              </a:rPr>
-              <a:t>Abstract Proposal Gap: </a:t>
-            </a:r>
-            <a:r>
-              <a:rPr sz="1800" b="0">
-                <a:solidFill>
-                  <a:srgbClr val="F8FAFC"/>
-                </a:solidFill>
-                <a:latin typeface="Calibri"/>
-              </a:rPr>
-              <a:t>The SNOOPFINGER IEEE paper discusses countermeasures (e.g. Obfuscation) but provides no implementation code or API design.</a:t>
-            </a:r>
-          </a:p>
-          <a:p>
-            <a:pPr>
-              <a:spcAft>
-                <a:spcPts val="1000"/>
-              </a:spcAft>
-            </a:pPr>
-            <a:r>
-              <a:rPr sz="1800" b="1">
-                <a:solidFill>
-                  <a:srgbClr val="F8FAFC"/>
-                </a:solidFill>
-                <a:latin typeface="Calibri"/>
-              </a:rPr>
-              <a:t>Utility Degradation: </a:t>
-            </a:r>
-            <a:r>
-              <a:rPr sz="1800" b="0">
-                <a:solidFill>
-                  <a:srgbClr val="F8FAFC"/>
-                </a:solidFill>
-                <a:latin typeface="Calibri"/>
-              </a:rPr>
-              <a:t>Adding simple independent random noise per frame degrades coordinate utility for background games/apps without stopping attackers.</a:t>
-            </a:r>
-          </a:p>
-          <a:p>
-            <a:pPr>
-              <a:spcAft>
-                <a:spcPts val="1000"/>
-              </a:spcAft>
-            </a:pPr>
-            <a:r>
-              <a:rPr sz="1800" b="1">
-                <a:solidFill>
-                  <a:srgbClr val="F8FAFC"/>
-                </a:solidFill>
-                <a:latin typeface="Calibri"/>
-              </a:rPr>
-              <a:t>Evaluation Deficit: </a:t>
-            </a:r>
-            <a:r>
-              <a:rPr sz="1800" b="0">
-                <a:solidFill>
-                  <a:srgbClr val="F8FAFC"/>
-                </a:solidFill>
-                <a:latin typeface="Calibri"/>
-              </a:rPr>
-              <a:t>The paper assumes simple attackers. It does not evaluate defenses against adaptive adversaries or geometric attacks like BackTree.</a:t>
-            </a:r>
-          </a:p>
-          <a:p>
-            <a:pPr>
-              <a:spcAft>
-                <a:spcPts val="1000"/>
-              </a:spcAft>
-            </a:pPr>
-            <a:r>
-              <a:rPr sz="1800" b="1">
-                <a:solidFill>
-                  <a:srgbClr val="F43F5E"/>
-                </a:solidFill>
-                <a:latin typeface="Calibri"/>
-              </a:rPr>
-              <a:t>Usability Conflict: </a:t>
-            </a:r>
-            <a:r>
-              <a:rPr sz="1800" b="0">
-                <a:solidFill>
-                  <a:srgbClr val="F43F5E"/>
-                </a:solidFill>
-                <a:latin typeface="Calibri"/>
-              </a:rPr>
-              <a:t>Virtual keyboard typing detection must be context-aware; static noise injection would break normal AR/VR head tracking gestures.</a:t>
-            </a:r>
-          </a:p>
-        </p:txBody>
-      </p:sp>
-    </p:spTree>
-  </p:cSld>
-  <p:clrMapOvr>
-    <a:masterClrMapping/>
-  </p:clrMapOvr>
-</p:sld>
-</file>
-
-<file path=ppt/slides/slide5.xml><?xml version="1.0" encoding="utf-8"?>
-<p:sld xmlns:a="http://schemas.openxmlformats.org/drawingml/2006/main" xmlns:p="http://schemas.openxmlformats.org/presentationml/2006/main" xmlns:r="http://schemas.openxmlformats.org/officeDocument/2006/relationships">
-  <p:cSld>
-    <p:bg>
-      <p:bgPr>
-        <a:solidFill>
-          <a:srgbClr val="0F172A"/>
-        </a:solidFill>
-        <a:effectLst/>
-      </p:bgPr>
-    </p:bg>
-    <p:spTree>
-      <p:nvGrpSpPr>
-        <p:cNvPr id="1" name=""/>
-        <p:cNvGrpSpPr/>
-        <p:nvPr/>
-      </p:nvGrpSpPr>
-      <p:grpSpPr/>
-      <p:sp>
-        <p:nvSpPr>
-          <p:cNvPr id="2" name="TextBox 1"/>
-          <p:cNvSpPr txBox="1"/>
-          <p:nvPr/>
-        </p:nvSpPr>
-        <p:spPr>
-          <a:xfrm>
-            <a:off x="548640" y="365760"/>
-            <a:ext cx="8046720" cy="731520"/>
-          </a:xfrm>
-          <a:prstGeom prst="rect">
-            <a:avLst/>
-          </a:prstGeom>
-          <a:noFill/>
-        </p:spPr>
-        <p:txBody>
-          <a:bodyPr wrap="square" tIns="91440" bIns="91440">
-            <a:spAutoFit/>
-          </a:bodyPr>
-          <a:lstStyle/>
-          <a:p>
-            <a:pPr>
-              <a:defRPr sz="2800" b="1">
-                <a:solidFill>
-                  <a:srgbClr val="38BDF8"/>
-                </a:solidFill>
-                <a:latin typeface="Calibri"/>
-              </a:defRPr>
-            </a:pPr>
-            <a:r>
-              <a:t>The 'Toy Attacker' Trap: Why IID Noise Fails</a:t>
-            </a:r>
-          </a:p>
-        </p:txBody>
-      </p:sp>
-      <p:sp>
-        <p:nvSpPr>
-          <p:cNvPr id="3" name="TextBox 2"/>
-          <p:cNvSpPr txBox="1"/>
-          <p:nvPr/>
-        </p:nvSpPr>
-        <p:spPr>
-          <a:xfrm>
-            <a:off x="548640" y="1188720"/>
-            <a:ext cx="4572000" cy="3566160"/>
-          </a:xfrm>
-          <a:prstGeom prst="rect">
-            <a:avLst/>
-          </a:prstGeom>
-          <a:noFill/>
-        </p:spPr>
-        <p:txBody>
-          <a:bodyPr wrap="square" tIns="91440" bIns="91440">
-            <a:spAutoFit/>
-          </a:bodyPr>
-          <a:lstStyle/>
-          <a:p>
-            <a:pPr>
-              <a:spcAft>
-                <a:spcPts val="1000"/>
-              </a:spcAft>
-            </a:pPr>
-            <a:r>
-              <a:rPr sz="1600" b="1">
-                <a:solidFill>
-                  <a:srgbClr val="F8FAFC"/>
-                </a:solidFill>
-                <a:latin typeface="Calibri"/>
-              </a:rPr>
-              <a:t>IID Noise Method: </a:t>
-            </a:r>
-            <a:r>
-              <a:rPr sz="1600" b="0">
-                <a:solidFill>
-                  <a:srgbClr val="F8FAFC"/>
-                </a:solidFill>
-                <a:latin typeface="Calibri"/>
-              </a:rPr>
-              <a:t>Adds independent zero-mean Laplace noise to each sample. Points appear scattered on raw plots.</a:t>
-            </a:r>
-          </a:p>
-          <a:p>
-            <a:pPr>
-              <a:spcAft>
-                <a:spcPts val="1000"/>
-              </a:spcAft>
-            </a:pPr>
-            <a:r>
-              <a:rPr sz="1600" b="1">
-                <a:solidFill>
-                  <a:srgbClr val="F8FAFC"/>
-                </a:solidFill>
-                <a:latin typeface="Calibri"/>
-              </a:rPr>
-              <a:t>Adaptive Counter-Strategy: </a:t>
-            </a:r>
-            <a:r>
-              <a:rPr sz="1600" b="0">
-                <a:solidFill>
-                  <a:srgbClr val="F8FAFC"/>
-                </a:solidFill>
-                <a:latin typeface="Calibri"/>
-              </a:rPr>
-              <a:t>Since user dwell holds ~15-35 frames, the attacker segments by dwell and averages coordinates.</a:t>
-            </a:r>
-          </a:p>
-          <a:p>
-            <a:pPr>
-              <a:spcAft>
-                <a:spcPts val="1000"/>
-              </a:spcAft>
-            </a:pPr>
-            <a:r>
-              <a:rPr sz="1600" b="1">
-                <a:solidFill>
-                  <a:srgbClr val="F8FAFC"/>
-                </a:solidFill>
-                <a:latin typeface="Calibri"/>
-              </a:rPr>
-              <a:t>Noise Cancellation: </a:t>
-            </a:r>
-            <a:r>
-              <a:rPr sz="1600" b="0">
-                <a:solidFill>
-                  <a:srgbClr val="F8FAFC"/>
-                </a:solidFill>
-                <a:latin typeface="Calibri"/>
-              </a:rPr>
-              <a:t>By the Law of Large Numbers, independent zero-mean noise cancels out and averages back to zero.</a:t>
-            </a:r>
-          </a:p>
-          <a:p>
-            <a:pPr>
-              <a:spcAft>
-                <a:spcPts val="1000"/>
-              </a:spcAft>
-            </a:pPr>
-            <a:r>
-              <a:rPr sz="1600" b="1">
-                <a:solidFill>
-                  <a:srgbClr val="F43F5E"/>
-                </a:solidFill>
-                <a:latin typeface="Calibri"/>
-              </a:rPr>
-              <a:t>Performance: </a:t>
-            </a:r>
-            <a:r>
-              <a:rPr sz="1600" b="0">
-                <a:solidFill>
-                  <a:srgbClr val="F43F5E"/>
-                </a:solidFill>
-                <a:latin typeface="Calibri"/>
-              </a:rPr>
-              <a:t>Evaluated in our benchmark: drops naive attacker to 11% but fails against adaptive attacker (51% Top-1 character leak).</a:t>
-            </a:r>
-          </a:p>
-        </p:txBody>
-      </p:sp>
-      <p:pic>
-        <p:nvPicPr>
-          <p:cNvPr id="4" name="Picture 3" descr="math_expectation.png"/>
-          <p:cNvPicPr>
-            <a:picLocks noChangeAspect="1"/>
-          </p:cNvPicPr>
-          <p:nvPr/>
-        </p:nvPicPr>
-        <p:blipFill>
-          <a:blip r:embed="rId2"/>
-          <a:stretch>
-            <a:fillRect/>
-          </a:stretch>
-        </p:blipFill>
-        <p:spPr>
-          <a:xfrm>
-            <a:off x="5303520" y="2011680"/>
-            <a:ext cx="3474720" cy="731863"/>
-          </a:xfrm>
-          <a:prstGeom prst="rect">
-            <a:avLst/>
-          </a:prstGeom>
-        </p:spPr>
-      </p:pic>
-    </p:spTree>
-  </p:cSld>
-  <p:clrMapOvr>
-    <a:masterClrMapping/>
-  </p:clrMapOvr>
-</p:sld>
-</file>
-
-<file path=ppt/slides/slide6.xml><?xml version="1.0" encoding="utf-8"?>
-<p:sld xmlns:a="http://schemas.openxmlformats.org/drawingml/2006/main" xmlns:p="http://schemas.openxmlformats.org/presentationml/2006/main" xmlns:r="http://schemas.openxmlformats.org/officeDocument/2006/relationships">
-  <p:cSld>
-    <p:bg>
-      <p:bgPr>
-        <a:solidFill>
-          <a:srgbClr val="0F172A"/>
-        </a:solidFill>
-        <a:effectLst/>
-      </p:bgPr>
-    </p:bg>
-    <p:spTree>
-      <p:nvGrpSpPr>
-        <p:cNvPr id="1" name=""/>
-        <p:cNvGrpSpPr/>
-        <p:nvPr/>
-      </p:nvGrpSpPr>
-      <p:grpSpPr/>
-      <p:sp>
-        <p:nvSpPr>
-          <p:cNvPr id="2" name="TextBox 1"/>
-          <p:cNvSpPr txBox="1"/>
-          <p:nvPr/>
-        </p:nvSpPr>
-        <p:spPr>
-          <a:xfrm>
-            <a:off x="548640" y="365760"/>
-            <a:ext cx="8046720" cy="731520"/>
-          </a:xfrm>
-          <a:prstGeom prst="rect">
-            <a:avLst/>
-          </a:prstGeom>
-          <a:noFill/>
-        </p:spPr>
-        <p:txBody>
-          <a:bodyPr wrap="square" tIns="91440" bIns="91440">
-            <a:spAutoFit/>
-          </a:bodyPr>
-          <a:lstStyle/>
-          <a:p>
-            <a:pPr>
-              <a:defRPr sz="2800" b="1">
-                <a:solidFill>
-                  <a:srgbClr val="38BDF8"/>
-                </a:solidFill>
-                <a:latin typeface="Calibri"/>
-              </a:defRPr>
-            </a:pPr>
-            <a:r>
-              <a:t>Proposed Solution: CASOM Architecture</a:t>
-            </a:r>
-          </a:p>
-        </p:txBody>
-      </p:sp>
-      <p:sp>
-        <p:nvSpPr>
-          <p:cNvPr id="3" name="TextBox 2"/>
-          <p:cNvSpPr txBox="1"/>
-          <p:nvPr/>
-        </p:nvSpPr>
-        <p:spPr>
-          <a:xfrm>
-            <a:off x="548640" y="1280160"/>
-            <a:ext cx="8046720" cy="3474720"/>
-          </a:xfrm>
-          <a:prstGeom prst="rect">
-            <a:avLst/>
-          </a:prstGeom>
-          <a:noFill/>
-        </p:spPr>
-        <p:txBody>
-          <a:bodyPr wrap="square" tIns="91440" bIns="91440">
-            <a:spAutoFit/>
-          </a:bodyPr>
-          <a:lstStyle/>
-          <a:p>
-            <a:pPr>
-              <a:spcAft>
-                <a:spcPts val="1000"/>
-              </a:spcAft>
-            </a:pPr>
-            <a:r>
-              <a:rPr sz="1800" b="1">
-                <a:solidFill>
-                  <a:srgbClr val="F8FAFC"/>
-                </a:solidFill>
-                <a:latin typeface="Calibri"/>
-              </a:rPr>
-              <a:t>OS-Level Interceptor: </a:t>
-            </a:r>
-            <a:r>
-              <a:rPr sz="1800" b="0">
-                <a:solidFill>
-                  <a:srgbClr val="F8FAFC"/>
-                </a:solidFill>
-                <a:latin typeface="Calibri"/>
-              </a:rPr>
-              <a:t>Context-Aware Sensor Obfuscation Middleware running inside the OS sensor framework boundary.</a:t>
-            </a:r>
-          </a:p>
-          <a:p>
-            <a:pPr>
-              <a:spcAft>
-                <a:spcPts val="1000"/>
-              </a:spcAft>
-            </a:pPr>
-            <a:r>
-              <a:rPr sz="1800" b="1">
-                <a:solidFill>
-                  <a:srgbClr val="F8FAFC"/>
-                </a:solidFill>
-                <a:latin typeface="Calibri"/>
-              </a:rPr>
-              <a:t>Context Awareness: </a:t>
-            </a:r>
-            <a:r>
-              <a:rPr sz="1800" b="0">
-                <a:solidFill>
-                  <a:srgbClr val="F8FAFC"/>
-                </a:solidFill>
-                <a:latin typeface="Calibri"/>
-              </a:rPr>
-              <a:t>Detects keyboard events and focus states to dynamically trigger protection without breaking standard gestures.</a:t>
-            </a:r>
-          </a:p>
-          <a:p>
-            <a:pPr>
-              <a:spcAft>
-                <a:spcPts val="1000"/>
-              </a:spcAft>
-            </a:pPr>
-            <a:r>
-              <a:rPr sz="1800" b="1">
-                <a:solidFill>
-                  <a:srgbClr val="F8FAFC"/>
-                </a:solidFill>
-                <a:latin typeface="Calibri"/>
-              </a:rPr>
-              <a:t>Stream Bifurcation: </a:t>
-            </a:r>
-            <a:r>
-              <a:rPr sz="1800" b="0">
-                <a:solidFill>
-                  <a:srgbClr val="F8FAFC"/>
-                </a:solidFill>
-                <a:latin typeface="Calibri"/>
-              </a:rPr>
-              <a:t>Bifurcates raw tracking coordinates into separate foreground and background streams.</a:t>
-            </a:r>
-          </a:p>
-          <a:p>
-            <a:pPr>
-              <a:spcAft>
-                <a:spcPts val="1000"/>
-              </a:spcAft>
-            </a:pPr>
-            <a:r>
-              <a:rPr sz="1800" b="1">
-                <a:solidFill>
-                  <a:srgbClr val="10B981"/>
-                </a:solidFill>
-                <a:latin typeface="Calibri"/>
-              </a:rPr>
-              <a:t>Foreground Stream: </a:t>
-            </a:r>
-            <a:r>
-              <a:rPr sz="1800" b="0">
-                <a:solidFill>
-                  <a:srgbClr val="10B981"/>
-                </a:solidFill>
-                <a:latin typeface="Calibri"/>
-              </a:rPr>
-              <a:t>Legitimate Virtual Keyboard receives clean, high-precision telemetry, ensuring 100% typing accuracy and zero UX lag.</a:t>
-            </a:r>
-          </a:p>
-          <a:p>
-            <a:pPr>
-              <a:spcAft>
-                <a:spcPts val="1000"/>
-              </a:spcAft>
-            </a:pPr>
-            <a:r>
-              <a:rPr sz="1800" b="1">
-                <a:solidFill>
-                  <a:srgbClr val="F43F5E"/>
-                </a:solidFill>
-                <a:latin typeface="Calibri"/>
-              </a:rPr>
-              <a:t>Background Stream: </a:t>
-            </a:r>
-            <a:r>
-              <a:rPr sz="1800" b="0">
-                <a:solidFill>
-                  <a:srgbClr val="F43F5E"/>
-                </a:solidFill>
-                <a:latin typeface="Calibri"/>
-              </a:rPr>
-              <a:t>Background processes receive mathematically obfuscated streams, stripping them of high-fidelity spatial telemetry.</a:t>
-            </a:r>
-          </a:p>
-        </p:txBody>
-      </p:sp>
-    </p:spTree>
-  </p:cSld>
-  <p:clrMapOvr>
-    <a:masterClrMapping/>
-  </p:clrMapOvr>
-</p:sld>
-</file>
-
-<file path=ppt/slides/slide7.xml><?xml version="1.0" encoding="utf-8"?>
-<p:sld xmlns:a="http://schemas.openxmlformats.org/drawingml/2006/main" xmlns:p="http://schemas.openxmlformats.org/presentationml/2006/main" xmlns:r="http://schemas.openxmlformats.org/officeDocument/2006/relationships">
-  <p:cSld>
-    <p:bg>
-      <p:bgPr>
-        <a:solidFill>
-          <a:srgbClr val="0F172A"/>
-        </a:solidFill>
-        <a:effectLst/>
-      </p:bgPr>
-    </p:bg>
-    <p:spTree>
-      <p:nvGrpSpPr>
-        <p:cNvPr id="1" name=""/>
-        <p:cNvGrpSpPr/>
-        <p:nvPr/>
-      </p:nvGrpSpPr>
-      <p:grpSpPr/>
-      <p:sp>
-        <p:nvSpPr>
-          <p:cNvPr id="2" name="TextBox 1"/>
-          <p:cNvSpPr txBox="1"/>
-          <p:nvPr/>
-        </p:nvSpPr>
-        <p:spPr>
-          <a:xfrm>
-            <a:off x="548640" y="365760"/>
-            <a:ext cx="8046720" cy="731520"/>
-          </a:xfrm>
-          <a:prstGeom prst="rect">
-            <a:avLst/>
-          </a:prstGeom>
-          <a:noFill/>
-        </p:spPr>
-        <p:txBody>
-          <a:bodyPr wrap="square" tIns="91440" bIns="91440">
-            <a:spAutoFit/>
-          </a:bodyPr>
-          <a:lstStyle/>
-          <a:p>
-            <a:pPr>
-              <a:defRPr sz="2800" b="1">
-                <a:solidFill>
-                  <a:srgbClr val="38BDF8"/>
-                </a:solidFill>
-                <a:latin typeface="Calibri"/>
-              </a:defRPr>
-            </a:pPr>
-            <a:r>
-              <a:t>CASOM v2: Surviving the BackTree Attack</a:t>
-            </a:r>
-          </a:p>
-        </p:txBody>
-      </p:sp>
-      <p:sp>
-        <p:nvSpPr>
-          <p:cNvPr id="3" name="TextBox 2"/>
-          <p:cNvSpPr txBox="1"/>
-          <p:nvPr/>
-        </p:nvSpPr>
-        <p:spPr>
-          <a:xfrm>
-            <a:off x="548640" y="1280160"/>
-            <a:ext cx="8046720" cy="3474720"/>
-          </a:xfrm>
-          <a:prstGeom prst="rect">
-            <a:avLst/>
-          </a:prstGeom>
-          <a:noFill/>
-        </p:spPr>
-        <p:txBody>
-          <a:bodyPr wrap="square" tIns="91440" bIns="91440">
-            <a:spAutoFit/>
-          </a:bodyPr>
-          <a:lstStyle/>
-          <a:p>
-            <a:pPr>
-              <a:spcAft>
-                <a:spcPts val="1000"/>
-              </a:spcAft>
-            </a:pPr>
-            <a:r>
-              <a:rPr sz="1800" b="1">
-                <a:solidFill>
-                  <a:srgbClr val="F8FAFC"/>
-                </a:solidFill>
-                <a:latin typeface="Calibri"/>
-              </a:rPr>
-              <a:t>BackTree Adversary: </a:t>
-            </a:r>
-            <a:r>
-              <a:rPr sz="1800" b="0">
-                <a:solidFill>
-                  <a:srgbClr val="F8FAFC"/>
-                </a:solidFill>
-                <a:latin typeface="Calibri"/>
-              </a:rPr>
-              <a:t>The BackTree attack (SNOOPFINGER paper section 5.6) maps relative geometry vectors between keypress centroids, bypassing simple drift.</a:t>
-            </a:r>
-          </a:p>
-          <a:p>
-            <a:pPr>
-              <a:spcAft>
-                <a:spcPts val="1000"/>
-              </a:spcAft>
-            </a:pPr>
-            <a:r>
-              <a:rPr sz="1800" b="1">
-                <a:solidFill>
-                  <a:srgbClr val="F8FAFC"/>
-                </a:solidFill>
-                <a:latin typeface="Calibri"/>
-              </a:rPr>
-              <a:t>Drift Failure: </a:t>
-            </a:r>
-            <a:r>
-              <a:rPr sz="1800" b="0">
-                <a:solidFill>
-                  <a:srgbClr val="F8FAFC"/>
-                </a:solidFill>
-                <a:latin typeface="Calibri"/>
-              </a:rPr>
-              <a:t>A slow coordinate bias drift shifts consecutive centroids in the same direction, preserving relative vectors and letting BackTree succeed.</a:t>
-            </a:r>
-          </a:p>
-          <a:p>
-            <a:pPr>
-              <a:spcAft>
-                <a:spcPts val="1000"/>
-              </a:spcAft>
-            </a:pPr>
-            <a:r>
-              <a:rPr sz="1800" b="1">
-                <a:solidFill>
-                  <a:srgbClr val="10B981"/>
-                </a:solidFill>
-                <a:latin typeface="Calibri"/>
-              </a:rPr>
-              <a:t>Block Offset Defense (Recommended): </a:t>
-            </a:r>
-            <a:r>
-              <a:rPr sz="1800" b="0">
-                <a:solidFill>
-                  <a:srgbClr val="10B981"/>
-                </a:solidFill>
-                <a:latin typeface="Calibri"/>
-              </a:rPr>
-              <a:t>A Laplace noise offset is generated once per block of 15 samples (~dwell length) and held constant during the block.</a:t>
-            </a:r>
-          </a:p>
-          <a:p>
-            <a:pPr>
-              <a:spcAft>
-                <a:spcPts val="1000"/>
-              </a:spcAft>
-            </a:pPr>
-            <a:r>
-              <a:rPr sz="1800" b="1">
-                <a:solidFill>
-                  <a:srgbClr val="F8FAFC"/>
-                </a:solidFill>
-                <a:latin typeface="Calibri"/>
-              </a:rPr>
-              <a:t>Disruption Mechanism: </a:t>
-            </a:r>
-            <a:r>
-              <a:rPr sz="1800" b="0">
-                <a:solidFill>
-                  <a:srgbClr val="F8FAFC"/>
-                </a:solidFill>
-                <a:latin typeface="Calibri"/>
-              </a:rPr>
-              <a:t>Because noise changes per block, it shifts each key centroid independently, breaking relative vectors and surviving dwell averages.</a:t>
-            </a:r>
-          </a:p>
-          <a:p>
-            <a:pPr>
-              <a:spcAft>
-                <a:spcPts val="1000"/>
-              </a:spcAft>
-            </a:pPr>
-            <a:r>
-              <a:rPr sz="1800" b="1">
-                <a:solidFill>
-                  <a:srgbClr val="F8FAFC"/>
-                </a:solidFill>
-                <a:latin typeface="Calibri"/>
-              </a:rPr>
-              <a:t>Deployment Advantage: </a:t>
-            </a:r>
-            <a:r>
-              <a:rPr sz="1800" b="0">
-                <a:solidFill>
-                  <a:srgbClr val="F8FAFC"/>
-                </a:solidFill>
-                <a:latin typeface="Calibri"/>
-              </a:rPr>
-              <a:t>Does not require precise typing boundaries, making it highly deployable via standard timers.</a:t>
-            </a:r>
-          </a:p>
-        </p:txBody>
-      </p:sp>
-    </p:spTree>
-  </p:cSld>
-  <p:clrMapOvr>
-    <a:masterClrMapping/>
-  </p:clrMapOvr>
-</p:sld>
-</file>
-
-<file path=ppt/slides/slide8.xml><?xml version="1.0" encoding="utf-8"?>
-<p:sld xmlns:a="http://schemas.openxmlformats.org/drawingml/2006/main" xmlns:p="http://schemas.openxmlformats.org/presentationml/2006/main" xmlns:r="http://schemas.openxmlformats.org/officeDocument/2006/relationships">
-  <p:cSld>
-    <p:bg>
-      <p:bgPr>
-        <a:solidFill>
-          <a:srgbClr val="0F172A"/>
-        </a:solidFill>
-        <a:effectLst/>
-      </p:bgPr>
-    </p:bg>
-    <p:spTree>
-      <p:nvGrpSpPr>
-        <p:cNvPr id="1" name=""/>
-        <p:cNvGrpSpPr/>
-        <p:nvPr/>
-      </p:nvGrpSpPr>
-      <p:grpSpPr/>
-      <p:sp>
-        <p:nvSpPr>
-          <p:cNvPr id="2" name="TextBox 1"/>
-          <p:cNvSpPr txBox="1"/>
-          <p:nvPr/>
-        </p:nvSpPr>
-        <p:spPr>
-          <a:xfrm>
-            <a:off x="548640" y="365760"/>
-            <a:ext cx="8046720" cy="731520"/>
-          </a:xfrm>
-          <a:prstGeom prst="rect">
-            <a:avLst/>
-          </a:prstGeom>
-          <a:noFill/>
-        </p:spPr>
-        <p:txBody>
-          <a:bodyPr wrap="square" tIns="91440" bIns="91440">
-            <a:spAutoFit/>
-          </a:bodyPr>
-          <a:lstStyle/>
-          <a:p>
-            <a:pPr>
-              <a:defRPr sz="2800" b="1">
-                <a:solidFill>
-                  <a:srgbClr val="38BDF8"/>
-                </a:solidFill>
-                <a:latin typeface="Calibri"/>
-              </a:defRPr>
-            </a:pPr>
-            <a:r>
-              <a:t>Empirical Results: Word-Level Evaluation Table</a:t>
-            </a:r>
-          </a:p>
-        </p:txBody>
-      </p:sp>
-      <p:graphicFrame>
-        <p:nvGraphicFramePr>
-          <p:cNvPr id="3" name="Table 2"/>
-          <p:cNvGraphicFramePr>
-            <a:graphicFrameLocks noGrp="1"/>
-          </p:cNvGraphicFramePr>
-          <p:nvPr/>
-        </p:nvGraphicFramePr>
-        <p:xfrm>
-          <a:off x="548640" y="1188720"/>
-          <a:ext cx="8046720" cy="2011680"/>
-        </p:xfrm>
-        <a:graphic>
-          <a:graphicData uri="http://schemas.openxmlformats.org/drawingml/2006/table">
-            <a:tbl>
-              <a:tblPr firstRow="1" bandRow="1">
-                <a:tableStyleId>{5C22544A-7EE6-4342-B048-85BDC9FD1C3A}</a:tableStyleId>
-              </a:tblPr>
-              <a:tblGrid>
-                <a:gridCol w="2011680"/>
-                <a:gridCol w="2011680"/>
-                <a:gridCol w="2011680"/>
-                <a:gridCol w="2011680"/>
-              </a:tblGrid>
-              <a:tr h="287382">
-                <a:tc>
-                  <a:txBody>
-                    <a:bodyPr/>
-                    <a:lstStyle/>
-                    <a:p>
-                      <a:pPr algn="ctr">
-                        <a:defRPr sz="1400" b="1">
-                          <a:solidFill>
-                            <a:srgbClr val="38BDF8"/>
-                          </a:solidFill>
-                          <a:latin typeface="Calibri"/>
-                        </a:defRPr>
-                      </a:pPr>
-                      <a:r>
-                        <a:t>Defense Mode</a:t>
-                      </a:r>
-                    </a:p>
-                  </a:txBody>
-                  <a:tcPr>
-                    <a:solidFill>
-                      <a:srgbClr val="1E293B"/>
-                    </a:solidFill>
-                  </a:tcPr>
-                </a:tc>
-                <a:tc>
-                  <a:txBody>
-                    <a:bodyPr/>
-                    <a:lstStyle/>
-                    <a:p>
-                      <a:pPr algn="ctr">
-                        <a:defRPr sz="1400" b="1">
-                          <a:solidFill>
-                            <a:srgbClr val="38BDF8"/>
-                          </a:solidFill>
-                          <a:latin typeface="Calibri"/>
-                        </a:defRPr>
-                      </a:pPr>
-                      <a:r>
-                        <a:t>Word Top-1 Accuracy</a:t>
-                      </a:r>
-                    </a:p>
-                  </a:txBody>
-                  <a:tcPr>
-                    <a:solidFill>
-                      <a:srgbClr val="1E293B"/>
-                    </a:solidFill>
-                  </a:tcPr>
-                </a:tc>
-                <a:tc>
-                  <a:txBody>
-                    <a:bodyPr/>
-                    <a:lstStyle/>
-                    <a:p>
-                      <a:pPr algn="ctr">
-                        <a:defRPr sz="1400" b="1">
-                          <a:solidFill>
-                            <a:srgbClr val="38BDF8"/>
-                          </a:solidFill>
-                          <a:latin typeface="Calibri"/>
-                        </a:defRPr>
-                      </a:pPr>
-                      <a:r>
-                        <a:t>Word Top-3 Accuracy</a:t>
-                      </a:r>
-                    </a:p>
-                  </a:txBody>
-                  <a:tcPr>
-                    <a:solidFill>
-                      <a:srgbClr val="1E293B"/>
-                    </a:solidFill>
-                  </a:tcPr>
-                </a:tc>
-                <a:tc>
-                  <a:txBody>
-                    <a:bodyPr/>
-                    <a:lstStyle/>
-                    <a:p>
-                      <a:pPr algn="ctr">
-                        <a:defRPr sz="1400" b="1">
-                          <a:solidFill>
-                            <a:srgbClr val="38BDF8"/>
-                          </a:solidFill>
-                          <a:latin typeface="Calibri"/>
-                        </a:defRPr>
-                      </a:pPr>
-                      <a:r>
-                        <a:t>Word Top-10 Accuracy</a:t>
-                      </a:r>
-                    </a:p>
-                  </a:txBody>
-                  <a:tcPr>
-                    <a:solidFill>
-                      <a:srgbClr val="1E293B"/>
-                    </a:solidFill>
-                  </a:tcPr>
-                </a:tc>
-              </a:tr>
-              <a:tr h="287382">
-                <a:tc>
-                  <a:txBody>
-                    <a:bodyPr/>
-                    <a:lstStyle/>
-                    <a:p>
-                      <a:pPr algn="l">
-                        <a:defRPr sz="1300" b="1">
-                          <a:solidFill>
-                            <a:srgbClr val="F8FAFC"/>
-                          </a:solidFill>
-                          <a:latin typeface="Calibri"/>
-                        </a:defRPr>
-                      </a:pPr>
-                      <a:r>
-                        <a:t>No Defense (Baseline)</a:t>
-                      </a:r>
-                    </a:p>
-                  </a:txBody>
-                  <a:tcPr>
-                    <a:solidFill>
-                      <a:srgbClr val="161E31"/>
-                    </a:solidFill>
-                  </a:tcPr>
-                </a:tc>
-                <a:tc>
-                  <a:txBody>
-                    <a:bodyPr/>
-                    <a:lstStyle/>
-                    <a:p>
-                      <a:pPr algn="ctr">
-                        <a:defRPr sz="1300" b="1">
-                          <a:solidFill>
-                            <a:srgbClr val="F43F5E"/>
-                          </a:solidFill>
-                          <a:latin typeface="Calibri"/>
-                        </a:defRPr>
-                      </a:pPr>
-                      <a:r>
-                        <a:t>80.9%</a:t>
-                      </a:r>
-                    </a:p>
-                  </a:txBody>
-                  <a:tcPr>
-                    <a:solidFill>
-                      <a:srgbClr val="161E31"/>
-                    </a:solidFill>
-                  </a:tcPr>
-                </a:tc>
-                <a:tc>
-                  <a:txBody>
-                    <a:bodyPr/>
-                    <a:lstStyle/>
-                    <a:p>
-                      <a:pPr algn="ctr">
-                        <a:defRPr sz="1300" b="1">
-                          <a:solidFill>
-                            <a:srgbClr val="F43F5E"/>
-                          </a:solidFill>
-                          <a:latin typeface="Calibri"/>
-                        </a:defRPr>
-                      </a:pPr>
-                      <a:r>
-                        <a:t>80.9%</a:t>
-                      </a:r>
-                    </a:p>
-                  </a:txBody>
-                  <a:tcPr>
-                    <a:solidFill>
-                      <a:srgbClr val="161E31"/>
-                    </a:solidFill>
-                  </a:tcPr>
-                </a:tc>
-                <a:tc>
-                  <a:txBody>
-                    <a:bodyPr/>
-                    <a:lstStyle/>
-                    <a:p>
-                      <a:pPr algn="ctr">
-                        <a:defRPr sz="1300" b="1">
-                          <a:solidFill>
-                            <a:srgbClr val="F43F5E"/>
-                          </a:solidFill>
-                          <a:latin typeface="Calibri"/>
-                        </a:defRPr>
-                      </a:pPr>
-                      <a:r>
-                        <a:t>80.9%</a:t>
-                      </a:r>
-                    </a:p>
-                  </a:txBody>
-                  <a:tcPr>
-                    <a:solidFill>
-                      <a:srgbClr val="161E31"/>
-                    </a:solidFill>
-                  </a:tcPr>
-                </a:tc>
-              </a:tr>
-              <a:tr h="287382">
-                <a:tc>
-                  <a:txBody>
-                    <a:bodyPr/>
-                    <a:lstStyle/>
-                    <a:p>
-                      <a:pPr algn="l">
-                        <a:defRPr sz="1300" b="1">
-                          <a:solidFill>
-                            <a:srgbClr val="F8FAFC"/>
-                          </a:solidFill>
-                          <a:latin typeface="Calibri"/>
-                        </a:defRPr>
-                      </a:pPr>
-                      <a:r>
-                        <a:t>IID Noise (Original)</a:t>
-                      </a:r>
-                    </a:p>
-                  </a:txBody>
-                  <a:tcPr>
-                    <a:solidFill>
-                      <a:srgbClr val="0F172A"/>
-                    </a:solidFill>
-                  </a:tcPr>
-                </a:tc>
-                <a:tc>
-                  <a:txBody>
-                    <a:bodyPr/>
-                    <a:lstStyle/>
-                    <a:p>
-                      <a:pPr algn="ctr">
-                        <a:defRPr sz="1300">
-                          <a:solidFill>
-                            <a:srgbClr val="F8FAFC"/>
-                          </a:solidFill>
-                          <a:latin typeface="Calibri"/>
-                        </a:defRPr>
-                      </a:pPr>
-                      <a:r>
-                        <a:t>35.8%</a:t>
-                      </a:r>
-                    </a:p>
-                  </a:txBody>
-                  <a:tcPr>
-                    <a:solidFill>
-                      <a:srgbClr val="0F172A"/>
-                    </a:solidFill>
-                  </a:tcPr>
-                </a:tc>
-                <a:tc>
-                  <a:txBody>
-                    <a:bodyPr/>
-                    <a:lstStyle/>
-                    <a:p>
-                      <a:pPr algn="ctr">
-                        <a:defRPr sz="1300">
-                          <a:solidFill>
-                            <a:srgbClr val="F8FAFC"/>
-                          </a:solidFill>
-                          <a:latin typeface="Calibri"/>
-                        </a:defRPr>
-                      </a:pPr>
-                      <a:r>
-                        <a:t>51.8%</a:t>
-                      </a:r>
-                    </a:p>
-                  </a:txBody>
-                  <a:tcPr>
-                    <a:solidFill>
-                      <a:srgbClr val="0F172A"/>
-                    </a:solidFill>
-                  </a:tcPr>
-                </a:tc>
-                <a:tc>
-                  <a:txBody>
-                    <a:bodyPr/>
-                    <a:lstStyle/>
-                    <a:p>
-                      <a:pPr algn="ctr">
-                        <a:defRPr sz="1300">
-                          <a:solidFill>
-                            <a:srgbClr val="F8FAFC"/>
-                          </a:solidFill>
-                          <a:latin typeface="Calibri"/>
-                        </a:defRPr>
-                      </a:pPr>
-                      <a:r>
-                        <a:t>62.9%</a:t>
-                      </a:r>
-                    </a:p>
-                  </a:txBody>
-                  <a:tcPr>
-                    <a:solidFill>
-                      <a:srgbClr val="0F172A"/>
-                    </a:solidFill>
-                  </a:tcPr>
-                </a:tc>
-              </a:tr>
-              <a:tr h="287382">
-                <a:tc>
-                  <a:txBody>
-                    <a:bodyPr/>
-                    <a:lstStyle/>
-                    <a:p>
-                      <a:pPr algn="l">
-                        <a:defRPr sz="1300" b="1">
-                          <a:solidFill>
-                            <a:srgbClr val="F8FAFC"/>
-                          </a:solidFill>
-                          <a:latin typeface="Calibri"/>
-                        </a:defRPr>
-                      </a:pPr>
-                      <a:r>
-                        <a:t>Correlated Drift</a:t>
-                      </a:r>
-                    </a:p>
-                  </a:txBody>
-                  <a:tcPr>
-                    <a:solidFill>
-                      <a:srgbClr val="161E31"/>
-                    </a:solidFill>
-                  </a:tcPr>
-                </a:tc>
-                <a:tc>
-                  <a:txBody>
-                    <a:bodyPr/>
-                    <a:lstStyle/>
-                    <a:p>
-                      <a:pPr algn="ctr">
-                        <a:defRPr sz="1300">
-                          <a:solidFill>
-                            <a:srgbClr val="F8FAFC"/>
-                          </a:solidFill>
-                          <a:latin typeface="Calibri"/>
-                        </a:defRPr>
-                      </a:pPr>
-                      <a:r>
-                        <a:t>27.6%</a:t>
-                      </a:r>
-                    </a:p>
-                  </a:txBody>
-                  <a:tcPr>
-                    <a:solidFill>
-                      <a:srgbClr val="161E31"/>
-                    </a:solidFill>
-                  </a:tcPr>
-                </a:tc>
-                <a:tc>
-                  <a:txBody>
-                    <a:bodyPr/>
-                    <a:lstStyle/>
-                    <a:p>
-                      <a:pPr algn="ctr">
-                        <a:defRPr sz="1300">
-                          <a:solidFill>
-                            <a:srgbClr val="F8FAFC"/>
-                          </a:solidFill>
-                          <a:latin typeface="Calibri"/>
-                        </a:defRPr>
-                      </a:pPr>
-                      <a:r>
-                        <a:t>42.1%</a:t>
-                      </a:r>
-                    </a:p>
-                  </a:txBody>
-                  <a:tcPr>
-                    <a:solidFill>
-                      <a:srgbClr val="161E31"/>
-                    </a:solidFill>
-                  </a:tcPr>
-                </a:tc>
-                <a:tc>
-                  <a:txBody>
-                    <a:bodyPr/>
-                    <a:lstStyle/>
-                    <a:p>
-                      <a:pPr algn="ctr">
-                        <a:defRPr sz="1300">
-                          <a:solidFill>
-                            <a:srgbClr val="F8FAFC"/>
-                          </a:solidFill>
-                          <a:latin typeface="Calibri"/>
-                        </a:defRPr>
-                      </a:pPr>
-                      <a:r>
-                        <a:t>52.7%</a:t>
-                      </a:r>
-                    </a:p>
-                  </a:txBody>
-                  <a:tcPr>
-                    <a:solidFill>
-                      <a:srgbClr val="161E31"/>
-                    </a:solidFill>
-                  </a:tcPr>
-                </a:tc>
-              </a:tr>
-              <a:tr h="287382">
-                <a:tc>
-                  <a:txBody>
-                    <a:bodyPr/>
-                    <a:lstStyle/>
-                    <a:p>
-                      <a:pPr algn="l">
-                        <a:defRPr sz="1300" b="1">
-                          <a:solidFill>
-                            <a:srgbClr val="F8FAFC"/>
-                          </a:solidFill>
-                          <a:latin typeface="Calibri"/>
-                        </a:defRPr>
-                      </a:pPr>
-                      <a:r>
-                        <a:t>Downsample &amp; Quantize</a:t>
-                      </a:r>
-                    </a:p>
-                  </a:txBody>
-                  <a:tcPr>
-                    <a:solidFill>
-                      <a:srgbClr val="0F172A"/>
-                    </a:solidFill>
-                  </a:tcPr>
-                </a:tc>
-                <a:tc>
-                  <a:txBody>
-                    <a:bodyPr/>
-                    <a:lstStyle/>
-                    <a:p>
-                      <a:pPr algn="ctr">
-                        <a:defRPr sz="1300" b="1">
-                          <a:solidFill>
-                            <a:srgbClr val="10B981"/>
-                          </a:solidFill>
-                          <a:latin typeface="Calibri"/>
-                        </a:defRPr>
-                      </a:pPr>
-                      <a:r>
-                        <a:t>2.3%</a:t>
-                      </a:r>
-                    </a:p>
-                  </a:txBody>
-                  <a:tcPr>
-                    <a:solidFill>
-                      <a:srgbClr val="0F172A"/>
-                    </a:solidFill>
-                  </a:tcPr>
-                </a:tc>
-                <a:tc>
-                  <a:txBody>
-                    <a:bodyPr/>
-                    <a:lstStyle/>
-                    <a:p>
-                      <a:pPr algn="ctr">
-                        <a:defRPr sz="1300">
-                          <a:solidFill>
-                            <a:srgbClr val="F8FAFC"/>
-                          </a:solidFill>
-                          <a:latin typeface="Calibri"/>
-                        </a:defRPr>
-                      </a:pPr>
-                      <a:r>
-                        <a:t>5.6%</a:t>
-                      </a:r>
-                    </a:p>
-                  </a:txBody>
-                  <a:tcPr>
-                    <a:solidFill>
-                      <a:srgbClr val="0F172A"/>
-                    </a:solidFill>
-                  </a:tcPr>
-                </a:tc>
-                <a:tc>
-                  <a:txBody>
-                    <a:bodyPr/>
-                    <a:lstStyle/>
-                    <a:p>
-                      <a:pPr algn="ctr">
-                        <a:defRPr sz="1300">
-                          <a:solidFill>
-                            <a:srgbClr val="F8FAFC"/>
-                          </a:solidFill>
-                          <a:latin typeface="Calibri"/>
-                        </a:defRPr>
-                      </a:pPr>
-                      <a:r>
-                        <a:t>8.9%</a:t>
-                      </a:r>
-                    </a:p>
-                  </a:txBody>
-                  <a:tcPr>
-                    <a:solidFill>
-                      <a:srgbClr val="0F172A"/>
-                    </a:solidFill>
-                  </a:tcPr>
-                </a:tc>
-              </a:tr>
-              <a:tr h="287382">
-                <a:tc>
-                  <a:txBody>
-                    <a:bodyPr/>
-                    <a:lstStyle/>
-                    <a:p>
-                      <a:pPr algn="l">
-                        <a:defRPr sz="1300" b="1">
-                          <a:solidFill>
-                            <a:srgbClr val="F8FAFC"/>
-                          </a:solidFill>
-                          <a:latin typeface="Calibri"/>
-                        </a:defRPr>
-                      </a:pPr>
-                      <a:r>
-                        <a:t>Block Offset (CASOM)</a:t>
-                      </a:r>
-                    </a:p>
-                  </a:txBody>
-                  <a:tcPr>
-                    <a:solidFill>
-                      <a:srgbClr val="161E31"/>
-                    </a:solidFill>
-                  </a:tcPr>
-                </a:tc>
-                <a:tc>
-                  <a:txBody>
-                    <a:bodyPr/>
-                    <a:lstStyle/>
-                    <a:p>
-                      <a:pPr algn="ctr">
-                        <a:defRPr sz="1300" b="1">
-                          <a:solidFill>
-                            <a:srgbClr val="10B981"/>
-                          </a:solidFill>
-                          <a:latin typeface="Calibri"/>
-                        </a:defRPr>
-                      </a:pPr>
-                      <a:r>
-                        <a:t>3.6%</a:t>
-                      </a:r>
-                    </a:p>
-                  </a:txBody>
-                  <a:tcPr>
-                    <a:solidFill>
-                      <a:srgbClr val="161E31"/>
-                    </a:solidFill>
-                  </a:tcPr>
-                </a:tc>
-                <a:tc>
-                  <a:txBody>
-                    <a:bodyPr/>
-                    <a:lstStyle/>
-                    <a:p>
-                      <a:pPr algn="ctr">
-                        <a:defRPr sz="1300">
-                          <a:solidFill>
-                            <a:srgbClr val="F8FAFC"/>
-                          </a:solidFill>
-                          <a:latin typeface="Calibri"/>
-                        </a:defRPr>
-                      </a:pPr>
-                      <a:r>
-                        <a:t>7.0%</a:t>
-                      </a:r>
-                    </a:p>
-                  </a:txBody>
-                  <a:tcPr>
-                    <a:solidFill>
-                      <a:srgbClr val="161E31"/>
-                    </a:solidFill>
-                  </a:tcPr>
-                </a:tc>
-                <a:tc>
-                  <a:txBody>
-                    <a:bodyPr/>
-                    <a:lstStyle/>
-                    <a:p>
-                      <a:pPr algn="ctr">
-                        <a:defRPr sz="1300">
-                          <a:solidFill>
-                            <a:srgbClr val="F8FAFC"/>
-                          </a:solidFill>
-                          <a:latin typeface="Calibri"/>
-                        </a:defRPr>
-                      </a:pPr>
-                      <a:r>
-                        <a:t>13.6%</a:t>
-                      </a:r>
-                    </a:p>
-                  </a:txBody>
-                  <a:tcPr>
-                    <a:solidFill>
-                      <a:srgbClr val="161E31"/>
-                    </a:solidFill>
-                  </a:tcPr>
-                </a:tc>
-              </a:tr>
-              <a:tr h="287388">
-                <a:tc>
-                  <a:txBody>
-                    <a:bodyPr/>
-                    <a:lstStyle/>
-                    <a:p>
-                      <a:pPr algn="l">
-                        <a:defRPr sz="1300" b="1">
-                          <a:solidFill>
-                            <a:srgbClr val="F8FAFC"/>
-                          </a:solidFill>
-                          <a:latin typeface="Calibri"/>
-                        </a:defRPr>
-                      </a:pPr>
-                      <a:r>
-                        <a:t>Per-Keypress Offset</a:t>
-                      </a:r>
-                    </a:p>
-                  </a:txBody>
-                  <a:tcPr>
-                    <a:solidFill>
-                      <a:srgbClr val="0F172A"/>
-                    </a:solidFill>
-                  </a:tcPr>
-                </a:tc>
-                <a:tc>
-                  <a:txBody>
-                    <a:bodyPr/>
-                    <a:lstStyle/>
-                    <a:p>
-                      <a:pPr algn="ctr">
-                        <a:defRPr sz="1300" b="1">
-                          <a:solidFill>
-                            <a:srgbClr val="10B981"/>
-                          </a:solidFill>
-                          <a:latin typeface="Calibri"/>
-                        </a:defRPr>
-                      </a:pPr>
-                      <a:r>
-                        <a:t>2.3%</a:t>
-                      </a:r>
-                    </a:p>
-                  </a:txBody>
-                  <a:tcPr>
-                    <a:solidFill>
-                      <a:srgbClr val="0F172A"/>
-                    </a:solidFill>
-                  </a:tcPr>
-                </a:tc>
-                <a:tc>
-                  <a:txBody>
-                    <a:bodyPr/>
-                    <a:lstStyle/>
-                    <a:p>
-                      <a:pPr algn="ctr">
-                        <a:defRPr sz="1300">
-                          <a:solidFill>
-                            <a:srgbClr val="F8FAFC"/>
-                          </a:solidFill>
-                          <a:latin typeface="Calibri"/>
-                        </a:defRPr>
-                      </a:pPr>
-                      <a:r>
-                        <a:t>3.8%</a:t>
-                      </a:r>
-                    </a:p>
-                  </a:txBody>
-                  <a:tcPr>
-                    <a:solidFill>
-                      <a:srgbClr val="0F172A"/>
-                    </a:solidFill>
-                  </a:tcPr>
-                </a:tc>
-                <a:tc>
-                  <a:txBody>
-                    <a:bodyPr/>
-                    <a:lstStyle/>
-                    <a:p>
-                      <a:pPr algn="ctr">
-                        <a:defRPr sz="1300">
-                          <a:solidFill>
-                            <a:srgbClr val="F8FAFC"/>
-                          </a:solidFill>
-                          <a:latin typeface="Calibri"/>
-                        </a:defRPr>
-                      </a:pPr>
-                      <a:r>
-                        <a:t>7.6%</a:t>
-                      </a:r>
-                    </a:p>
-                  </a:txBody>
-                  <a:tcPr>
-                    <a:solidFill>
-                      <a:srgbClr val="0F172A"/>
-                    </a:solidFill>
-                  </a:tcPr>
-                </a:tc>
-              </a:tr>
-            </a:tbl>
-          </a:graphicData>
-        </a:graphic>
-      </p:graphicFrame>
-      <p:sp>
-        <p:nvSpPr>
-          <p:cNvPr id="4" name="TextBox 3"/>
-          <p:cNvSpPr txBox="1"/>
-          <p:nvPr/>
-        </p:nvSpPr>
-        <p:spPr>
-          <a:xfrm>
-            <a:off x="548640" y="3474720"/>
-            <a:ext cx="8046720" cy="1371600"/>
-          </a:xfrm>
-          <a:prstGeom prst="rect">
-            <a:avLst/>
-          </a:prstGeom>
-          <a:noFill/>
-        </p:spPr>
-        <p:txBody>
-          <a:bodyPr wrap="square" tIns="91440" bIns="91440">
-            <a:spAutoFit/>
-          </a:bodyPr>
-          <a:lstStyle/>
-          <a:p>
-            <a:pPr>
-              <a:spcAft>
-                <a:spcPts val="1000"/>
-              </a:spcAft>
-            </a:pPr>
-            <a:r>
-              <a:rPr sz="1400" b="1">
-                <a:solidFill>
-                  <a:srgbClr val="F8FAFC"/>
-                </a:solidFill>
-                <a:latin typeface="Calibri"/>
-              </a:rPr>
-              <a:t>Key Takeaway: </a:t>
-            </a:r>
-            <a:r>
-              <a:rPr sz="1400" b="0">
-                <a:solidFill>
-                  <a:srgbClr val="F8FAFC"/>
-                </a:solidFill>
-                <a:latin typeface="Calibri"/>
-              </a:rPr>
-              <a:t>The recommended Block Offset defense collapses Top-1 accuracy to 3.6% (near chance for 8k dictionary).</a:t>
-            </a:r>
-          </a:p>
-          <a:p>
-            <a:pPr>
-              <a:spcAft>
-                <a:spcPts val="1000"/>
-              </a:spcAft>
-            </a:pPr>
-            <a:r>
-              <a:rPr sz="1400" b="1">
-                <a:solidFill>
-                  <a:srgbClr val="F8FAFC"/>
-                </a:solidFill>
-                <a:latin typeface="Calibri"/>
-              </a:rPr>
-              <a:t>Drift Deficit: </a:t>
-            </a:r>
-            <a:r>
-              <a:rPr sz="1400" b="0">
-                <a:solidFill>
-                  <a:srgbClr val="F8FAFC"/>
-                </a:solidFill>
-                <a:latin typeface="Calibri"/>
-              </a:rPr>
-              <a:t> drift fails to defend against BackTree because vectors survive, leaving Top-1 at 27.6%.</a:t>
-            </a:r>
-          </a:p>
-          <a:p>
-            <a:pPr>
-              <a:spcAft>
-                <a:spcPts val="1000"/>
-              </a:spcAft>
-            </a:pPr>
-            <a:r>
-              <a:rPr sz="1400" b="1">
-                <a:solidFill>
-                  <a:srgbClr val="F8FAFC"/>
-                </a:solidFill>
-                <a:latin typeface="Calibri"/>
-              </a:rPr>
-              <a:t>IID Deficit: </a:t>
-            </a:r>
-            <a:r>
-              <a:rPr sz="1400" b="0">
-                <a:solidFill>
-                  <a:srgbClr val="F8FAFC"/>
-                </a:solidFill>
-                <a:latin typeface="Calibri"/>
-              </a:rPr>
-              <a:t>IID Noise averages out, leaving a significant Top-10 leak of 62.9%.</a:t>
-            </a:r>
-          </a:p>
-        </p:txBody>
-      </p:sp>
-    </p:spTree>
-  </p:cSld>
-  <p:clrMapOvr>
-    <a:masterClrMapping/>
-  </p:clrMapOvr>
-</p:sld>
-</file>
-
-<file path=ppt/slides/slide9.xml><?xml version="1.0" encoding="utf-8"?>
-<p:sld xmlns:a="http://schemas.openxmlformats.org/drawingml/2006/main" xmlns:p="http://schemas.openxmlformats.org/presentationml/2006/main" xmlns:r="http://schemas.openxmlformats.org/officeDocument/2006/relationships">
-  <p:cSld>
-    <p:bg>
-      <p:bgPr>
-        <a:solidFill>
-          <a:srgbClr val="0F172A"/>
-        </a:solidFill>
-        <a:effectLst/>
-      </p:bgPr>
-    </p:bg>
-    <p:spTree>
-      <p:nvGrpSpPr>
-        <p:cNvPr id="1" name=""/>
-        <p:cNvGrpSpPr/>
-        <p:nvPr/>
-      </p:nvGrpSpPr>
-      <p:grpSpPr/>
-      <p:sp>
-        <p:nvSpPr>
-          <p:cNvPr id="2" name="TextBox 1"/>
-          <p:cNvSpPr txBox="1"/>
-          <p:nvPr/>
-        </p:nvSpPr>
-        <p:spPr>
-          <a:xfrm>
-            <a:off x="548640" y="365760"/>
-            <a:ext cx="8046720" cy="731520"/>
-          </a:xfrm>
-          <a:prstGeom prst="rect">
-            <a:avLst/>
-          </a:prstGeom>
-          <a:noFill/>
-        </p:spPr>
-        <p:txBody>
-          <a:bodyPr wrap="square" tIns="91440" bIns="91440">
-            <a:spAutoFit/>
-          </a:bodyPr>
-          <a:lstStyle/>
-          <a:p>
-            <a:pPr>
-              <a:defRPr sz="2800" b="1">
-                <a:solidFill>
-                  <a:srgbClr val="38BDF8"/>
-                </a:solidFill>
-                <a:latin typeface="Calibri"/>
-              </a:defRPr>
-            </a:pPr>
-            <a:r>
-              <a:t>Empirical Validation Plots</a:t>
-            </a:r>
-          </a:p>
-        </p:txBody>
-      </p:sp>
-      <p:sp>
-        <p:nvSpPr>
-          <p:cNvPr id="3" name="TextBox 2"/>
-          <p:cNvSpPr txBox="1"/>
-          <p:nvPr/>
-        </p:nvSpPr>
-        <p:spPr>
-          <a:xfrm>
-            <a:off x="548640" y="1188720"/>
-            <a:ext cx="4114800" cy="3566160"/>
-          </a:xfrm>
-          <a:prstGeom prst="rect">
-            <a:avLst/>
-          </a:prstGeom>
-          <a:noFill/>
-        </p:spPr>
-        <p:txBody>
-          <a:bodyPr wrap="square" tIns="91440" bIns="91440">
-            <a:spAutoFit/>
-          </a:bodyPr>
-          <a:lstStyle/>
-          <a:p>
-            <a:pPr>
-              <a:spcAft>
-                <a:spcPts val="1000"/>
-              </a:spcAft>
-            </a:pPr>
-            <a:r>
-              <a:rPr sz="1600" b="1">
-                <a:solidFill>
-                  <a:srgbClr val="F8FAFC"/>
-                </a:solidFill>
-                <a:latin typeface="Calibri"/>
-              </a:rPr>
-              <a:t>Telemetry Plots: </a:t>
-            </a:r>
-            <a:r>
-              <a:rPr sz="1600" b="0">
-                <a:solidFill>
-                  <a:srgbClr val="F8FAFC"/>
-                </a:solidFill>
-                <a:latin typeface="Calibri"/>
-              </a:rPr>
-              <a:t>Includes a character-level simulation dashboard and word-level evaluation plots.</a:t>
-            </a:r>
-          </a:p>
-          <a:p>
-            <a:pPr>
-              <a:spcAft>
-                <a:spcPts val="1000"/>
-              </a:spcAft>
-            </a:pPr>
-            <a:r>
-              <a:rPr sz="1600" b="1">
-                <a:solidFill>
-                  <a:srgbClr val="F8FAFC"/>
-                </a:solidFill>
-                <a:latin typeface="Calibri"/>
-              </a:rPr>
-              <a:t>Visual Scatter: </a:t>
-            </a:r>
-            <a:r>
-              <a:rPr sz="1600" b="0">
-                <a:solidFill>
-                  <a:srgbClr val="F8FAFC"/>
-                </a:solidFill>
-                <a:latin typeface="Calibri"/>
-              </a:rPr>
-              <a:t>Left Panel (simulation_result.png) demonstrates visual scatter. Dwell clusters are completely dispersed.</a:t>
-            </a:r>
-          </a:p>
-          <a:p>
-            <a:pPr>
-              <a:spcAft>
-                <a:spcPts val="1000"/>
-              </a:spcAft>
-            </a:pPr>
-            <a:r>
-              <a:rPr sz="1600" b="1">
-                <a:solidFill>
-                  <a:srgbClr val="F8FAFC"/>
-                </a:solidFill>
-                <a:latin typeface="Calibri"/>
-              </a:rPr>
-              <a:t>BackTree Results: </a:t>
-            </a:r>
-            <a:r>
-              <a:rPr sz="1600" b="0">
-                <a:solidFill>
-                  <a:srgbClr val="F8FAFC"/>
-                </a:solidFill>
-                <a:latin typeface="Calibri"/>
-              </a:rPr>
-              <a:t>Right Panel (backtree_result.png) maps word inference rates under various noise profiles, validating the collapse of BackTree.</a:t>
-            </a:r>
-          </a:p>
-        </p:txBody>
-      </p:sp>
-      <p:pic>
-        <p:nvPicPr>
-          <p:cNvPr id="4" name="Picture 3" descr="simulation_result.png"/>
-          <p:cNvPicPr>
-            <a:picLocks noChangeAspect="1"/>
-          </p:cNvPicPr>
-          <p:nvPr/>
-        </p:nvPicPr>
-        <p:blipFill>
-          <a:blip r:embed="rId2"/>
-          <a:stretch>
-            <a:fillRect/>
-          </a:stretch>
-        </p:blipFill>
-        <p:spPr>
-          <a:xfrm>
-            <a:off x="4846320" y="1188720"/>
-            <a:ext cx="3749039" cy="1737360"/>
-          </a:xfrm>
-          <a:prstGeom prst="rect">
-            <a:avLst/>
-          </a:prstGeom>
-        </p:spPr>
-      </p:pic>
-      <p:pic>
-        <p:nvPicPr>
-          <p:cNvPr id="5" name="Picture 4" descr="backtree_result.png"/>
-          <p:cNvPicPr>
-            <a:picLocks noChangeAspect="1"/>
-          </p:cNvPicPr>
-          <p:nvPr/>
-        </p:nvPicPr>
-        <p:blipFill>
-          <a:blip r:embed="rId3"/>
-          <a:stretch>
-            <a:fillRect/>
-          </a:stretch>
-        </p:blipFill>
-        <p:spPr>
-          <a:xfrm>
-            <a:off x="4846320" y="3017520"/>
-            <a:ext cx="3749039" cy="1737360"/>
-          </a:xfrm>
-          <a:prstGeom prst="rect">
-            <a:avLst/>
-          </a:prstGeom>
-        </p:spPr>
-      </p:pic>
+          <p:cNvPr id="2" name="Title 1"/>
+          <p:cNvSpPr>
+            <a:spLocks noGrp="1"/>
+          </p:cNvSpPr>
+          <p:nvPr>
+            <p:ph type="title"/>
+          </p:nvPr>
+        </p:nvSpPr>
+        <p:spPr/>
+        <p:txBody>
+          <a:bodyPr/>
+          <a:lstStyle/>
+          <a:p>
+            <a:r>
+              <a:t>Conclusion</a:t>
+            </a:r>
+          </a:p>
+        </p:txBody>
+      </p:sp>
+      <p:sp>
+        <p:nvSpPr>
+          <p:cNvPr id="3" name="Content Placeholder 2"/>
+          <p:cNvSpPr>
+            <a:spLocks noGrp="1"/>
+          </p:cNvSpPr>
+          <p:nvPr>
+            <p:ph idx="1"/>
+          </p:nvPr>
+        </p:nvSpPr>
+        <p:spPr/>
+        <p:txBody>
+          <a:bodyPr/>
+          <a:lstStyle/>
+          <a:p>
+            <a:r>
+              <a:t>Summary</a:t>
+            </a:r>
+          </a:p>
+          <a:p>
+            <a:pPr lvl="1"/>
+            <a:r>
+              <a:t>SNOOPFINGER exploits zero-permission sensors, posing a major risk.</a:t>
+            </a:r>
+          </a:p>
+          <a:p>
+            <a:pPr lvl="1"/>
+            <a:r>
+              <a:t>Our CASOM implementation successfully defends against the attack by dynamically degrading data utility for background apps.</a:t>
+            </a:r>
+          </a:p>
+          <a:p>
+            <a:pPr lvl="1"/>
+            <a:r>
+              <a:t>As proven in our simulation, the attacker infers the exact word when unprotected, but infers useless gibberish when CASOM is active.</a:t>
+            </a:r>
+          </a:p>
+          <a:p>
+            <a:pPr lvl="1"/>
+            <a:r>
+              <a:t>Project Repository: https://github.com/AzDevops143/CSIEEE</a:t>
+            </a:r>
+          </a:p>
+        </p:txBody>
+      </p:sp>
     </p:spTree>
   </p:cSld>
   <p:clrMapOvr>

</xml_diff>